<commit_message>
Update findings deck: add CASEVAC slide and decisions Q-G/Q-H
Folds the CASEVAC walk into the deck (new slide with X1/X2 and the two new
decisions), updates the coverage and next-steps slides, and adds Q-G/Q-H to the
decisions slide. Generator now auto-numbers footers. 13 slides, layout
re-audited (0 off-slide).

Co-Authored-By: Claude Opus 4.8 (1M context) <noreply@anthropic.com>
</commit_message>
<xml_diff>
--- a/Subgroups/ASX/InstantiationReview/ASX-Instantiation-Findings.pptx
+++ b/Subgroups/ASX/InstantiationReview/ASX-Instantiation-Findings.pptx
@@ -17,6 +17,7 @@
     <p:sldId id="265" r:id="rId16"/>
     <p:sldId id="266" r:id="rId17"/>
     <p:sldId id="267" r:id="rId18"/>
+    <p:sldId id="268" r:id="rId19"/>
   </p:sldIdLst>
   <p:sldSz cx="12191695" cy="6858000" type="screen4x3"/>
   <p:notesSz cx="6858000" cy="9144000"/>
@@ -3409,11 +3410,11 @@
                 <a:spcPts val="200"/>
               </a:spcBef>
               <a:spcAft>
-                <a:spcPts val="800"/>
+                <a:spcPts val="1200"/>
               </a:spcAft>
             </a:pPr>
             <a:r>
-              <a:rPr sz="1550" b="1" i="0">
+              <a:rPr sz="1650" b="1" i="0">
                 <a:solidFill>
                   <a:srgbClr val="333333"/>
                 </a:solidFill>
@@ -3428,74 +3429,17 @@
                 <a:spcPts val="200"/>
               </a:spcBef>
               <a:spcAft>
-                <a:spcPts val="800"/>
+                <a:spcPts val="1200"/>
               </a:spcAft>
             </a:pPr>
             <a:r>
-              <a:rPr sz="1550" b="0" i="0">
+              <a:rPr sz="1650" b="1" i="0">
                 <a:solidFill>
                   <a:srgbClr val="333333"/>
                 </a:solidFill>
                 <a:latin typeface="Calibri"/>
               </a:rPr>
-              <a:t>CASEVAC needs message patterns none of the current examples cover:</a:t>
-            </a:r>
-          </a:p>
-          <a:p>
-            <a:pPr lvl="1">
-              <a:spcBef>
-                <a:spcPts val="200"/>
-              </a:spcBef>
-              <a:spcAft>
-                <a:spcPts val="800"/>
-              </a:spcAft>
-            </a:pPr>
-            <a:r>
-              <a:rPr sz="1550" b="0" i="0">
-                <a:solidFill>
-                  <a:srgbClr val="333333"/>
-                </a:solidFill>
-                <a:latin typeface="Calibri"/>
-              </a:rPr>
-              <a:t>      -  machine-to-machine route hand-off (scout -&gt; transport)</a:t>
-            </a:r>
-          </a:p>
-          <a:p>
-            <a:pPr lvl="1">
-              <a:spcBef>
-                <a:spcPts val="200"/>
-              </a:spcBef>
-              <a:spcAft>
-                <a:spcPts val="800"/>
-              </a:spcAft>
-            </a:pPr>
-            <a:r>
-              <a:rPr sz="1550" b="0" i="0">
-                <a:solidFill>
-                  <a:srgbClr val="333333"/>
-                </a:solidFill>
-                <a:latin typeface="Calibri"/>
-              </a:rPr>
-              <a:t>      -  'explainable reasons' report (why the route changed / mission could not complete)</a:t>
-            </a:r>
-          </a:p>
-          <a:p>
-            <a:pPr lvl="1">
-              <a:spcBef>
-                <a:spcPts val="200"/>
-              </a:spcBef>
-              <a:spcAft>
-                <a:spcPts val="800"/>
-              </a:spcAft>
-            </a:pPr>
-            <a:r>
-              <a:rPr sz="1550" b="0" i="0">
-                <a:solidFill>
-                  <a:srgbClr val="333333"/>
-                </a:solidFill>
-                <a:latin typeface="Calibri"/>
-              </a:rPr>
-              <a:t>      -  on-the-loop status and position updates</a:t>
+              <a:t>CASEVAC: walked end-to-end in this review - surfaces two gaps with no element (next slide).</a:t>
             </a:r>
           </a:p>
           <a:p>
@@ -3504,11 +3448,11 @@
                 <a:spcPts val="200"/>
               </a:spcBef>
               <a:spcAft>
-                <a:spcPts val="800"/>
+                <a:spcPts val="1200"/>
               </a:spcAft>
             </a:pPr>
             <a:r>
-              <a:rPr sz="1550" b="0" i="0">
+              <a:rPr sz="1650" b="0" i="0">
                 <a:solidFill>
                   <a:srgbClr val="333333"/>
                 </a:solidFill>
@@ -3523,11 +3467,11 @@
                 <a:spcPts val="200"/>
               </a:spcBef>
               <a:spcAft>
-                <a:spcPts val="800"/>
+                <a:spcPts val="1200"/>
               </a:spcAft>
             </a:pPr>
             <a:r>
-              <a:rPr sz="1550" b="0" i="0">
+              <a:rPr sz="1650" b="0" i="0">
                 <a:solidFill>
                   <a:srgbClr val="333333"/>
                 </a:solidFill>
@@ -3697,7 +3641,7 @@
                 </a:solidFill>
                 <a:latin typeface="Calibri"/>
               </a:rPr>
-              <a:t>Decisions for the sub-group</a:t>
+              <a:t>CASEVAC walk: two gaps with no element</a:t>
             </a:r>
           </a:p>
         </p:txBody>
@@ -3710,8 +3654,42 @@
         </p:nvSpPr>
         <p:spPr>
           <a:xfrm>
-            <a:off x="640080" y="1645920"/>
-            <a:ext cx="10972800" cy="4709160"/>
+            <a:off x="548640" y="914400"/>
+            <a:ext cx="10972800" cy="320040"/>
+          </a:xfrm>
+          <a:prstGeom prst="rect">
+            <a:avLst/>
+          </a:prstGeom>
+          <a:noFill/>
+        </p:spPr>
+        <p:txBody>
+          <a:bodyPr wrap="square">
+            <a:spAutoFit/>
+          </a:bodyPr>
+          <a:lstStyle/>
+          <a:p>
+            <a:r>
+              <a:rPr sz="1300" b="0" i="1">
+                <a:solidFill>
+                  <a:srgbClr val="2E869A"/>
+                </a:solidFill>
+                <a:latin typeface="Calibri"/>
+              </a:rPr>
+              <a:t>The flagship contributed scenario</a:t>
+            </a:r>
+          </a:p>
+        </p:txBody>
+      </p:sp>
+      <p:sp>
+        <p:nvSpPr>
+          <p:cNvPr id="5" name="TextBox 4"/>
+          <p:cNvSpPr txBox="1"/>
+          <p:nvPr/>
+        </p:nvSpPr>
+        <p:spPr>
+          <a:xfrm>
+            <a:off x="640080" y="1417320"/>
+            <a:ext cx="10972800" cy="777240"/>
           </a:xfrm>
           <a:prstGeom prst="rect">
             <a:avLst/>
@@ -3729,54 +3707,174 @@
                 <a:spcPts val="200"/>
               </a:spcBef>
               <a:spcAft>
-                <a:spcPts val="1200"/>
+                <a:spcPts val="600"/>
               </a:spcAft>
             </a:pPr>
             <a:r>
-              <a:rPr sz="1600" b="1" i="0">
-                <a:solidFill>
-                  <a:srgbClr val="2E869A"/>
-                </a:solidFill>
-                <a:latin typeface="Calibri"/>
-              </a:rPr>
-              <a:t>Q-A  </a:t>
-            </a:r>
-            <a:r>
-              <a:rPr sz="1600" b="0" i="0">
+              <a:rPr sz="1400" b="0" i="0">
                 <a:solidFill>
                   <a:srgbClr val="333333"/>
                 </a:solidFill>
                 <a:latin typeface="Calibri"/>
               </a:rPr>
-              <a:t>UAV/robot typing: a role on the existing Platform tree, or a parallel Robot tree?</a:t>
-            </a:r>
-          </a:p>
+              <a:t>Walked end-to-end: Initialization -&gt; tasking Order -&gt; robot-to-robot route hand-off -&gt; status/threat Reports -&gt; explainable-reasons Report.</a:t>
+            </a:r>
+          </a:p>
+        </p:txBody>
+      </p:sp>
+      <p:sp>
+        <p:nvSpPr>
+          <p:cNvPr id="6" name="Rounded Rectangle 5"/>
+          <p:cNvSpPr/>
+          <p:nvPr/>
+        </p:nvSpPr>
+        <p:spPr>
+          <a:xfrm>
+            <a:off x="731520" y="2240280"/>
+            <a:ext cx="5257800" cy="1600200"/>
+          </a:xfrm>
+          <a:prstGeom prst="roundRect">
+            <a:avLst/>
+          </a:prstGeom>
+          <a:solidFill>
+            <a:srgbClr val="C0392B"/>
+          </a:solidFill>
+          <a:ln>
+            <a:noFill/>
+          </a:ln>
+        </p:spPr>
+        <p:style>
+          <a:lnRef idx="1">
+            <a:schemeClr val="accent1"/>
+          </a:lnRef>
+          <a:fillRef idx="3">
+            <a:schemeClr val="accent1"/>
+          </a:fillRef>
+          <a:effectRef idx="2">
+            <a:schemeClr val="accent1"/>
+          </a:effectRef>
+          <a:fontRef idx="minor">
+            <a:schemeClr val="lt1"/>
+          </a:fontRef>
+        </p:style>
+        <p:txBody>
+          <a:bodyPr rtlCol="0" anchor="ctr" wrap="square"/>
+          <a:lstStyle/>
+          <a:p>
+            <a:pPr algn="ctr"/>
+            <a:r>
+              <a:rPr sz="1300" b="1" i="0">
+                <a:solidFill>
+                  <a:srgbClr val="FFFFFF"/>
+                </a:solidFill>
+                <a:latin typeface="Calibri"/>
+              </a:rPr>
+              <a:t>X1  -  No robot-to-robot content
+Scout cannot hand a verified safe Route to the transport UGV (envelope addressing exists; a content type does not)</a:t>
+            </a:r>
+          </a:p>
+        </p:txBody>
+      </p:sp>
+      <p:sp>
+        <p:nvSpPr>
+          <p:cNvPr id="7" name="Rounded Rectangle 6"/>
+          <p:cNvSpPr/>
+          <p:nvPr/>
+        </p:nvSpPr>
+        <p:spPr>
+          <a:xfrm>
+            <a:off x="6217920" y="2240280"/>
+            <a:ext cx="5257800" cy="1600200"/>
+          </a:xfrm>
+          <a:prstGeom prst="roundRect">
+            <a:avLst/>
+          </a:prstGeom>
+          <a:solidFill>
+            <a:srgbClr val="C0392B"/>
+          </a:solidFill>
+          <a:ln>
+            <a:noFill/>
+          </a:ln>
+        </p:spPr>
+        <p:style>
+          <a:lnRef idx="1">
+            <a:schemeClr val="accent1"/>
+          </a:lnRef>
+          <a:fillRef idx="3">
+            <a:schemeClr val="accent1"/>
+          </a:fillRef>
+          <a:effectRef idx="2">
+            <a:schemeClr val="accent1"/>
+          </a:effectRef>
+          <a:fontRef idx="minor">
+            <a:schemeClr val="lt1"/>
+          </a:fontRef>
+        </p:style>
+        <p:txBody>
+          <a:bodyPr rtlCol="0" anchor="ctr" wrap="square"/>
+          <a:lstStyle/>
+          <a:p>
+            <a:pPr algn="ctr"/>
+            <a:r>
+              <a:rPr sz="1300" b="1" i="0">
+                <a:solidFill>
+                  <a:srgbClr val="FFFFFF"/>
+                </a:solidFill>
+                <a:latin typeface="Calibri"/>
+              </a:rPr>
+              <a:t>X2  -  No rationale report
+Systems can report WHAT (TaskStatus) but not WHY a route changed or a mission failed</a:t>
+            </a:r>
+          </a:p>
+        </p:txBody>
+      </p:sp>
+      <p:sp>
+        <p:nvSpPr>
+          <p:cNvPr id="8" name="TextBox 7"/>
+          <p:cNvSpPr txBox="1"/>
+          <p:nvPr/>
+        </p:nvSpPr>
+        <p:spPr>
+          <a:xfrm>
+            <a:off x="640080" y="4114800"/>
+            <a:ext cx="10972800" cy="2240280"/>
+          </a:xfrm>
+          <a:prstGeom prst="rect">
+            <a:avLst/>
+          </a:prstGeom>
+          <a:noFill/>
+        </p:spPr>
+        <p:txBody>
+          <a:bodyPr wrap="square">
+            <a:spAutoFit/>
+          </a:bodyPr>
+          <a:lstStyle/>
           <a:p>
             <a:pPr>
               <a:spcBef>
                 <a:spcPts val="200"/>
               </a:spcBef>
               <a:spcAft>
-                <a:spcPts val="1200"/>
+                <a:spcPts val="900"/>
               </a:spcAft>
             </a:pPr>
             <a:r>
-              <a:rPr sz="1600" b="1" i="0">
+              <a:rPr sz="1400" b="1" i="0">
                 <a:solidFill>
                   <a:srgbClr val="2E869A"/>
                 </a:solidFill>
                 <a:latin typeface="Calibri"/>
               </a:rPr>
-              <a:t>Q-B  </a:t>
-            </a:r>
-            <a:r>
-              <a:rPr sz="1600" b="0" i="0">
+              <a:t>Decision (Q-G):  </a:t>
+            </a:r>
+            <a:r>
+              <a:rPr sz="1400" b="0" i="0">
                 <a:solidFill>
                   <a:srgbClr val="333333"/>
                 </a:solidFill>
                 <a:latin typeface="Calibri"/>
               </a:rPr>
-              <a:t>Swarm: derive from CollectiveEntity (ActorEntity) so it can be tasked.</a:t>
+              <a:t>define a robot-to-robot coordination content type (safe-route advertisement) and the issuing-authority model.</a:t>
             </a:r>
           </a:p>
           <a:p>
@@ -3785,26 +3883,26 @@
                 <a:spcPts val="200"/>
               </a:spcBef>
               <a:spcAft>
-                <a:spcPts val="1200"/>
+                <a:spcPts val="900"/>
               </a:spcAft>
             </a:pPr>
             <a:r>
-              <a:rPr sz="1600" b="1" i="0">
+              <a:rPr sz="1400" b="1" i="0">
                 <a:solidFill>
                   <a:srgbClr val="2E869A"/>
                 </a:solidFill>
                 <a:latin typeface="Calibri"/>
               </a:rPr>
-              <a:t>Q-C  </a:t>
-            </a:r>
-            <a:r>
-              <a:rPr sz="1600" b="0" i="0">
+              <a:t>Decision (Q-H):  </a:t>
+            </a:r>
+            <a:r>
+              <a:rPr sz="1400" b="0" i="0">
                 <a:solidFill>
                   <a:srgbClr val="333333"/>
                 </a:solidFill>
                 <a:latin typeface="Calibri"/>
               </a:rPr>
-              <a:t>Sensor: entity, class, or attribute - choose one model and apply it everywhere.</a:t>
+              <a:t>add a rationale/explanation ReportContent so systems can report why, not just what.</a:t>
             </a:r>
           </a:p>
           <a:p>
@@ -3813,89 +3911,33 @@
                 <a:spcPts val="200"/>
               </a:spcBef>
               <a:spcAft>
-                <a:spcPts val="1200"/>
+                <a:spcPts val="900"/>
               </a:spcAft>
             </a:pPr>
             <a:r>
-              <a:rPr sz="1600" b="1" i="0">
-                <a:solidFill>
-                  <a:srgbClr val="2E869A"/>
-                </a:solidFill>
-                <a:latin typeface="Calibri"/>
-              </a:rPr>
-              <a:t>Q-D  </a:t>
-            </a:r>
-            <a:r>
-              <a:rPr sz="1600" b="0" i="0">
+              <a:rPr sz="1400" b="1" i="0">
+                <a:solidFill>
+                  <a:srgbClr val="2E7D32"/>
+                </a:solidFill>
+                <a:latin typeface="Calibri"/>
+              </a:rPr>
+              <a:t>Checked:  </a:t>
+            </a:r>
+            <a:r>
+              <a:rPr sz="1400" b="0" i="0">
                 <a:solidFill>
                   <a:srgbClr val="333333"/>
                 </a:solidFill>
                 <a:latin typeface="Calibri"/>
               </a:rPr>
-              <a:t>Autonomy: choose one normative vocabulary.</a:t>
-            </a:r>
-          </a:p>
-          <a:p>
-            <a:pPr>
-              <a:spcBef>
-                <a:spcPts val="200"/>
-              </a:spcBef>
-              <a:spcAft>
-                <a:spcPts val="1200"/>
-              </a:spcAft>
-            </a:pPr>
-            <a:r>
-              <a:rPr sz="1600" b="1" i="0">
-                <a:solidFill>
-                  <a:srgbClr val="2E869A"/>
-                </a:solidFill>
-                <a:latin typeface="Calibri"/>
-              </a:rPr>
-              <a:t>Q-E  </a:t>
-            </a:r>
-            <a:r>
-              <a:rPr sz="1600" b="0" i="0">
-                <a:solidFill>
-                  <a:srgbClr val="333333"/>
-                </a:solidFill>
-                <a:latin typeface="Calibri"/>
-              </a:rPr>
-              <a:t>Define inline entity definition for newly-observed entities in reports.</a:t>
-            </a:r>
-          </a:p>
-          <a:p>
-            <a:pPr>
-              <a:spcBef>
-                <a:spcPts val="200"/>
-              </a:spcBef>
-              <a:spcAft>
-                <a:spcPts val="1200"/>
-              </a:spcAft>
-            </a:pPr>
-            <a:r>
-              <a:rPr sz="1600" b="1" i="0">
-                <a:solidFill>
-                  <a:srgbClr val="2E869A"/>
-                </a:solidFill>
-                <a:latin typeface="Calibri"/>
-              </a:rPr>
-              <a:t>Q-F  </a:t>
-            </a:r>
-            <a:r>
-              <a:rPr sz="1600" b="0" i="0">
-                <a:solidFill>
-                  <a:srgbClr val="333333"/>
-                </a:solidFill>
-                <a:latin typeface="Calibri"/>
-              </a:rPr>
-              <a:t>MediaReference identity, and separate media-format from sensor-modality.</a:t>
-            </a:r>
-          </a:p>
-        </p:txBody>
-      </p:sp>
-      <p:sp>
-        <p:nvSpPr>
-          <p:cNvPr id="5" name="TextBox 4"/>
+              <a:t>Route, phased planning (PlanBody/PlanPhase), and position reporting already exist - not gaps.</a:t>
+            </a:r>
+          </a:p>
+        </p:txBody>
+      </p:sp>
+      <p:sp>
+        <p:nvSpPr>
+          <p:cNvPr id="9" name="TextBox 8"/>
           <p:cNvSpPr txBox="1"/>
           <p:nvPr/>
         </p:nvSpPr>
@@ -3929,7 +3971,7 @@
       </p:sp>
       <p:sp>
         <p:nvSpPr>
-          <p:cNvPr id="6" name="TextBox 5"/>
+          <p:cNvPr id="10" name="TextBox 9"/>
           <p:cNvSpPr txBox="1"/>
           <p:nvPr/>
         </p:nvSpPr>
@@ -4052,7 +4094,7 @@
                 </a:solidFill>
                 <a:latin typeface="Calibri"/>
               </a:rPr>
-              <a:t>Recommended next steps</a:t>
+              <a:t>Decisions for the sub-group</a:t>
             </a:r>
           </a:p>
         </p:txBody>
@@ -4065,8 +4107,8 @@
         </p:nvSpPr>
         <p:spPr>
           <a:xfrm>
-            <a:off x="640080" y="1645920"/>
-            <a:ext cx="10972800" cy="4709160"/>
+            <a:off x="640080" y="1554480"/>
+            <a:ext cx="10972800" cy="4754880"/>
           </a:xfrm>
           <a:prstGeom prst="rect">
             <a:avLst/>
@@ -4084,17 +4126,26 @@
                 <a:spcPts val="200"/>
               </a:spcBef>
               <a:spcAft>
-                <a:spcPts val="1300"/>
+                <a:spcPts val="900"/>
               </a:spcAft>
             </a:pPr>
             <a:r>
-              <a:rPr sz="1700" b="1" i="0">
+              <a:rPr sz="1400" b="1" i="0">
+                <a:solidFill>
+                  <a:srgbClr val="2E869A"/>
+                </a:solidFill>
+                <a:latin typeface="Calibri"/>
+              </a:rPr>
+              <a:t>Q-A  </a:t>
+            </a:r>
+            <a:r>
+              <a:rPr sz="1400" b="0" i="0">
                 <a:solidFill>
                   <a:srgbClr val="333333"/>
                 </a:solidFill>
                 <a:latin typeface="Calibri"/>
               </a:rPr>
-              <a:t>Settle the two entity-typing decisions (Q-A, Q-B) - this unblocks Initialization.</a:t>
+              <a:t>UAV/robot typing: a role on the existing Platform tree, or a parallel Robot tree?</a:t>
             </a:r>
           </a:p>
           <a:p>
@@ -4103,17 +4154,26 @@
                 <a:spcPts val="200"/>
               </a:spcBef>
               <a:spcAft>
-                <a:spcPts val="1300"/>
+                <a:spcPts val="900"/>
               </a:spcAft>
             </a:pPr>
             <a:r>
-              <a:rPr sz="1700" b="0" i="0">
+              <a:rPr sz="1400" b="1" i="0">
+                <a:solidFill>
+                  <a:srgbClr val="2E869A"/>
+                </a:solidFill>
+                <a:latin typeface="Calibri"/>
+              </a:rPr>
+              <a:t>Q-B  </a:t>
+            </a:r>
+            <a:r>
+              <a:rPr sz="1400" b="0" i="0">
                 <a:solidFill>
                   <a:srgbClr val="333333"/>
                 </a:solidFill>
                 <a:latin typeface="Calibri"/>
               </a:rPr>
-              <a:t>Complete the Initialization instantiations (drafts provided for the 3 named scenarios).</a:t>
+              <a:t>Swarm: derive from CollectiveEntity (ActorEntity) so it can be tasked.</a:t>
             </a:r>
           </a:p>
           <a:p>
@@ -4122,17 +4182,26 @@
                 <a:spcPts val="200"/>
               </a:spcBef>
               <a:spcAft>
-                <a:spcPts val="1300"/>
+                <a:spcPts val="900"/>
               </a:spcAft>
             </a:pPr>
             <a:r>
-              <a:rPr sz="1700" b="0" i="0">
+              <a:rPr sz="1400" b="1" i="0">
+                <a:solidFill>
+                  <a:srgbClr val="2E869A"/>
+                </a:solidFill>
+                <a:latin typeface="Calibri"/>
+              </a:rPr>
+              <a:t>Q-C  </a:t>
+            </a:r>
+            <a:r>
+              <a:rPr sz="1400" b="0" i="0">
                 <a:solidFill>
                   <a:srgbClr val="333333"/>
                 </a:solidFill>
                 <a:latin typeface="Calibri"/>
               </a:rPr>
-              <a:t>Walk CASEVAC end-to-end to exercise coordination and explainability.</a:t>
+              <a:t>Sensor: entity, class, or attribute - choose one model and apply it everywhere.</a:t>
             </a:r>
           </a:p>
           <a:p>
@@ -4141,17 +4210,26 @@
                 <a:spcPts val="200"/>
               </a:spcBef>
               <a:spcAft>
-                <a:spcPts val="1300"/>
+                <a:spcPts val="900"/>
               </a:spcAft>
             </a:pPr>
             <a:r>
-              <a:rPr sz="1700" b="0" i="0">
+              <a:rPr sz="1400" b="1" i="0">
+                <a:solidFill>
+                  <a:srgbClr val="2E869A"/>
+                </a:solidFill>
+                <a:latin typeface="Calibri"/>
+              </a:rPr>
+              <a:t>Q-D  </a:t>
+            </a:r>
+            <a:r>
+              <a:rPr sz="1400" b="0" i="0">
                 <a:solidFill>
                   <a:srgbClr val="333333"/>
                 </a:solidFill>
                 <a:latin typeface="Calibri"/>
               </a:rPr>
-              <a:t>Reconcile the OWL model with the June spreadsheet decisions; fix the typos.</a:t>
+              <a:t>Autonomy: choose one normative vocabulary.</a:t>
             </a:r>
           </a:p>
           <a:p>
@@ -4160,17 +4238,110 @@
                 <a:spcPts val="200"/>
               </a:spcBef>
               <a:spcAft>
-                <a:spcPts val="1300"/>
+                <a:spcPts val="900"/>
               </a:spcAft>
             </a:pPr>
             <a:r>
-              <a:rPr sz="1700" b="0" i="0">
+              <a:rPr sz="1400" b="1" i="0">
+                <a:solidFill>
+                  <a:srgbClr val="2E869A"/>
+                </a:solidFill>
+                <a:latin typeface="Calibri"/>
+              </a:rPr>
+              <a:t>Q-E  </a:t>
+            </a:r>
+            <a:r>
+              <a:rPr sz="1400" b="0" i="0">
                 <a:solidFill>
                   <a:srgbClr val="333333"/>
                 </a:solidFill>
                 <a:latin typeface="Calibri"/>
               </a:rPr>
-              <a:t>Optional: adopt the diff-able (.xml) workbooks so edits can be reviewed and merged in git.</a:t>
+              <a:t>Define inline entity definition for newly-observed entities in reports.</a:t>
+            </a:r>
+          </a:p>
+          <a:p>
+            <a:pPr>
+              <a:spcBef>
+                <a:spcPts val="200"/>
+              </a:spcBef>
+              <a:spcAft>
+                <a:spcPts val="900"/>
+              </a:spcAft>
+            </a:pPr>
+            <a:r>
+              <a:rPr sz="1400" b="1" i="0">
+                <a:solidFill>
+                  <a:srgbClr val="2E869A"/>
+                </a:solidFill>
+                <a:latin typeface="Calibri"/>
+              </a:rPr>
+              <a:t>Q-F  </a:t>
+            </a:r>
+            <a:r>
+              <a:rPr sz="1400" b="0" i="0">
+                <a:solidFill>
+                  <a:srgbClr val="333333"/>
+                </a:solidFill>
+                <a:latin typeface="Calibri"/>
+              </a:rPr>
+              <a:t>MediaReference identity, and separate media-format from sensor-modality.</a:t>
+            </a:r>
+          </a:p>
+          <a:p>
+            <a:pPr>
+              <a:spcBef>
+                <a:spcPts val="200"/>
+              </a:spcBef>
+              <a:spcAft>
+                <a:spcPts val="900"/>
+              </a:spcAft>
+            </a:pPr>
+            <a:r>
+              <a:rPr sz="1400" b="1" i="0">
+                <a:solidFill>
+                  <a:srgbClr val="2E869A"/>
+                </a:solidFill>
+                <a:latin typeface="Calibri"/>
+              </a:rPr>
+              <a:t>Q-G  </a:t>
+            </a:r>
+            <a:r>
+              <a:rPr sz="1400" b="0" i="0">
+                <a:solidFill>
+                  <a:srgbClr val="333333"/>
+                </a:solidFill>
+                <a:latin typeface="Calibri"/>
+              </a:rPr>
+              <a:t>Robot-to-robot coordination content type + issuing authority (from CASEVAC).</a:t>
+            </a:r>
+          </a:p>
+          <a:p>
+            <a:pPr>
+              <a:spcBef>
+                <a:spcPts val="200"/>
+              </a:spcBef>
+              <a:spcAft>
+                <a:spcPts val="900"/>
+              </a:spcAft>
+            </a:pPr>
+            <a:r>
+              <a:rPr sz="1400" b="1" i="0">
+                <a:solidFill>
+                  <a:srgbClr val="2E869A"/>
+                </a:solidFill>
+                <a:latin typeface="Calibri"/>
+              </a:rPr>
+              <a:t>Q-H  </a:t>
+            </a:r>
+            <a:r>
+              <a:rPr sz="1400" b="0" i="0">
+                <a:solidFill>
+                  <a:srgbClr val="333333"/>
+                </a:solidFill>
+                <a:latin typeface="Calibri"/>
+              </a:rPr>
+              <a:t>Rationale/explanation ReportContent - report why, not just what (from CASEVAC).</a:t>
             </a:r>
           </a:p>
         </p:txBody>
@@ -4240,6 +4411,288 @@
                 <a:latin typeface="Calibri"/>
               </a:rPr>
               <a:t>12</a:t>
+            </a:r>
+          </a:p>
+        </p:txBody>
+      </p:sp>
+    </p:spTree>
+  </p:cSld>
+  <p:clrMapOvr>
+    <a:masterClrMapping/>
+  </p:clrMapOvr>
+</p:sld>
+</file>
+
+<file path=ppt/slides/slide13.xml><?xml version="1.0" encoding="utf-8"?>
+<p:sld xmlns:a="http://schemas.openxmlformats.org/drawingml/2006/main" xmlns:p="http://schemas.openxmlformats.org/presentationml/2006/main" xmlns:r="http://schemas.openxmlformats.org/officeDocument/2006/relationships">
+  <p:cSld>
+    <p:spTree>
+      <p:nvGrpSpPr>
+        <p:cNvPr id="1" name=""/>
+        <p:cNvGrpSpPr/>
+        <p:nvPr/>
+      </p:nvGrpSpPr>
+      <p:grpSpPr/>
+      <p:sp>
+        <p:nvSpPr>
+          <p:cNvPr id="2" name="Rectangle 1"/>
+          <p:cNvSpPr/>
+          <p:nvPr/>
+        </p:nvSpPr>
+        <p:spPr>
+          <a:xfrm>
+            <a:off x="548640" y="1170432"/>
+            <a:ext cx="2011680" cy="38100"/>
+          </a:xfrm>
+          <a:prstGeom prst="rect">
+            <a:avLst/>
+          </a:prstGeom>
+          <a:solidFill>
+            <a:srgbClr val="2E869A"/>
+          </a:solidFill>
+          <a:ln>
+            <a:noFill/>
+          </a:ln>
+        </p:spPr>
+        <p:style>
+          <a:lnRef idx="1">
+            <a:schemeClr val="accent1"/>
+          </a:lnRef>
+          <a:fillRef idx="3">
+            <a:schemeClr val="accent1"/>
+          </a:fillRef>
+          <a:effectRef idx="2">
+            <a:schemeClr val="accent1"/>
+          </a:effectRef>
+          <a:fontRef idx="minor">
+            <a:schemeClr val="lt1"/>
+          </a:fontRef>
+        </p:style>
+        <p:txBody>
+          <a:bodyPr rtlCol="0" anchor="ctr"/>
+          <a:lstStyle/>
+          <a:p>
+            <a:pPr algn="ctr"/>
+          </a:p>
+        </p:txBody>
+      </p:sp>
+      <p:sp>
+        <p:nvSpPr>
+          <p:cNvPr id="3" name="TextBox 2"/>
+          <p:cNvSpPr txBox="1"/>
+          <p:nvPr/>
+        </p:nvSpPr>
+        <p:spPr>
+          <a:xfrm>
+            <a:off x="502920" y="411480"/>
+            <a:ext cx="11155680" cy="822960"/>
+          </a:xfrm>
+          <a:prstGeom prst="rect">
+            <a:avLst/>
+          </a:prstGeom>
+          <a:noFill/>
+        </p:spPr>
+        <p:txBody>
+          <a:bodyPr wrap="square">
+            <a:spAutoFit/>
+          </a:bodyPr>
+          <a:lstStyle/>
+          <a:p>
+            <a:r>
+              <a:rPr sz="3000" b="1" i="0">
+                <a:solidFill>
+                  <a:srgbClr val="1F3A5F"/>
+                </a:solidFill>
+                <a:latin typeface="Calibri"/>
+              </a:rPr>
+              <a:t>Recommended next steps</a:t>
+            </a:r>
+          </a:p>
+        </p:txBody>
+      </p:sp>
+      <p:sp>
+        <p:nvSpPr>
+          <p:cNvPr id="4" name="TextBox 3"/>
+          <p:cNvSpPr txBox="1"/>
+          <p:nvPr/>
+        </p:nvSpPr>
+        <p:spPr>
+          <a:xfrm>
+            <a:off x="640080" y="1645920"/>
+            <a:ext cx="10972800" cy="4709160"/>
+          </a:xfrm>
+          <a:prstGeom prst="rect">
+            <a:avLst/>
+          </a:prstGeom>
+          <a:noFill/>
+        </p:spPr>
+        <p:txBody>
+          <a:bodyPr wrap="square">
+            <a:spAutoFit/>
+          </a:bodyPr>
+          <a:lstStyle/>
+          <a:p>
+            <a:pPr>
+              <a:spcBef>
+                <a:spcPts val="200"/>
+              </a:spcBef>
+              <a:spcAft>
+                <a:spcPts val="1200"/>
+              </a:spcAft>
+            </a:pPr>
+            <a:r>
+              <a:rPr sz="1650" b="1" i="0">
+                <a:solidFill>
+                  <a:srgbClr val="333333"/>
+                </a:solidFill>
+                <a:latin typeface="Calibri"/>
+              </a:rPr>
+              <a:t>Settle the two entity-typing decisions (Q-A, Q-B) - this unblocks Initialization.</a:t>
+            </a:r>
+          </a:p>
+          <a:p>
+            <a:pPr>
+              <a:spcBef>
+                <a:spcPts val="200"/>
+              </a:spcBef>
+              <a:spcAft>
+                <a:spcPts val="1200"/>
+              </a:spcAft>
+            </a:pPr>
+            <a:r>
+              <a:rPr sz="1650" b="0" i="0">
+                <a:solidFill>
+                  <a:srgbClr val="333333"/>
+                </a:solidFill>
+                <a:latin typeface="Calibri"/>
+              </a:rPr>
+              <a:t>Complete the Initialization instantiations (drafts provided for the 3 named scenarios).</a:t>
+            </a:r>
+          </a:p>
+          <a:p>
+            <a:pPr>
+              <a:spcBef>
+                <a:spcPts val="200"/>
+              </a:spcBef>
+              <a:spcAft>
+                <a:spcPts val="1200"/>
+              </a:spcAft>
+            </a:pPr>
+            <a:r>
+              <a:rPr sz="1650" b="0" i="0">
+                <a:solidFill>
+                  <a:srgbClr val="333333"/>
+                </a:solidFill>
+                <a:latin typeface="Calibri"/>
+              </a:rPr>
+              <a:t>Add the two CASEVAC content types (Q-G robot-to-robot, Q-H rationale) - both are explicit scenario requirements.</a:t>
+            </a:r>
+          </a:p>
+          <a:p>
+            <a:pPr>
+              <a:spcBef>
+                <a:spcPts val="200"/>
+              </a:spcBef>
+              <a:spcAft>
+                <a:spcPts val="1200"/>
+              </a:spcAft>
+            </a:pPr>
+            <a:r>
+              <a:rPr sz="1650" b="0" i="0">
+                <a:solidFill>
+                  <a:srgbClr val="333333"/>
+                </a:solidFill>
+                <a:latin typeface="Calibri"/>
+              </a:rPr>
+              <a:t>Reconcile the OWL model with the June spreadsheet decisions; fix the typos.</a:t>
+            </a:r>
+          </a:p>
+          <a:p>
+            <a:pPr>
+              <a:spcBef>
+                <a:spcPts val="200"/>
+              </a:spcBef>
+              <a:spcAft>
+                <a:spcPts val="1200"/>
+              </a:spcAft>
+            </a:pPr>
+            <a:r>
+              <a:rPr sz="1650" b="0" i="0">
+                <a:solidFill>
+                  <a:srgbClr val="333333"/>
+                </a:solidFill>
+                <a:latin typeface="Calibri"/>
+              </a:rPr>
+              <a:t>Optional: adopt the diff-able (.xml) workbooks so edits can be reviewed and merged in git.</a:t>
+            </a:r>
+          </a:p>
+        </p:txBody>
+      </p:sp>
+      <p:sp>
+        <p:nvSpPr>
+          <p:cNvPr id="5" name="TextBox 4"/>
+          <p:cNvSpPr txBox="1"/>
+          <p:nvPr/>
+        </p:nvSpPr>
+        <p:spPr>
+          <a:xfrm>
+            <a:off x="502920" y="6419088"/>
+            <a:ext cx="11155680" cy="320040"/>
+          </a:xfrm>
+          <a:prstGeom prst="rect">
+            <a:avLst/>
+          </a:prstGeom>
+          <a:noFill/>
+        </p:spPr>
+        <p:txBody>
+          <a:bodyPr wrap="square">
+            <a:spAutoFit/>
+          </a:bodyPr>
+          <a:lstStyle/>
+          <a:p>
+            <a:r>
+              <a:rPr sz="900" b="0" i="0">
+                <a:solidFill>
+                  <a:srgbClr val="666666"/>
+                </a:solidFill>
+                <a:latin typeface="Calibri"/>
+              </a:rPr>
+              <a:t>C2SIM ASX Sub-group   |   Hyssos   |   July 2026</a:t>
+            </a:r>
+          </a:p>
+        </p:txBody>
+      </p:sp>
+      <p:sp>
+        <p:nvSpPr>
+          <p:cNvPr id="6" name="TextBox 5"/>
+          <p:cNvSpPr txBox="1"/>
+          <p:nvPr/>
+        </p:nvSpPr>
+        <p:spPr>
+          <a:xfrm>
+            <a:off x="11338560" y="6419088"/>
+            <a:ext cx="640080" cy="320040"/>
+          </a:xfrm>
+          <a:prstGeom prst="rect">
+            <a:avLst/>
+          </a:prstGeom>
+          <a:noFill/>
+        </p:spPr>
+        <p:txBody>
+          <a:bodyPr wrap="square">
+            <a:spAutoFit/>
+          </a:bodyPr>
+          <a:lstStyle/>
+          <a:p>
+            <a:pPr algn="r"/>
+            <a:r>
+              <a:rPr sz="900" b="0" i="0">
+                <a:solidFill>
+                  <a:srgbClr val="666666"/>
+                </a:solidFill>
+                <a:latin typeface="Calibri"/>
+              </a:rPr>
+              <a:t>13</a:t>
             </a:r>
           </a:p>
         </p:txBody>
@@ -4448,7 +4901,7 @@
                 </a:solidFill>
                 <a:latin typeface="Calibri"/>
               </a:rPr>
-              <a:t>This review focused on Initialization (which had zero worked examples) and cross-checked the OWL model against the spreadsheets.</a:t>
+              <a:t>This review focused on Initialization (which had zero worked examples) and the CASEVAC scenario, and cross-checked the OWL model against the spreadsheets.</a:t>
             </a:r>
           </a:p>
           <a:p>
@@ -4730,7 +5183,7 @@
                 </a:solidFill>
                 <a:latin typeface="Calibri"/>
               </a:rPr>
-              <a:t>CASEVAC - the one human-authored contributed scenario - has no messages of any type yet.</a:t>
+              <a:t>CASEVAC - the one human-authored contributed scenario - had no messages of any type (now walked in this review).</a:t>
             </a:r>
           </a:p>
           <a:p>

</xml_diff>

<commit_message>
Add non-video sensor report tabs; log Y1-Y5
Stress-tests the sensor model with CBRN / EW / GPR report instantiations
(3 tabs added to the Report .xml). The media-based Video Detection Report model
(SensorObservation + MediaReference + MediaTypeEnum) does not generalize:
non-imaging sensors emit readings, not media files.

Findings (NonVideoSensors-Walk.md, log section 6c):
  Y1 media-based report model does not generalize
  Y2 SensorType enum incomplete (no CBRN/radar/thermal/...)
  Y3 no detection/hazard Observation subtype
  Y4 EW sensing has no report content type (JAM is an action)
  Y5 no sensor-reading value+unit property
Adds decision Q-I; updates C4; deck regenerated (13 slides, 0 off-slide).
Grounding check confirmed the gaps are real.

Co-Authored-By: Claude Opus 4.8 (1M context) <noreply@anthropic.com>
</commit_message>
<xml_diff>
--- a/Subgroups/ASX/InstantiationReview/ASX-Instantiation-Findings.pptx
+++ b/Subgroups/ASX/InstantiationReview/ASX-Instantiation-Findings.pptx
@@ -3452,13 +3452,13 @@
               </a:spcAft>
             </a:pPr>
             <a:r>
-              <a:rPr sz="1650" b="0" i="0">
+              <a:rPr sz="1650" b="1" i="0">
                 <a:solidFill>
                   <a:srgbClr val="333333"/>
                 </a:solidFill>
                 <a:latin typeface="Calibri"/>
               </a:rPr>
-              <a:t>Non-video sensors (CBRN, EW/jammer, GPR, thermal): no reports; SensorType enum incomplete.</a:t>
+              <a:t>Non-video sensors (CBRN, EW, GPR): walked - the media-based report model does not generalize; non-imaging sensors have no measurement type (Y1/Y5).</a:t>
             </a:r>
           </a:p>
           <a:p>
@@ -4107,7 +4107,7 @@
         </p:nvSpPr>
         <p:spPr>
           <a:xfrm>
-            <a:off x="640080" y="1554480"/>
+            <a:off x="640080" y="1463040"/>
             <a:ext cx="10972800" cy="4754880"/>
           </a:xfrm>
           <a:prstGeom prst="rect">
@@ -4126,11 +4126,11 @@
                 <a:spcPts val="200"/>
               </a:spcBef>
               <a:spcAft>
-                <a:spcPts val="900"/>
+                <a:spcPts val="800"/>
               </a:spcAft>
             </a:pPr>
             <a:r>
-              <a:rPr sz="1400" b="1" i="0">
+              <a:rPr sz="1300" b="1" i="0">
                 <a:solidFill>
                   <a:srgbClr val="2E869A"/>
                 </a:solidFill>
@@ -4139,7 +4139,7 @@
               <a:t>Q-A  </a:t>
             </a:r>
             <a:r>
-              <a:rPr sz="1400" b="0" i="0">
+              <a:rPr sz="1300" b="0" i="0">
                 <a:solidFill>
                   <a:srgbClr val="333333"/>
                 </a:solidFill>
@@ -4154,11 +4154,11 @@
                 <a:spcPts val="200"/>
               </a:spcBef>
               <a:spcAft>
-                <a:spcPts val="900"/>
+                <a:spcPts val="800"/>
               </a:spcAft>
             </a:pPr>
             <a:r>
-              <a:rPr sz="1400" b="1" i="0">
+              <a:rPr sz="1300" b="1" i="0">
                 <a:solidFill>
                   <a:srgbClr val="2E869A"/>
                 </a:solidFill>
@@ -4167,7 +4167,7 @@
               <a:t>Q-B  </a:t>
             </a:r>
             <a:r>
-              <a:rPr sz="1400" b="0" i="0">
+              <a:rPr sz="1300" b="0" i="0">
                 <a:solidFill>
                   <a:srgbClr val="333333"/>
                 </a:solidFill>
@@ -4182,11 +4182,11 @@
                 <a:spcPts val="200"/>
               </a:spcBef>
               <a:spcAft>
-                <a:spcPts val="900"/>
+                <a:spcPts val="800"/>
               </a:spcAft>
             </a:pPr>
             <a:r>
-              <a:rPr sz="1400" b="1" i="0">
+              <a:rPr sz="1300" b="1" i="0">
                 <a:solidFill>
                   <a:srgbClr val="2E869A"/>
                 </a:solidFill>
@@ -4195,7 +4195,7 @@
               <a:t>Q-C  </a:t>
             </a:r>
             <a:r>
-              <a:rPr sz="1400" b="0" i="0">
+              <a:rPr sz="1300" b="0" i="0">
                 <a:solidFill>
                   <a:srgbClr val="333333"/>
                 </a:solidFill>
@@ -4210,11 +4210,11 @@
                 <a:spcPts val="200"/>
               </a:spcBef>
               <a:spcAft>
-                <a:spcPts val="900"/>
+                <a:spcPts val="800"/>
               </a:spcAft>
             </a:pPr>
             <a:r>
-              <a:rPr sz="1400" b="1" i="0">
+              <a:rPr sz="1300" b="1" i="0">
                 <a:solidFill>
                   <a:srgbClr val="2E869A"/>
                 </a:solidFill>
@@ -4223,7 +4223,7 @@
               <a:t>Q-D  </a:t>
             </a:r>
             <a:r>
-              <a:rPr sz="1400" b="0" i="0">
+              <a:rPr sz="1300" b="0" i="0">
                 <a:solidFill>
                   <a:srgbClr val="333333"/>
                 </a:solidFill>
@@ -4238,11 +4238,11 @@
                 <a:spcPts val="200"/>
               </a:spcBef>
               <a:spcAft>
-                <a:spcPts val="900"/>
+                <a:spcPts val="800"/>
               </a:spcAft>
             </a:pPr>
             <a:r>
-              <a:rPr sz="1400" b="1" i="0">
+              <a:rPr sz="1300" b="1" i="0">
                 <a:solidFill>
                   <a:srgbClr val="2E869A"/>
                 </a:solidFill>
@@ -4251,7 +4251,7 @@
               <a:t>Q-E  </a:t>
             </a:r>
             <a:r>
-              <a:rPr sz="1400" b="0" i="0">
+              <a:rPr sz="1300" b="0" i="0">
                 <a:solidFill>
                   <a:srgbClr val="333333"/>
                 </a:solidFill>
@@ -4266,11 +4266,11 @@
                 <a:spcPts val="200"/>
               </a:spcBef>
               <a:spcAft>
-                <a:spcPts val="900"/>
+                <a:spcPts val="800"/>
               </a:spcAft>
             </a:pPr>
             <a:r>
-              <a:rPr sz="1400" b="1" i="0">
+              <a:rPr sz="1300" b="1" i="0">
                 <a:solidFill>
                   <a:srgbClr val="2E869A"/>
                 </a:solidFill>
@@ -4279,7 +4279,7 @@
               <a:t>Q-F  </a:t>
             </a:r>
             <a:r>
-              <a:rPr sz="1400" b="0" i="0">
+              <a:rPr sz="1300" b="0" i="0">
                 <a:solidFill>
                   <a:srgbClr val="333333"/>
                 </a:solidFill>
@@ -4294,11 +4294,11 @@
                 <a:spcPts val="200"/>
               </a:spcBef>
               <a:spcAft>
-                <a:spcPts val="900"/>
+                <a:spcPts val="800"/>
               </a:spcAft>
             </a:pPr>
             <a:r>
-              <a:rPr sz="1400" b="1" i="0">
+              <a:rPr sz="1300" b="1" i="0">
                 <a:solidFill>
                   <a:srgbClr val="2E869A"/>
                 </a:solidFill>
@@ -4307,7 +4307,7 @@
               <a:t>Q-G  </a:t>
             </a:r>
             <a:r>
-              <a:rPr sz="1400" b="0" i="0">
+              <a:rPr sz="1300" b="0" i="0">
                 <a:solidFill>
                   <a:srgbClr val="333333"/>
                 </a:solidFill>
@@ -4322,11 +4322,11 @@
                 <a:spcPts val="200"/>
               </a:spcBef>
               <a:spcAft>
-                <a:spcPts val="900"/>
+                <a:spcPts val="800"/>
               </a:spcAft>
             </a:pPr>
             <a:r>
-              <a:rPr sz="1400" b="1" i="0">
+              <a:rPr sz="1300" b="1" i="0">
                 <a:solidFill>
                   <a:srgbClr val="2E869A"/>
                 </a:solidFill>
@@ -4335,13 +4335,41 @@
               <a:t>Q-H  </a:t>
             </a:r>
             <a:r>
-              <a:rPr sz="1400" b="0" i="0">
+              <a:rPr sz="1300" b="0" i="0">
                 <a:solidFill>
                   <a:srgbClr val="333333"/>
                 </a:solidFill>
                 <a:latin typeface="Calibri"/>
               </a:rPr>
               <a:t>Rationale/explanation ReportContent - report why, not just what (from CASEVAC).</a:t>
+            </a:r>
+          </a:p>
+          <a:p>
+            <a:pPr>
+              <a:spcBef>
+                <a:spcPts val="200"/>
+              </a:spcBef>
+              <a:spcAft>
+                <a:spcPts val="800"/>
+              </a:spcAft>
+            </a:pPr>
+            <a:r>
+              <a:rPr sz="1300" b="1" i="0">
+                <a:solidFill>
+                  <a:srgbClr val="2E869A"/>
+                </a:solidFill>
+                <a:latin typeface="Calibri"/>
+              </a:rPr>
+              <a:t>Q-I  </a:t>
+            </a:r>
+            <a:r>
+              <a:rPr sz="1300" b="0" i="0">
+                <a:solidFill>
+                  <a:srgbClr val="333333"/>
+                </a:solidFill>
+                <a:latin typeface="Calibri"/>
+              </a:rPr>
+              <a:t>Media-independent sensor-reading (value+unit+modality) + complete SensorType taxonomy (non-video walk).</a:t>
             </a:r>
           </a:p>
         </p:txBody>

</xml_diff>

<commit_message>
Walk swarm: fill Swarm Detection, add Swarm Coordination
Instantiates the swarm scenario - fills the empty Swarm Detection report stub
and adds a Swarm Coordination order tab. Both messages confirm P7 (a swarm
derives from PhysicalEntity, so it cannot be ordered or be a ReportingEntity;
fix: derive from CollectiveEntity).

Grounding narrowed P8: membership and command already exist in base C2SIM
(hasSubordinate / hasSuperior / hasCommandRelation), so the residual swarm needs
are small - network params, leader role, aggregation (Z1), member lifecycle (Z2).

Log: section 6d, decision Q-J, C5 INSTANTIATED, P8 NARROWED. Deck P7 slide
updated (13 slides, 0 off-slide).

Co-Authored-By: Claude Opus 4.8 (1M context) <noreply@anthropic.com>
</commit_message>
<xml_diff>
--- a/Subgroups/ASX/InstantiationReview/ASX-Instantiation-Findings.pptx
+++ b/Subgroups/ASX/InstantiationReview/ASX-Instantiation-Findings.pptx
@@ -7448,8 +7448,8 @@
         </p:nvSpPr>
         <p:spPr>
           <a:xfrm>
-            <a:off x="640080" y="4937760"/>
-            <a:ext cx="10972800" cy="1417319"/>
+            <a:off x="640080" y="4846320"/>
+            <a:ext cx="10972800" cy="1508760"/>
           </a:xfrm>
           <a:prstGeom prst="rect">
             <a:avLst/>
@@ -7467,17 +7467,36 @@
                 <a:spcPts val="200"/>
               </a:spcBef>
               <a:spcAft>
-                <a:spcPts val="800"/>
+                <a:spcPts val="600"/>
               </a:spcAft>
             </a:pPr>
             <a:r>
-              <a:rPr sz="1500" b="0" i="0">
+              <a:rPr sz="1350" b="0" i="0">
                 <a:solidFill>
                   <a:srgbClr val="333333"/>
                 </a:solidFill>
                 <a:latin typeface="Calibri"/>
               </a:rPr>
               <a:t>A swarm is exactly what orders are addressed to and what sends reports - it must be an ActorEntity.</a:t>
+            </a:r>
+          </a:p>
+          <a:p>
+            <a:pPr lvl="1">
+              <a:spcBef>
+                <a:spcPts val="200"/>
+              </a:spcBef>
+              <a:spcAft>
+                <a:spcPts val="600"/>
+              </a:spcAft>
+            </a:pPr>
+            <a:r>
+              <a:rPr sz="1350" b="0" i="0">
+                <a:solidFill>
+                  <a:srgbClr val="333333"/>
+                </a:solidFill>
+                <a:latin typeface="Calibri"/>
+              </a:rPr>
+              <a:t>      -  Once fixed, membership and command already exist in base C2SIM (hasSubordinate, hasCommandRelation); the residual swarm needs are small.</a:t>
             </a:r>
           </a:p>
           <a:p>
@@ -7486,11 +7505,11 @@
                 <a:spcPts val="200"/>
               </a:spcBef>
               <a:spcAft>
-                <a:spcPts val="800"/>
+                <a:spcPts val="600"/>
               </a:spcAft>
             </a:pPr>
             <a:r>
-              <a:rPr sz="1500" b="1" i="0">
+              <a:rPr sz="1350" b="1" i="0">
                 <a:solidFill>
                   <a:srgbClr val="2E869A"/>
                 </a:solidFill>
@@ -7499,7 +7518,7 @@
               <a:t>Decision (Q-B):  </a:t>
             </a:r>
             <a:r>
-              <a:rPr sz="1500" b="0" i="0">
+              <a:rPr sz="1350" b="0" i="0">
                 <a:solidFill>
                   <a:srgbClr val="333333"/>
                 </a:solidFill>

</xml_diff>

<commit_message>
Walk Fire Support: engagement order + BDA report (task/effect axis)
Opens the task/effect axis with an armed-engagement instantiation
(Fire Support Order + BDA Report tabs). Headline finding W1: no link between
autonomy level and engagement authority - the standard expresses what effect,
which ROE, and who authorized the order, but not whether an autonomous system
may take a lethal action without a human in/on the loop.

Grounding narrowed the finding (ROE and authorization already exist in LOX/
C2SIM, so they are not gaps). W2 weapon typing and W3 BDA report are ordinary
gaps. Log: section 6e (W1-W3), decision Q-K, coverage C6. Deck: added a Fire
Support slide and split decisions into two slides (15 slides, 0 off-slide).

Co-Authored-By: Claude Opus 4.8 (1M context) <noreply@anthropic.com>
</commit_message>
<xml_diff>
--- a/Subgroups/ASX/InstantiationReview/ASX-Instantiation-Findings.pptx
+++ b/Subgroups/ASX/InstantiationReview/ASX-Instantiation-Findings.pptx
@@ -18,6 +18,8 @@
     <p:sldId id="266" r:id="rId17"/>
     <p:sldId id="267" r:id="rId18"/>
     <p:sldId id="268" r:id="rId19"/>
+    <p:sldId id="269" r:id="rId20"/>
+    <p:sldId id="270" r:id="rId21"/>
   </p:sldIdLst>
   <p:sldSz cx="12191695" cy="6858000" type="screen4x3"/>
   <p:notesSz cx="6858000" cy="9144000"/>
@@ -3477,7 +3479,7 @@
                 </a:solidFill>
                 <a:latin typeface="Calibri"/>
               </a:rPr>
-              <a:t>8 of 10 MUTT scenarios have no instantiations.</a:t>
+              <a:t>Task/effect scenarios: Fire Support walked (autonomous engagement); logistics, engineering, rescue still open.</a:t>
             </a:r>
           </a:p>
         </p:txBody>
@@ -4094,7 +4096,7 @@
                 </a:solidFill>
                 <a:latin typeface="Calibri"/>
               </a:rPr>
-              <a:t>Decisions for the sub-group</a:t>
+              <a:t>Fire Support: autonomous engagement authority</a:t>
             </a:r>
           </a:p>
         </p:txBody>
@@ -4107,8 +4109,95 @@
         </p:nvSpPr>
         <p:spPr>
           <a:xfrm>
-            <a:off x="640080" y="1463040"/>
-            <a:ext cx="10972800" cy="4754880"/>
+            <a:off x="548640" y="914400"/>
+            <a:ext cx="10972800" cy="320040"/>
+          </a:xfrm>
+          <a:prstGeom prst="rect">
+            <a:avLst/>
+          </a:prstGeom>
+          <a:noFill/>
+        </p:spPr>
+        <p:txBody>
+          <a:bodyPr wrap="square">
+            <a:spAutoFit/>
+          </a:bodyPr>
+          <a:lstStyle/>
+          <a:p>
+            <a:r>
+              <a:rPr sz="1300" b="0" i="1">
+                <a:solidFill>
+                  <a:srgbClr val="2E869A"/>
+                </a:solidFill>
+                <a:latin typeface="Calibri"/>
+              </a:rPr>
+              <a:t>The task/effect axis</a:t>
+            </a:r>
+          </a:p>
+        </p:txBody>
+      </p:sp>
+      <p:sp>
+        <p:nvSpPr>
+          <p:cNvPr id="5" name="Rounded Rectangle 4"/>
+          <p:cNvSpPr/>
+          <p:nvPr/>
+        </p:nvSpPr>
+        <p:spPr>
+          <a:xfrm>
+            <a:off x="731520" y="1783080"/>
+            <a:ext cx="10744200" cy="1463040"/>
+          </a:xfrm>
+          <a:prstGeom prst="roundRect">
+            <a:avLst/>
+          </a:prstGeom>
+          <a:solidFill>
+            <a:srgbClr val="C0392B"/>
+          </a:solidFill>
+          <a:ln>
+            <a:noFill/>
+          </a:ln>
+        </p:spPr>
+        <p:style>
+          <a:lnRef idx="1">
+            <a:schemeClr val="accent1"/>
+          </a:lnRef>
+          <a:fillRef idx="3">
+            <a:schemeClr val="accent1"/>
+          </a:fillRef>
+          <a:effectRef idx="2">
+            <a:schemeClr val="accent1"/>
+          </a:effectRef>
+          <a:fontRef idx="minor">
+            <a:schemeClr val="lt1"/>
+          </a:fontRef>
+        </p:style>
+        <p:txBody>
+          <a:bodyPr rtlCol="0" anchor="ctr" wrap="square"/>
+          <a:lstStyle/>
+          <a:p>
+            <a:pPr algn="ctr"/>
+            <a:r>
+              <a:rPr sz="1500" b="1" i="0">
+                <a:solidFill>
+                  <a:srgbClr val="FFFFFF"/>
+                </a:solidFill>
+                <a:latin typeface="Calibri"/>
+              </a:rPr>
+              <a:t>W1  -  No link between autonomy level and permission to engage
+The standard can say WHAT effect, WHICH ROE, and WHO authorized the order - but not whether a FullAuto system may take a lethal action without a human in / on the loop.</a:t>
+            </a:r>
+          </a:p>
+        </p:txBody>
+      </p:sp>
+      <p:sp>
+        <p:nvSpPr>
+          <p:cNvPr id="6" name="TextBox 5"/>
+          <p:cNvSpPr txBox="1"/>
+          <p:nvPr/>
+        </p:nvSpPr>
+        <p:spPr>
+          <a:xfrm>
+            <a:off x="640080" y="3474720"/>
+            <a:ext cx="10972800" cy="2880360"/>
           </a:xfrm>
           <a:prstGeom prst="rect">
             <a:avLst/>
@@ -4126,26 +4215,26 @@
                 <a:spcPts val="200"/>
               </a:spcBef>
               <a:spcAft>
-                <a:spcPts val="800"/>
+                <a:spcPts val="1100"/>
               </a:spcAft>
             </a:pPr>
             <a:r>
-              <a:rPr sz="1300" b="1" i="0">
-                <a:solidFill>
-                  <a:srgbClr val="2E869A"/>
-                </a:solidFill>
-                <a:latin typeface="Calibri"/>
-              </a:rPr>
-              <a:t>Q-A  </a:t>
-            </a:r>
-            <a:r>
-              <a:rPr sz="1300" b="0" i="0">
+              <a:rPr sz="1450" b="1" i="0">
+                <a:solidFill>
+                  <a:srgbClr val="2E7D32"/>
+                </a:solidFill>
+                <a:latin typeface="Calibri"/>
+              </a:rPr>
+              <a:t>Checked - already exist (not gaps):  </a:t>
+            </a:r>
+            <a:r>
+              <a:rPr sz="1450" b="0" i="0">
                 <a:solidFill>
                   <a:srgbClr val="333333"/>
                 </a:solidFill>
                 <a:latin typeface="Calibri"/>
               </a:rPr>
-              <a:t>UAV/robot typing: a role on the existing Platform tree, or a parallel Robot tree?</a:t>
+              <a:t>rules of engagement (RuleOfEngagement, WeaponROECode - LOX), order authorization (AuthorizationHeader), desired effect (DesiredEffectCode), target (hasAffectedEntity).</a:t>
             </a:r>
           </a:p>
           <a:p>
@@ -4154,26 +4243,26 @@
                 <a:spcPts val="200"/>
               </a:spcBef>
               <a:spcAft>
-                <a:spcPts val="800"/>
+                <a:spcPts val="1100"/>
               </a:spcAft>
             </a:pPr>
             <a:r>
-              <a:rPr sz="1300" b="1" i="0">
-                <a:solidFill>
-                  <a:srgbClr val="2E869A"/>
-                </a:solidFill>
-                <a:latin typeface="Calibri"/>
-              </a:rPr>
-              <a:t>Q-B  </a:t>
-            </a:r>
-            <a:r>
-              <a:rPr sz="1300" b="0" i="0">
+              <a:rPr sz="1450" b="1" i="0">
+                <a:solidFill>
+                  <a:srgbClr val="C87F0A"/>
+                </a:solidFill>
+                <a:latin typeface="Calibri"/>
+              </a:rPr>
+              <a:t>Also gaps:  </a:t>
+            </a:r>
+            <a:r>
+              <a:rPr sz="1450" b="0" i="0">
                 <a:solidFill>
                   <a:srgbClr val="333333"/>
                 </a:solidFill>
                 <a:latin typeface="Calibri"/>
               </a:rPr>
-              <a:t>Swarm: derive from CollectiveEntity (ActorEntity) so it can be tasked.</a:t>
+              <a:t>W2 weapon/munition not typed; W3 no battle-damage / effect-achieved report (TaskStatus = the task ran, not the target destroyed).</a:t>
             </a:r>
           </a:p>
           <a:p>
@@ -4182,201 +4271,33 @@
                 <a:spcPts val="200"/>
               </a:spcBef>
               <a:spcAft>
-                <a:spcPts val="800"/>
+                <a:spcPts val="1100"/>
               </a:spcAft>
             </a:pPr>
             <a:r>
-              <a:rPr sz="1300" b="1" i="0">
+              <a:rPr sz="1450" b="1" i="0">
                 <a:solidFill>
                   <a:srgbClr val="2E869A"/>
                 </a:solidFill>
                 <a:latin typeface="Calibri"/>
               </a:rPr>
-              <a:t>Q-C  </a:t>
-            </a:r>
-            <a:r>
-              <a:rPr sz="1300" b="0" i="0">
+              <a:t>Decision (Q-K):  </a:t>
+            </a:r>
+            <a:r>
+              <a:rPr sz="1450" b="0" i="0">
                 <a:solidFill>
                   <a:srgbClr val="333333"/>
                 </a:solidFill>
                 <a:latin typeface="Calibri"/>
               </a:rPr>
-              <a:t>Sensor: entity, class, or attribute - choose one model and apply it everywhere.</a:t>
-            </a:r>
-          </a:p>
-          <a:p>
-            <a:pPr>
-              <a:spcBef>
-                <a:spcPts val="200"/>
-              </a:spcBef>
-              <a:spcAft>
-                <a:spcPts val="800"/>
-              </a:spcAft>
-            </a:pPr>
-            <a:r>
-              <a:rPr sz="1300" b="1" i="0">
-                <a:solidFill>
-                  <a:srgbClr val="2E869A"/>
-                </a:solidFill>
-                <a:latin typeface="Calibri"/>
-              </a:rPr>
-              <a:t>Q-D  </a:t>
-            </a:r>
-            <a:r>
-              <a:rPr sz="1300" b="0" i="0">
-                <a:solidFill>
-                  <a:srgbClr val="333333"/>
-                </a:solidFill>
-                <a:latin typeface="Calibri"/>
-              </a:rPr>
-              <a:t>Autonomy: choose one normative vocabulary.</a:t>
-            </a:r>
-          </a:p>
-          <a:p>
-            <a:pPr>
-              <a:spcBef>
-                <a:spcPts val="200"/>
-              </a:spcBef>
-              <a:spcAft>
-                <a:spcPts val="800"/>
-              </a:spcAft>
-            </a:pPr>
-            <a:r>
-              <a:rPr sz="1300" b="1" i="0">
-                <a:solidFill>
-                  <a:srgbClr val="2E869A"/>
-                </a:solidFill>
-                <a:latin typeface="Calibri"/>
-              </a:rPr>
-              <a:t>Q-E  </a:t>
-            </a:r>
-            <a:r>
-              <a:rPr sz="1300" b="0" i="0">
-                <a:solidFill>
-                  <a:srgbClr val="333333"/>
-                </a:solidFill>
-                <a:latin typeface="Calibri"/>
-              </a:rPr>
-              <a:t>Define inline entity definition for newly-observed entities in reports.</a:t>
-            </a:r>
-          </a:p>
-          <a:p>
-            <a:pPr>
-              <a:spcBef>
-                <a:spcPts val="200"/>
-              </a:spcBef>
-              <a:spcAft>
-                <a:spcPts val="800"/>
-              </a:spcAft>
-            </a:pPr>
-            <a:r>
-              <a:rPr sz="1300" b="1" i="0">
-                <a:solidFill>
-                  <a:srgbClr val="2E869A"/>
-                </a:solidFill>
-                <a:latin typeface="Calibri"/>
-              </a:rPr>
-              <a:t>Q-F  </a:t>
-            </a:r>
-            <a:r>
-              <a:rPr sz="1300" b="0" i="0">
-                <a:solidFill>
-                  <a:srgbClr val="333333"/>
-                </a:solidFill>
-                <a:latin typeface="Calibri"/>
-              </a:rPr>
-              <a:t>MediaReference identity, and separate media-format from sensor-modality.</a:t>
-            </a:r>
-          </a:p>
-          <a:p>
-            <a:pPr>
-              <a:spcBef>
-                <a:spcPts val="200"/>
-              </a:spcBef>
-              <a:spcAft>
-                <a:spcPts val="800"/>
-              </a:spcAft>
-            </a:pPr>
-            <a:r>
-              <a:rPr sz="1300" b="1" i="0">
-                <a:solidFill>
-                  <a:srgbClr val="2E869A"/>
-                </a:solidFill>
-                <a:latin typeface="Calibri"/>
-              </a:rPr>
-              <a:t>Q-G  </a:t>
-            </a:r>
-            <a:r>
-              <a:rPr sz="1300" b="0" i="0">
-                <a:solidFill>
-                  <a:srgbClr val="333333"/>
-                </a:solidFill>
-                <a:latin typeface="Calibri"/>
-              </a:rPr>
-              <a:t>Robot-to-robot coordination content type + issuing authority (from CASEVAC).</a:t>
-            </a:r>
-          </a:p>
-          <a:p>
-            <a:pPr>
-              <a:spcBef>
-                <a:spcPts val="200"/>
-              </a:spcBef>
-              <a:spcAft>
-                <a:spcPts val="800"/>
-              </a:spcAft>
-            </a:pPr>
-            <a:r>
-              <a:rPr sz="1300" b="1" i="0">
-                <a:solidFill>
-                  <a:srgbClr val="2E869A"/>
-                </a:solidFill>
-                <a:latin typeface="Calibri"/>
-              </a:rPr>
-              <a:t>Q-H  </a:t>
-            </a:r>
-            <a:r>
-              <a:rPr sz="1300" b="0" i="0">
-                <a:solidFill>
-                  <a:srgbClr val="333333"/>
-                </a:solidFill>
-                <a:latin typeface="Calibri"/>
-              </a:rPr>
-              <a:t>Rationale/explanation ReportContent - report why, not just what (from CASEVAC).</a:t>
-            </a:r>
-          </a:p>
-          <a:p>
-            <a:pPr>
-              <a:spcBef>
-                <a:spcPts val="200"/>
-              </a:spcBef>
-              <a:spcAft>
-                <a:spcPts val="800"/>
-              </a:spcAft>
-            </a:pPr>
-            <a:r>
-              <a:rPr sz="1300" b="1" i="0">
-                <a:solidFill>
-                  <a:srgbClr val="2E869A"/>
-                </a:solidFill>
-                <a:latin typeface="Calibri"/>
-              </a:rPr>
-              <a:t>Q-I  </a:t>
-            </a:r>
-            <a:r>
-              <a:rPr sz="1300" b="0" i="0">
-                <a:solidFill>
-                  <a:srgbClr val="333333"/>
-                </a:solidFill>
-                <a:latin typeface="Calibri"/>
-              </a:rPr>
-              <a:t>Media-independent sensor-reading (value+unit+modality) + complete SensorType taxonomy (non-video walk).</a:t>
-            </a:r>
-          </a:p>
-        </p:txBody>
-      </p:sp>
-      <p:sp>
-        <p:nvSpPr>
-          <p:cNvPr id="5" name="TextBox 4"/>
+              <a:t>model engagement authority as a function of autonomy level - may this system take this action unsupervised?</a:t>
+            </a:r>
+          </a:p>
+        </p:txBody>
+      </p:sp>
+      <p:sp>
+        <p:nvSpPr>
+          <p:cNvPr id="7" name="TextBox 6"/>
           <p:cNvSpPr txBox="1"/>
           <p:nvPr/>
         </p:nvSpPr>
@@ -4410,7 +4331,7 @@
       </p:sp>
       <p:sp>
         <p:nvSpPr>
-          <p:cNvPr id="6" name="TextBox 5"/>
+          <p:cNvPr id="8" name="TextBox 7"/>
           <p:cNvSpPr txBox="1"/>
           <p:nvPr/>
         </p:nvSpPr>
@@ -4533,6 +4454,688 @@
                 </a:solidFill>
                 <a:latin typeface="Calibri"/>
               </a:rPr>
+              <a:t>Decisions (1/2): model structure</a:t>
+            </a:r>
+          </a:p>
+        </p:txBody>
+      </p:sp>
+      <p:sp>
+        <p:nvSpPr>
+          <p:cNvPr id="4" name="TextBox 3"/>
+          <p:cNvSpPr txBox="1"/>
+          <p:nvPr/>
+        </p:nvSpPr>
+        <p:spPr>
+          <a:xfrm>
+            <a:off x="640080" y="1737360"/>
+            <a:ext cx="10972800" cy="4617720"/>
+          </a:xfrm>
+          <a:prstGeom prst="rect">
+            <a:avLst/>
+          </a:prstGeom>
+          <a:noFill/>
+        </p:spPr>
+        <p:txBody>
+          <a:bodyPr wrap="square">
+            <a:spAutoFit/>
+          </a:bodyPr>
+          <a:lstStyle/>
+          <a:p>
+            <a:pPr>
+              <a:spcBef>
+                <a:spcPts val="200"/>
+              </a:spcBef>
+              <a:spcAft>
+                <a:spcPts val="1800"/>
+              </a:spcAft>
+            </a:pPr>
+            <a:r>
+              <a:rPr sz="1800" b="1" i="0">
+                <a:solidFill>
+                  <a:srgbClr val="2E869A"/>
+                </a:solidFill>
+                <a:latin typeface="Calibri"/>
+              </a:rPr>
+              <a:t>Q-A  </a:t>
+            </a:r>
+            <a:r>
+              <a:rPr sz="1800" b="0" i="0">
+                <a:solidFill>
+                  <a:srgbClr val="333333"/>
+                </a:solidFill>
+                <a:latin typeface="Calibri"/>
+              </a:rPr>
+              <a:t>UAV/robot typing: a role on the existing Platform tree, or a parallel Robot tree?</a:t>
+            </a:r>
+          </a:p>
+          <a:p>
+            <a:pPr>
+              <a:spcBef>
+                <a:spcPts val="200"/>
+              </a:spcBef>
+              <a:spcAft>
+                <a:spcPts val="1800"/>
+              </a:spcAft>
+            </a:pPr>
+            <a:r>
+              <a:rPr sz="1800" b="1" i="0">
+                <a:solidFill>
+                  <a:srgbClr val="2E869A"/>
+                </a:solidFill>
+                <a:latin typeface="Calibri"/>
+              </a:rPr>
+              <a:t>Q-B  </a:t>
+            </a:r>
+            <a:r>
+              <a:rPr sz="1800" b="0" i="0">
+                <a:solidFill>
+                  <a:srgbClr val="333333"/>
+                </a:solidFill>
+                <a:latin typeface="Calibri"/>
+              </a:rPr>
+              <a:t>Swarm: derive from CollectiveEntity (ActorEntity) so it can be tasked.</a:t>
+            </a:r>
+          </a:p>
+          <a:p>
+            <a:pPr>
+              <a:spcBef>
+                <a:spcPts val="200"/>
+              </a:spcBef>
+              <a:spcAft>
+                <a:spcPts val="1800"/>
+              </a:spcAft>
+            </a:pPr>
+            <a:r>
+              <a:rPr sz="1800" b="1" i="0">
+                <a:solidFill>
+                  <a:srgbClr val="2E869A"/>
+                </a:solidFill>
+                <a:latin typeface="Calibri"/>
+              </a:rPr>
+              <a:t>Q-C  </a:t>
+            </a:r>
+            <a:r>
+              <a:rPr sz="1800" b="0" i="0">
+                <a:solidFill>
+                  <a:srgbClr val="333333"/>
+                </a:solidFill>
+                <a:latin typeface="Calibri"/>
+              </a:rPr>
+              <a:t>Sensor: entity, class, or attribute - choose one model and apply it everywhere.</a:t>
+            </a:r>
+          </a:p>
+          <a:p>
+            <a:pPr>
+              <a:spcBef>
+                <a:spcPts val="200"/>
+              </a:spcBef>
+              <a:spcAft>
+                <a:spcPts val="1800"/>
+              </a:spcAft>
+            </a:pPr>
+            <a:r>
+              <a:rPr sz="1800" b="1" i="0">
+                <a:solidFill>
+                  <a:srgbClr val="2E869A"/>
+                </a:solidFill>
+                <a:latin typeface="Calibri"/>
+              </a:rPr>
+              <a:t>Q-D  </a:t>
+            </a:r>
+            <a:r>
+              <a:rPr sz="1800" b="0" i="0">
+                <a:solidFill>
+                  <a:srgbClr val="333333"/>
+                </a:solidFill>
+                <a:latin typeface="Calibri"/>
+              </a:rPr>
+              <a:t>Autonomy: choose one normative vocabulary.</a:t>
+            </a:r>
+          </a:p>
+        </p:txBody>
+      </p:sp>
+      <p:sp>
+        <p:nvSpPr>
+          <p:cNvPr id="5" name="TextBox 4"/>
+          <p:cNvSpPr txBox="1"/>
+          <p:nvPr/>
+        </p:nvSpPr>
+        <p:spPr>
+          <a:xfrm>
+            <a:off x="502920" y="6419088"/>
+            <a:ext cx="11155680" cy="320040"/>
+          </a:xfrm>
+          <a:prstGeom prst="rect">
+            <a:avLst/>
+          </a:prstGeom>
+          <a:noFill/>
+        </p:spPr>
+        <p:txBody>
+          <a:bodyPr wrap="square">
+            <a:spAutoFit/>
+          </a:bodyPr>
+          <a:lstStyle/>
+          <a:p>
+            <a:r>
+              <a:rPr sz="900" b="0" i="0">
+                <a:solidFill>
+                  <a:srgbClr val="666666"/>
+                </a:solidFill>
+                <a:latin typeface="Calibri"/>
+              </a:rPr>
+              <a:t>C2SIM ASX Sub-group   |   Hyssos   |   July 2026</a:t>
+            </a:r>
+          </a:p>
+        </p:txBody>
+      </p:sp>
+      <p:sp>
+        <p:nvSpPr>
+          <p:cNvPr id="6" name="TextBox 5"/>
+          <p:cNvSpPr txBox="1"/>
+          <p:nvPr/>
+        </p:nvSpPr>
+        <p:spPr>
+          <a:xfrm>
+            <a:off x="11338560" y="6419088"/>
+            <a:ext cx="640080" cy="320040"/>
+          </a:xfrm>
+          <a:prstGeom prst="rect">
+            <a:avLst/>
+          </a:prstGeom>
+          <a:noFill/>
+        </p:spPr>
+        <p:txBody>
+          <a:bodyPr wrap="square">
+            <a:spAutoFit/>
+          </a:bodyPr>
+          <a:lstStyle/>
+          <a:p>
+            <a:pPr algn="r"/>
+            <a:r>
+              <a:rPr sz="900" b="0" i="0">
+                <a:solidFill>
+                  <a:srgbClr val="666666"/>
+                </a:solidFill>
+                <a:latin typeface="Calibri"/>
+              </a:rPr>
+              <a:t>13</a:t>
+            </a:r>
+          </a:p>
+        </p:txBody>
+      </p:sp>
+    </p:spTree>
+  </p:cSld>
+  <p:clrMapOvr>
+    <a:masterClrMapping/>
+  </p:clrMapOvr>
+</p:sld>
+</file>
+
+<file path=ppt/slides/slide14.xml><?xml version="1.0" encoding="utf-8"?>
+<p:sld xmlns:a="http://schemas.openxmlformats.org/drawingml/2006/main" xmlns:p="http://schemas.openxmlformats.org/presentationml/2006/main" xmlns:r="http://schemas.openxmlformats.org/officeDocument/2006/relationships">
+  <p:cSld>
+    <p:spTree>
+      <p:nvGrpSpPr>
+        <p:cNvPr id="1" name=""/>
+        <p:cNvGrpSpPr/>
+        <p:nvPr/>
+      </p:nvGrpSpPr>
+      <p:grpSpPr/>
+      <p:sp>
+        <p:nvSpPr>
+          <p:cNvPr id="2" name="Rectangle 1"/>
+          <p:cNvSpPr/>
+          <p:nvPr/>
+        </p:nvSpPr>
+        <p:spPr>
+          <a:xfrm>
+            <a:off x="548640" y="1170432"/>
+            <a:ext cx="2011680" cy="38100"/>
+          </a:xfrm>
+          <a:prstGeom prst="rect">
+            <a:avLst/>
+          </a:prstGeom>
+          <a:solidFill>
+            <a:srgbClr val="2E869A"/>
+          </a:solidFill>
+          <a:ln>
+            <a:noFill/>
+          </a:ln>
+        </p:spPr>
+        <p:style>
+          <a:lnRef idx="1">
+            <a:schemeClr val="accent1"/>
+          </a:lnRef>
+          <a:fillRef idx="3">
+            <a:schemeClr val="accent1"/>
+          </a:fillRef>
+          <a:effectRef idx="2">
+            <a:schemeClr val="accent1"/>
+          </a:effectRef>
+          <a:fontRef idx="minor">
+            <a:schemeClr val="lt1"/>
+          </a:fontRef>
+        </p:style>
+        <p:txBody>
+          <a:bodyPr rtlCol="0" anchor="ctr"/>
+          <a:lstStyle/>
+          <a:p>
+            <a:pPr algn="ctr"/>
+          </a:p>
+        </p:txBody>
+      </p:sp>
+      <p:sp>
+        <p:nvSpPr>
+          <p:cNvPr id="3" name="TextBox 2"/>
+          <p:cNvSpPr txBox="1"/>
+          <p:nvPr/>
+        </p:nvSpPr>
+        <p:spPr>
+          <a:xfrm>
+            <a:off x="502920" y="411480"/>
+            <a:ext cx="11155680" cy="822960"/>
+          </a:xfrm>
+          <a:prstGeom prst="rect">
+            <a:avLst/>
+          </a:prstGeom>
+          <a:noFill/>
+        </p:spPr>
+        <p:txBody>
+          <a:bodyPr wrap="square">
+            <a:spAutoFit/>
+          </a:bodyPr>
+          <a:lstStyle/>
+          <a:p>
+            <a:r>
+              <a:rPr sz="3000" b="1" i="0">
+                <a:solidFill>
+                  <a:srgbClr val="1F3A5F"/>
+                </a:solidFill>
+                <a:latin typeface="Calibri"/>
+              </a:rPr>
+              <a:t>Decisions (2/2): new content types needed</a:t>
+            </a:r>
+          </a:p>
+        </p:txBody>
+      </p:sp>
+      <p:sp>
+        <p:nvSpPr>
+          <p:cNvPr id="4" name="TextBox 3"/>
+          <p:cNvSpPr txBox="1"/>
+          <p:nvPr/>
+        </p:nvSpPr>
+        <p:spPr>
+          <a:xfrm>
+            <a:off x="640080" y="1554480"/>
+            <a:ext cx="10972800" cy="4754880"/>
+          </a:xfrm>
+          <a:prstGeom prst="rect">
+            <a:avLst/>
+          </a:prstGeom>
+          <a:noFill/>
+        </p:spPr>
+        <p:txBody>
+          <a:bodyPr wrap="square">
+            <a:spAutoFit/>
+          </a:bodyPr>
+          <a:lstStyle/>
+          <a:p>
+            <a:pPr>
+              <a:spcBef>
+                <a:spcPts val="200"/>
+              </a:spcBef>
+              <a:spcAft>
+                <a:spcPts val="1000"/>
+              </a:spcAft>
+            </a:pPr>
+            <a:r>
+              <a:rPr sz="1500" b="1" i="0">
+                <a:solidFill>
+                  <a:srgbClr val="2E869A"/>
+                </a:solidFill>
+                <a:latin typeface="Calibri"/>
+              </a:rPr>
+              <a:t>Q-E  </a:t>
+            </a:r>
+            <a:r>
+              <a:rPr sz="1500" b="0" i="0">
+                <a:solidFill>
+                  <a:srgbClr val="333333"/>
+                </a:solidFill>
+                <a:latin typeface="Calibri"/>
+              </a:rPr>
+              <a:t>Inline entity definition for newly-observed entities in reports.</a:t>
+            </a:r>
+          </a:p>
+          <a:p>
+            <a:pPr>
+              <a:spcBef>
+                <a:spcPts val="200"/>
+              </a:spcBef>
+              <a:spcAft>
+                <a:spcPts val="1000"/>
+              </a:spcAft>
+            </a:pPr>
+            <a:r>
+              <a:rPr sz="1500" b="1" i="0">
+                <a:solidFill>
+                  <a:srgbClr val="2E869A"/>
+                </a:solidFill>
+                <a:latin typeface="Calibri"/>
+              </a:rPr>
+              <a:t>Q-F  </a:t>
+            </a:r>
+            <a:r>
+              <a:rPr sz="1500" b="0" i="0">
+                <a:solidFill>
+                  <a:srgbClr val="333333"/>
+                </a:solidFill>
+                <a:latin typeface="Calibri"/>
+              </a:rPr>
+              <a:t>MediaReference identity; separate media-format from sensor-modality.</a:t>
+            </a:r>
+          </a:p>
+          <a:p>
+            <a:pPr>
+              <a:spcBef>
+                <a:spcPts val="200"/>
+              </a:spcBef>
+              <a:spcAft>
+                <a:spcPts val="1000"/>
+              </a:spcAft>
+            </a:pPr>
+            <a:r>
+              <a:rPr sz="1500" b="1" i="0">
+                <a:solidFill>
+                  <a:srgbClr val="2E869A"/>
+                </a:solidFill>
+                <a:latin typeface="Calibri"/>
+              </a:rPr>
+              <a:t>Q-G  </a:t>
+            </a:r>
+            <a:r>
+              <a:rPr sz="1500" b="0" i="0">
+                <a:solidFill>
+                  <a:srgbClr val="333333"/>
+                </a:solidFill>
+                <a:latin typeface="Calibri"/>
+              </a:rPr>
+              <a:t>Robot-to-robot coordination content type + issuing authority (CASEVAC).</a:t>
+            </a:r>
+          </a:p>
+          <a:p>
+            <a:pPr>
+              <a:spcBef>
+                <a:spcPts val="200"/>
+              </a:spcBef>
+              <a:spcAft>
+                <a:spcPts val="1000"/>
+              </a:spcAft>
+            </a:pPr>
+            <a:r>
+              <a:rPr sz="1500" b="1" i="0">
+                <a:solidFill>
+                  <a:srgbClr val="2E869A"/>
+                </a:solidFill>
+                <a:latin typeface="Calibri"/>
+              </a:rPr>
+              <a:t>Q-H  </a:t>
+            </a:r>
+            <a:r>
+              <a:rPr sz="1500" b="0" i="0">
+                <a:solidFill>
+                  <a:srgbClr val="333333"/>
+                </a:solidFill>
+                <a:latin typeface="Calibri"/>
+              </a:rPr>
+              <a:t>Rationale/explanation ReportContent - report why, not just what (CASEVAC).</a:t>
+            </a:r>
+          </a:p>
+          <a:p>
+            <a:pPr>
+              <a:spcBef>
+                <a:spcPts val="200"/>
+              </a:spcBef>
+              <a:spcAft>
+                <a:spcPts val="1000"/>
+              </a:spcAft>
+            </a:pPr>
+            <a:r>
+              <a:rPr sz="1500" b="1" i="0">
+                <a:solidFill>
+                  <a:srgbClr val="2E869A"/>
+                </a:solidFill>
+                <a:latin typeface="Calibri"/>
+              </a:rPr>
+              <a:t>Q-I  </a:t>
+            </a:r>
+            <a:r>
+              <a:rPr sz="1500" b="0" i="0">
+                <a:solidFill>
+                  <a:srgbClr val="333333"/>
+                </a:solidFill>
+                <a:latin typeface="Calibri"/>
+              </a:rPr>
+              <a:t>Media-independent sensor-reading (value+unit+modality) + full SensorType taxonomy.</a:t>
+            </a:r>
+          </a:p>
+          <a:p>
+            <a:pPr>
+              <a:spcBef>
+                <a:spcPts val="200"/>
+              </a:spcBef>
+              <a:spcAft>
+                <a:spcPts val="1000"/>
+              </a:spcAft>
+            </a:pPr>
+            <a:r>
+              <a:rPr sz="1500" b="1" i="0">
+                <a:solidFill>
+                  <a:srgbClr val="2E869A"/>
+                </a:solidFill>
+                <a:latin typeface="Calibri"/>
+              </a:rPr>
+              <a:t>Q-J  </a:t>
+            </a:r>
+            <a:r>
+              <a:rPr sz="1500" b="0" i="0">
+                <a:solidFill>
+                  <a:srgbClr val="333333"/>
+                </a:solidFill>
+                <a:latin typeface="Calibri"/>
+              </a:rPr>
+              <a:t>Swarm residuals: network params, leader role, aggregation, member lifecycle.</a:t>
+            </a:r>
+          </a:p>
+          <a:p>
+            <a:pPr>
+              <a:spcBef>
+                <a:spcPts val="200"/>
+              </a:spcBef>
+              <a:spcAft>
+                <a:spcPts val="1000"/>
+              </a:spcAft>
+            </a:pPr>
+            <a:r>
+              <a:rPr sz="1500" b="1" i="0">
+                <a:solidFill>
+                  <a:srgbClr val="2E869A"/>
+                </a:solidFill>
+                <a:latin typeface="Calibri"/>
+              </a:rPr>
+              <a:t>Q-K  </a:t>
+            </a:r>
+            <a:r>
+              <a:rPr sz="1500" b="0" i="0">
+                <a:solidFill>
+                  <a:srgbClr val="333333"/>
+                </a:solidFill>
+                <a:latin typeface="Calibri"/>
+              </a:rPr>
+              <a:t>Engagement authority as a function of autonomy level (Fire Support).</a:t>
+            </a:r>
+          </a:p>
+        </p:txBody>
+      </p:sp>
+      <p:sp>
+        <p:nvSpPr>
+          <p:cNvPr id="5" name="TextBox 4"/>
+          <p:cNvSpPr txBox="1"/>
+          <p:nvPr/>
+        </p:nvSpPr>
+        <p:spPr>
+          <a:xfrm>
+            <a:off x="502920" y="6419088"/>
+            <a:ext cx="11155680" cy="320040"/>
+          </a:xfrm>
+          <a:prstGeom prst="rect">
+            <a:avLst/>
+          </a:prstGeom>
+          <a:noFill/>
+        </p:spPr>
+        <p:txBody>
+          <a:bodyPr wrap="square">
+            <a:spAutoFit/>
+          </a:bodyPr>
+          <a:lstStyle/>
+          <a:p>
+            <a:r>
+              <a:rPr sz="900" b="0" i="0">
+                <a:solidFill>
+                  <a:srgbClr val="666666"/>
+                </a:solidFill>
+                <a:latin typeface="Calibri"/>
+              </a:rPr>
+              <a:t>C2SIM ASX Sub-group   |   Hyssos   |   July 2026</a:t>
+            </a:r>
+          </a:p>
+        </p:txBody>
+      </p:sp>
+      <p:sp>
+        <p:nvSpPr>
+          <p:cNvPr id="6" name="TextBox 5"/>
+          <p:cNvSpPr txBox="1"/>
+          <p:nvPr/>
+        </p:nvSpPr>
+        <p:spPr>
+          <a:xfrm>
+            <a:off x="11338560" y="6419088"/>
+            <a:ext cx="640080" cy="320040"/>
+          </a:xfrm>
+          <a:prstGeom prst="rect">
+            <a:avLst/>
+          </a:prstGeom>
+          <a:noFill/>
+        </p:spPr>
+        <p:txBody>
+          <a:bodyPr wrap="square">
+            <a:spAutoFit/>
+          </a:bodyPr>
+          <a:lstStyle/>
+          <a:p>
+            <a:pPr algn="r"/>
+            <a:r>
+              <a:rPr sz="900" b="0" i="0">
+                <a:solidFill>
+                  <a:srgbClr val="666666"/>
+                </a:solidFill>
+                <a:latin typeface="Calibri"/>
+              </a:rPr>
+              <a:t>14</a:t>
+            </a:r>
+          </a:p>
+        </p:txBody>
+      </p:sp>
+    </p:spTree>
+  </p:cSld>
+  <p:clrMapOvr>
+    <a:masterClrMapping/>
+  </p:clrMapOvr>
+</p:sld>
+</file>
+
+<file path=ppt/slides/slide15.xml><?xml version="1.0" encoding="utf-8"?>
+<p:sld xmlns:a="http://schemas.openxmlformats.org/drawingml/2006/main" xmlns:p="http://schemas.openxmlformats.org/presentationml/2006/main" xmlns:r="http://schemas.openxmlformats.org/officeDocument/2006/relationships">
+  <p:cSld>
+    <p:spTree>
+      <p:nvGrpSpPr>
+        <p:cNvPr id="1" name=""/>
+        <p:cNvGrpSpPr/>
+        <p:nvPr/>
+      </p:nvGrpSpPr>
+      <p:grpSpPr/>
+      <p:sp>
+        <p:nvSpPr>
+          <p:cNvPr id="2" name="Rectangle 1"/>
+          <p:cNvSpPr/>
+          <p:nvPr/>
+        </p:nvSpPr>
+        <p:spPr>
+          <a:xfrm>
+            <a:off x="548640" y="1170432"/>
+            <a:ext cx="2011680" cy="38100"/>
+          </a:xfrm>
+          <a:prstGeom prst="rect">
+            <a:avLst/>
+          </a:prstGeom>
+          <a:solidFill>
+            <a:srgbClr val="2E869A"/>
+          </a:solidFill>
+          <a:ln>
+            <a:noFill/>
+          </a:ln>
+        </p:spPr>
+        <p:style>
+          <a:lnRef idx="1">
+            <a:schemeClr val="accent1"/>
+          </a:lnRef>
+          <a:fillRef idx="3">
+            <a:schemeClr val="accent1"/>
+          </a:fillRef>
+          <a:effectRef idx="2">
+            <a:schemeClr val="accent1"/>
+          </a:effectRef>
+          <a:fontRef idx="minor">
+            <a:schemeClr val="lt1"/>
+          </a:fontRef>
+        </p:style>
+        <p:txBody>
+          <a:bodyPr rtlCol="0" anchor="ctr"/>
+          <a:lstStyle/>
+          <a:p>
+            <a:pPr algn="ctr"/>
+          </a:p>
+        </p:txBody>
+      </p:sp>
+      <p:sp>
+        <p:nvSpPr>
+          <p:cNvPr id="3" name="TextBox 2"/>
+          <p:cNvSpPr txBox="1"/>
+          <p:nvPr/>
+        </p:nvSpPr>
+        <p:spPr>
+          <a:xfrm>
+            <a:off x="502920" y="411480"/>
+            <a:ext cx="11155680" cy="822960"/>
+          </a:xfrm>
+          <a:prstGeom prst="rect">
+            <a:avLst/>
+          </a:prstGeom>
+          <a:noFill/>
+        </p:spPr>
+        <p:txBody>
+          <a:bodyPr wrap="square">
+            <a:spAutoFit/>
+          </a:bodyPr>
+          <a:lstStyle/>
+          <a:p>
+            <a:r>
+              <a:rPr sz="3000" b="1" i="0">
+                <a:solidFill>
+                  <a:srgbClr val="1F3A5F"/>
+                </a:solidFill>
+                <a:latin typeface="Calibri"/>
+              </a:rPr>
               <a:t>Recommended next steps</a:t>
             </a:r>
           </a:p>
@@ -4720,7 +5323,7 @@
                 </a:solidFill>
                 <a:latin typeface="Calibri"/>
               </a:rPr>
-              <a:t>13</a:t>
+              <a:t>15</a:t>
             </a:r>
           </a:p>
         </p:txBody>

</xml_diff>

<commit_message>
Walk Logistics + Engineering + USV Rescue (task/effect batch)
Batched three task/effect scenarios: added Logistics Delivery Order,
Engineering Task Order, USV Rescue Order, and Delivery Confirmation Report.

The axis distills to two recurring gaps: (a) task verbs (deliver, dig/clear/
emplace, recover/rescue) and (b) payload/effector/weapon typing (cargo L1,
manipulator E2, weapon W2 are one gap). Everything else already exists - effects,
targets, resources+quantities, ROE, authorization, and platform types
(SurfaceVessel confirms P1 in the maritime domain).

Log: section 6f (L/E/R), decision Q-L, C6 updated. Deck: added a task/effect
summary slide and Q-L (16 slides, 0 off-slide). Grounding narrowed the findings.

Co-Authored-By: Claude Opus 4.8 (1M context) <noreply@anthropic.com>
</commit_message>
<xml_diff>
--- a/Subgroups/ASX/InstantiationReview/ASX-Instantiation-Findings.pptx
+++ b/Subgroups/ASX/InstantiationReview/ASX-Instantiation-Findings.pptx
@@ -20,6 +20,7 @@
     <p:sldId id="268" r:id="rId19"/>
     <p:sldId id="269" r:id="rId20"/>
     <p:sldId id="270" r:id="rId21"/>
+    <p:sldId id="271" r:id="rId22"/>
   </p:sldIdLst>
   <p:sldSz cx="12191695" cy="6858000" type="screen4x3"/>
   <p:notesSz cx="6858000" cy="9144000"/>
@@ -3479,7 +3480,7 @@
                 </a:solidFill>
                 <a:latin typeface="Calibri"/>
               </a:rPr>
-              <a:t>Task/effect scenarios: Fire Support walked (autonomous engagement); logistics, engineering, rescue still open.</a:t>
+              <a:t>Task/effect scenarios: engagement, delivery, manipulation, rescue walked - the gap is consistent (task verbs + payload/effector typing).</a:t>
             </a:r>
           </a:p>
         </p:txBody>
@@ -4454,7 +4455,7 @@
                 </a:solidFill>
                 <a:latin typeface="Calibri"/>
               </a:rPr>
-              <a:t>Decisions (1/2): model structure</a:t>
+              <a:t>The task/effect axis distills to two gaps</a:t>
             </a:r>
           </a:p>
         </p:txBody>
@@ -4467,8 +4468,148 @@
         </p:nvSpPr>
         <p:spPr>
           <a:xfrm>
-            <a:off x="640080" y="1737360"/>
-            <a:ext cx="10972800" cy="4617720"/>
+            <a:off x="548640" y="914400"/>
+            <a:ext cx="10972800" cy="320040"/>
+          </a:xfrm>
+          <a:prstGeom prst="rect">
+            <a:avLst/>
+          </a:prstGeom>
+          <a:noFill/>
+        </p:spPr>
+        <p:txBody>
+          <a:bodyPr wrap="square">
+            <a:spAutoFit/>
+          </a:bodyPr>
+          <a:lstStyle/>
+          <a:p>
+            <a:r>
+              <a:rPr sz="1300" b="0" i="1">
+                <a:solidFill>
+                  <a:srgbClr val="2E869A"/>
+                </a:solidFill>
+                <a:latin typeface="Calibri"/>
+              </a:rPr>
+              <a:t>Across engagement, delivery, manipulation, rescue</a:t>
+            </a:r>
+          </a:p>
+        </p:txBody>
+      </p:sp>
+      <p:sp>
+        <p:nvSpPr>
+          <p:cNvPr id="5" name="Rounded Rectangle 4"/>
+          <p:cNvSpPr/>
+          <p:nvPr/>
+        </p:nvSpPr>
+        <p:spPr>
+          <a:xfrm>
+            <a:off x="731520" y="1828800"/>
+            <a:ext cx="5257800" cy="1600200"/>
+          </a:xfrm>
+          <a:prstGeom prst="roundRect">
+            <a:avLst/>
+          </a:prstGeom>
+          <a:solidFill>
+            <a:srgbClr val="1F3A5F"/>
+          </a:solidFill>
+          <a:ln>
+            <a:noFill/>
+          </a:ln>
+        </p:spPr>
+        <p:style>
+          <a:lnRef idx="1">
+            <a:schemeClr val="accent1"/>
+          </a:lnRef>
+          <a:fillRef idx="3">
+            <a:schemeClr val="accent1"/>
+          </a:fillRef>
+          <a:effectRef idx="2">
+            <a:schemeClr val="accent1"/>
+          </a:effectRef>
+          <a:fontRef idx="minor">
+            <a:schemeClr val="lt1"/>
+          </a:fontRef>
+        </p:style>
+        <p:txBody>
+          <a:bodyPr rtlCol="0" anchor="ctr" wrap="square"/>
+          <a:lstStyle/>
+          <a:p>
+            <a:pPr algn="ctr"/>
+            <a:r>
+              <a:rPr sz="1400" b="1" i="0">
+                <a:solidFill>
+                  <a:srgbClr val="FFFFFF"/>
+                </a:solidFill>
+                <a:latin typeface="Calibri"/>
+              </a:rPr>
+              <a:t>1.  Task verbs
+No vocabulary for what systems DO: deliver, dig / clear / emplace, recover / rescue (engage uncertain).</a:t>
+            </a:r>
+          </a:p>
+        </p:txBody>
+      </p:sp>
+      <p:sp>
+        <p:nvSpPr>
+          <p:cNvPr id="6" name="Rounded Rectangle 5"/>
+          <p:cNvSpPr/>
+          <p:nvPr/>
+        </p:nvSpPr>
+        <p:spPr>
+          <a:xfrm>
+            <a:off x="6217920" y="1828800"/>
+            <a:ext cx="5257800" cy="1600200"/>
+          </a:xfrm>
+          <a:prstGeom prst="roundRect">
+            <a:avLst/>
+          </a:prstGeom>
+          <a:solidFill>
+            <a:srgbClr val="1F3A5F"/>
+          </a:solidFill>
+          <a:ln>
+            <a:noFill/>
+          </a:ln>
+        </p:spPr>
+        <p:style>
+          <a:lnRef idx="1">
+            <a:schemeClr val="accent1"/>
+          </a:lnRef>
+          <a:fillRef idx="3">
+            <a:schemeClr val="accent1"/>
+          </a:fillRef>
+          <a:effectRef idx="2">
+            <a:schemeClr val="accent1"/>
+          </a:effectRef>
+          <a:fontRef idx="minor">
+            <a:schemeClr val="lt1"/>
+          </a:fontRef>
+        </p:style>
+        <p:txBody>
+          <a:bodyPr rtlCol="0" anchor="ctr" wrap="square"/>
+          <a:lstStyle/>
+          <a:p>
+            <a:pPr algn="ctr"/>
+            <a:r>
+              <a:rPr sz="1400" b="1" i="0">
+                <a:solidFill>
+                  <a:srgbClr val="FFFFFF"/>
+                </a:solidFill>
+                <a:latin typeface="Calibri"/>
+              </a:rPr>
+              <a:t>2.  Payload / effector / weapon typing
+Cargo (L1), manipulator (E2), weapon (W2) are one gap: no typed thing carried or wielded.</a:t>
+            </a:r>
+          </a:p>
+        </p:txBody>
+      </p:sp>
+      <p:sp>
+        <p:nvSpPr>
+          <p:cNvPr id="7" name="TextBox 6"/>
+          <p:cNvSpPr txBox="1"/>
+          <p:nvPr/>
+        </p:nvSpPr>
+        <p:spPr>
+          <a:xfrm>
+            <a:off x="640080" y="3703320"/>
+            <a:ext cx="10972800" cy="2651760"/>
           </a:xfrm>
           <a:prstGeom prst="rect">
             <a:avLst/>
@@ -4486,26 +4627,26 @@
                 <a:spcPts val="200"/>
               </a:spcBef>
               <a:spcAft>
-                <a:spcPts val="1800"/>
+                <a:spcPts val="1200"/>
               </a:spcAft>
             </a:pPr>
             <a:r>
-              <a:rPr sz="1800" b="1" i="0">
-                <a:solidFill>
-                  <a:srgbClr val="2E869A"/>
-                </a:solidFill>
-                <a:latin typeface="Calibri"/>
-              </a:rPr>
-              <a:t>Q-A  </a:t>
-            </a:r>
-            <a:r>
-              <a:rPr sz="1800" b="0" i="0">
+              <a:rPr sz="1500" b="1" i="0">
+                <a:solidFill>
+                  <a:srgbClr val="2E7D32"/>
+                </a:solidFill>
+                <a:latin typeface="Calibri"/>
+              </a:rPr>
+              <a:t>Already there (checked):  </a:t>
+            </a:r>
+            <a:r>
+              <a:rPr sz="1500" b="0" i="0">
                 <a:solidFill>
                   <a:srgbClr val="333333"/>
                 </a:solidFill>
                 <a:latin typeface="Calibri"/>
               </a:rPr>
-              <a:t>UAV/robot typing: a role on the existing Platform tree, or a parallel Robot tree?</a:t>
+              <a:t>effects (DesiredEffectCode), targets (hasAffectedEntity), resources + quantities, ROE, authorization, and platform types (Vehicle / Aircraft / SurfaceVessel).</a:t>
             </a:r>
           </a:p>
           <a:p>
@@ -4514,89 +4655,33 @@
                 <a:spcPts val="200"/>
               </a:spcBef>
               <a:spcAft>
-                <a:spcPts val="1800"/>
+                <a:spcPts val="1200"/>
               </a:spcAft>
             </a:pPr>
             <a:r>
-              <a:rPr sz="1800" b="1" i="0">
+              <a:rPr sz="1500" b="1" i="0">
                 <a:solidFill>
                   <a:srgbClr val="2E869A"/>
                 </a:solidFill>
                 <a:latin typeface="Calibri"/>
               </a:rPr>
-              <a:t>Q-B  </a:t>
-            </a:r>
-            <a:r>
-              <a:rPr sz="1800" b="0" i="0">
+              <a:t>Decision (Q-L):  </a:t>
+            </a:r>
+            <a:r>
+              <a:rPr sz="1500" b="0" i="0">
                 <a:solidFill>
                   <a:srgbClr val="333333"/>
                 </a:solidFill>
                 <a:latin typeface="Calibri"/>
               </a:rPr>
-              <a:t>Swarm: derive from CollectiveEntity (ActorEntity) so it can be tasked.</a:t>
-            </a:r>
-          </a:p>
-          <a:p>
-            <a:pPr>
-              <a:spcBef>
-                <a:spcPts val="200"/>
-              </a:spcBef>
-              <a:spcAft>
-                <a:spcPts val="1800"/>
-              </a:spcAft>
-            </a:pPr>
-            <a:r>
-              <a:rPr sz="1800" b="1" i="0">
-                <a:solidFill>
-                  <a:srgbClr val="2E869A"/>
-                </a:solidFill>
-                <a:latin typeface="Calibri"/>
-              </a:rPr>
-              <a:t>Q-C  </a:t>
-            </a:r>
-            <a:r>
-              <a:rPr sz="1800" b="0" i="0">
-                <a:solidFill>
-                  <a:srgbClr val="333333"/>
-                </a:solidFill>
-                <a:latin typeface="Calibri"/>
-              </a:rPr>
-              <a:t>Sensor: entity, class, or attribute - choose one model and apply it everywhere.</a:t>
-            </a:r>
-          </a:p>
-          <a:p>
-            <a:pPr>
-              <a:spcBef>
-                <a:spcPts val="200"/>
-              </a:spcBef>
-              <a:spcAft>
-                <a:spcPts val="1800"/>
-              </a:spcAft>
-            </a:pPr>
-            <a:r>
-              <a:rPr sz="1800" b="1" i="0">
-                <a:solidFill>
-                  <a:srgbClr val="2E869A"/>
-                </a:solidFill>
-                <a:latin typeface="Calibri"/>
-              </a:rPr>
-              <a:t>Q-D  </a:t>
-            </a:r>
-            <a:r>
-              <a:rPr sz="1800" b="0" i="0">
-                <a:solidFill>
-                  <a:srgbClr val="333333"/>
-                </a:solidFill>
-                <a:latin typeface="Calibri"/>
-              </a:rPr>
-              <a:t>Autonomy: choose one normative vocabulary.</a:t>
-            </a:r>
-          </a:p>
-        </p:txBody>
-      </p:sp>
-      <p:sp>
-        <p:nvSpPr>
-          <p:cNvPr id="5" name="TextBox 4"/>
+              <a:t>define the task-verb vocabulary and the typed payload / effector / weapon - that is the whole axis.</a:t>
+            </a:r>
+          </a:p>
+        </p:txBody>
+      </p:sp>
+      <p:sp>
+        <p:nvSpPr>
+          <p:cNvPr id="8" name="TextBox 7"/>
           <p:cNvSpPr txBox="1"/>
           <p:nvPr/>
         </p:nvSpPr>
@@ -4630,7 +4715,7 @@
       </p:sp>
       <p:sp>
         <p:nvSpPr>
-          <p:cNvPr id="6" name="TextBox 5"/>
+          <p:cNvPr id="9" name="TextBox 8"/>
           <p:cNvSpPr txBox="1"/>
           <p:nvPr/>
         </p:nvSpPr>
@@ -4753,7 +4838,7 @@
                 </a:solidFill>
                 <a:latin typeface="Calibri"/>
               </a:rPr>
-              <a:t>Decisions (2/2): new content types needed</a:t>
+              <a:t>Decisions (1/2): model structure</a:t>
             </a:r>
           </a:p>
         </p:txBody>
@@ -4766,8 +4851,8 @@
         </p:nvSpPr>
         <p:spPr>
           <a:xfrm>
-            <a:off x="640080" y="1554480"/>
-            <a:ext cx="10972800" cy="4754880"/>
+            <a:off x="640080" y="1737360"/>
+            <a:ext cx="10972800" cy="4617720"/>
           </a:xfrm>
           <a:prstGeom prst="rect">
             <a:avLst/>
@@ -4785,26 +4870,26 @@
                 <a:spcPts val="200"/>
               </a:spcBef>
               <a:spcAft>
-                <a:spcPts val="1000"/>
+                <a:spcPts val="1800"/>
               </a:spcAft>
             </a:pPr>
             <a:r>
-              <a:rPr sz="1500" b="1" i="0">
+              <a:rPr sz="1800" b="1" i="0">
                 <a:solidFill>
                   <a:srgbClr val="2E869A"/>
                 </a:solidFill>
                 <a:latin typeface="Calibri"/>
               </a:rPr>
-              <a:t>Q-E  </a:t>
-            </a:r>
-            <a:r>
-              <a:rPr sz="1500" b="0" i="0">
+              <a:t>Q-A  </a:t>
+            </a:r>
+            <a:r>
+              <a:rPr sz="1800" b="0" i="0">
                 <a:solidFill>
                   <a:srgbClr val="333333"/>
                 </a:solidFill>
                 <a:latin typeface="Calibri"/>
               </a:rPr>
-              <a:t>Inline entity definition for newly-observed entities in reports.</a:t>
+              <a:t>UAV/robot typing: a role on the existing Platform tree, or a parallel Robot tree?</a:t>
             </a:r>
           </a:p>
           <a:p>
@@ -4813,26 +4898,26 @@
                 <a:spcPts val="200"/>
               </a:spcBef>
               <a:spcAft>
-                <a:spcPts val="1000"/>
+                <a:spcPts val="1800"/>
               </a:spcAft>
             </a:pPr>
             <a:r>
-              <a:rPr sz="1500" b="1" i="0">
+              <a:rPr sz="1800" b="1" i="0">
                 <a:solidFill>
                   <a:srgbClr val="2E869A"/>
                 </a:solidFill>
                 <a:latin typeface="Calibri"/>
               </a:rPr>
-              <a:t>Q-F  </a:t>
-            </a:r>
-            <a:r>
-              <a:rPr sz="1500" b="0" i="0">
+              <a:t>Q-B  </a:t>
+            </a:r>
+            <a:r>
+              <a:rPr sz="1800" b="0" i="0">
                 <a:solidFill>
                   <a:srgbClr val="333333"/>
                 </a:solidFill>
                 <a:latin typeface="Calibri"/>
               </a:rPr>
-              <a:t>MediaReference identity; separate media-format from sensor-modality.</a:t>
+              <a:t>Swarm: derive from CollectiveEntity (ActorEntity) so it can be tasked.</a:t>
             </a:r>
           </a:p>
           <a:p>
@@ -4841,26 +4926,26 @@
                 <a:spcPts val="200"/>
               </a:spcBef>
               <a:spcAft>
-                <a:spcPts val="1000"/>
+                <a:spcPts val="1800"/>
               </a:spcAft>
             </a:pPr>
             <a:r>
-              <a:rPr sz="1500" b="1" i="0">
+              <a:rPr sz="1800" b="1" i="0">
                 <a:solidFill>
                   <a:srgbClr val="2E869A"/>
                 </a:solidFill>
                 <a:latin typeface="Calibri"/>
               </a:rPr>
-              <a:t>Q-G  </a:t>
-            </a:r>
-            <a:r>
-              <a:rPr sz="1500" b="0" i="0">
+              <a:t>Q-C  </a:t>
+            </a:r>
+            <a:r>
+              <a:rPr sz="1800" b="0" i="0">
                 <a:solidFill>
                   <a:srgbClr val="333333"/>
                 </a:solidFill>
                 <a:latin typeface="Calibri"/>
               </a:rPr>
-              <a:t>Robot-to-robot coordination content type + issuing authority (CASEVAC).</a:t>
+              <a:t>Sensor: entity, class, or attribute - choose one model and apply it everywhere.</a:t>
             </a:r>
           </a:p>
           <a:p>
@@ -4869,110 +4954,26 @@
                 <a:spcPts val="200"/>
               </a:spcBef>
               <a:spcAft>
-                <a:spcPts val="1000"/>
+                <a:spcPts val="1800"/>
               </a:spcAft>
             </a:pPr>
             <a:r>
-              <a:rPr sz="1500" b="1" i="0">
+              <a:rPr sz="1800" b="1" i="0">
                 <a:solidFill>
                   <a:srgbClr val="2E869A"/>
                 </a:solidFill>
                 <a:latin typeface="Calibri"/>
               </a:rPr>
-              <a:t>Q-H  </a:t>
-            </a:r>
-            <a:r>
-              <a:rPr sz="1500" b="0" i="0">
+              <a:t>Q-D  </a:t>
+            </a:r>
+            <a:r>
+              <a:rPr sz="1800" b="0" i="0">
                 <a:solidFill>
                   <a:srgbClr val="333333"/>
                 </a:solidFill>
                 <a:latin typeface="Calibri"/>
               </a:rPr>
-              <a:t>Rationale/explanation ReportContent - report why, not just what (CASEVAC).</a:t>
-            </a:r>
-          </a:p>
-          <a:p>
-            <a:pPr>
-              <a:spcBef>
-                <a:spcPts val="200"/>
-              </a:spcBef>
-              <a:spcAft>
-                <a:spcPts val="1000"/>
-              </a:spcAft>
-            </a:pPr>
-            <a:r>
-              <a:rPr sz="1500" b="1" i="0">
-                <a:solidFill>
-                  <a:srgbClr val="2E869A"/>
-                </a:solidFill>
-                <a:latin typeface="Calibri"/>
-              </a:rPr>
-              <a:t>Q-I  </a:t>
-            </a:r>
-            <a:r>
-              <a:rPr sz="1500" b="0" i="0">
-                <a:solidFill>
-                  <a:srgbClr val="333333"/>
-                </a:solidFill>
-                <a:latin typeface="Calibri"/>
-              </a:rPr>
-              <a:t>Media-independent sensor-reading (value+unit+modality) + full SensorType taxonomy.</a:t>
-            </a:r>
-          </a:p>
-          <a:p>
-            <a:pPr>
-              <a:spcBef>
-                <a:spcPts val="200"/>
-              </a:spcBef>
-              <a:spcAft>
-                <a:spcPts val="1000"/>
-              </a:spcAft>
-            </a:pPr>
-            <a:r>
-              <a:rPr sz="1500" b="1" i="0">
-                <a:solidFill>
-                  <a:srgbClr val="2E869A"/>
-                </a:solidFill>
-                <a:latin typeface="Calibri"/>
-              </a:rPr>
-              <a:t>Q-J  </a:t>
-            </a:r>
-            <a:r>
-              <a:rPr sz="1500" b="0" i="0">
-                <a:solidFill>
-                  <a:srgbClr val="333333"/>
-                </a:solidFill>
-                <a:latin typeface="Calibri"/>
-              </a:rPr>
-              <a:t>Swarm residuals: network params, leader role, aggregation, member lifecycle.</a:t>
-            </a:r>
-          </a:p>
-          <a:p>
-            <a:pPr>
-              <a:spcBef>
-                <a:spcPts val="200"/>
-              </a:spcBef>
-              <a:spcAft>
-                <a:spcPts val="1000"/>
-              </a:spcAft>
-            </a:pPr>
-            <a:r>
-              <a:rPr sz="1500" b="1" i="0">
-                <a:solidFill>
-                  <a:srgbClr val="2E869A"/>
-                </a:solidFill>
-                <a:latin typeface="Calibri"/>
-              </a:rPr>
-              <a:t>Q-K  </a:t>
-            </a:r>
-            <a:r>
-              <a:rPr sz="1500" b="0" i="0">
-                <a:solidFill>
-                  <a:srgbClr val="333333"/>
-                </a:solidFill>
-                <a:latin typeface="Calibri"/>
-              </a:rPr>
-              <a:t>Engagement authority as a function of autonomy level (Fire Support).</a:t>
+              <a:t>Autonomy: choose one normative vocabulary.</a:t>
             </a:r>
           </a:p>
         </p:txBody>
@@ -5136,6 +5137,417 @@
                 </a:solidFill>
                 <a:latin typeface="Calibri"/>
               </a:rPr>
+              <a:t>Decisions (2/2): new content types needed</a:t>
+            </a:r>
+          </a:p>
+        </p:txBody>
+      </p:sp>
+      <p:sp>
+        <p:nvSpPr>
+          <p:cNvPr id="4" name="TextBox 3"/>
+          <p:cNvSpPr txBox="1"/>
+          <p:nvPr/>
+        </p:nvSpPr>
+        <p:spPr>
+          <a:xfrm>
+            <a:off x="640080" y="1508760"/>
+            <a:ext cx="10972800" cy="4754880"/>
+          </a:xfrm>
+          <a:prstGeom prst="rect">
+            <a:avLst/>
+          </a:prstGeom>
+          <a:noFill/>
+        </p:spPr>
+        <p:txBody>
+          <a:bodyPr wrap="square">
+            <a:spAutoFit/>
+          </a:bodyPr>
+          <a:lstStyle/>
+          <a:p>
+            <a:pPr>
+              <a:spcBef>
+                <a:spcPts val="200"/>
+              </a:spcBef>
+              <a:spcAft>
+                <a:spcPts val="900"/>
+              </a:spcAft>
+            </a:pPr>
+            <a:r>
+              <a:rPr sz="1400" b="1" i="0">
+                <a:solidFill>
+                  <a:srgbClr val="2E869A"/>
+                </a:solidFill>
+                <a:latin typeface="Calibri"/>
+              </a:rPr>
+              <a:t>Q-E  </a:t>
+            </a:r>
+            <a:r>
+              <a:rPr sz="1400" b="0" i="0">
+                <a:solidFill>
+                  <a:srgbClr val="333333"/>
+                </a:solidFill>
+                <a:latin typeface="Calibri"/>
+              </a:rPr>
+              <a:t>Inline entity definition for newly-observed entities in reports.</a:t>
+            </a:r>
+          </a:p>
+          <a:p>
+            <a:pPr>
+              <a:spcBef>
+                <a:spcPts val="200"/>
+              </a:spcBef>
+              <a:spcAft>
+                <a:spcPts val="900"/>
+              </a:spcAft>
+            </a:pPr>
+            <a:r>
+              <a:rPr sz="1400" b="1" i="0">
+                <a:solidFill>
+                  <a:srgbClr val="2E869A"/>
+                </a:solidFill>
+                <a:latin typeface="Calibri"/>
+              </a:rPr>
+              <a:t>Q-F  </a:t>
+            </a:r>
+            <a:r>
+              <a:rPr sz="1400" b="0" i="0">
+                <a:solidFill>
+                  <a:srgbClr val="333333"/>
+                </a:solidFill>
+                <a:latin typeface="Calibri"/>
+              </a:rPr>
+              <a:t>MediaReference identity; separate media-format from sensor-modality.</a:t>
+            </a:r>
+          </a:p>
+          <a:p>
+            <a:pPr>
+              <a:spcBef>
+                <a:spcPts val="200"/>
+              </a:spcBef>
+              <a:spcAft>
+                <a:spcPts val="900"/>
+              </a:spcAft>
+            </a:pPr>
+            <a:r>
+              <a:rPr sz="1400" b="1" i="0">
+                <a:solidFill>
+                  <a:srgbClr val="2E869A"/>
+                </a:solidFill>
+                <a:latin typeface="Calibri"/>
+              </a:rPr>
+              <a:t>Q-G  </a:t>
+            </a:r>
+            <a:r>
+              <a:rPr sz="1400" b="0" i="0">
+                <a:solidFill>
+                  <a:srgbClr val="333333"/>
+                </a:solidFill>
+                <a:latin typeface="Calibri"/>
+              </a:rPr>
+              <a:t>Robot-to-robot coordination content type + issuing authority (CASEVAC).</a:t>
+            </a:r>
+          </a:p>
+          <a:p>
+            <a:pPr>
+              <a:spcBef>
+                <a:spcPts val="200"/>
+              </a:spcBef>
+              <a:spcAft>
+                <a:spcPts val="900"/>
+              </a:spcAft>
+            </a:pPr>
+            <a:r>
+              <a:rPr sz="1400" b="1" i="0">
+                <a:solidFill>
+                  <a:srgbClr val="2E869A"/>
+                </a:solidFill>
+                <a:latin typeface="Calibri"/>
+              </a:rPr>
+              <a:t>Q-H  </a:t>
+            </a:r>
+            <a:r>
+              <a:rPr sz="1400" b="0" i="0">
+                <a:solidFill>
+                  <a:srgbClr val="333333"/>
+                </a:solidFill>
+                <a:latin typeface="Calibri"/>
+              </a:rPr>
+              <a:t>Rationale/explanation ReportContent - report why, not just what (CASEVAC).</a:t>
+            </a:r>
+          </a:p>
+          <a:p>
+            <a:pPr>
+              <a:spcBef>
+                <a:spcPts val="200"/>
+              </a:spcBef>
+              <a:spcAft>
+                <a:spcPts val="900"/>
+              </a:spcAft>
+            </a:pPr>
+            <a:r>
+              <a:rPr sz="1400" b="1" i="0">
+                <a:solidFill>
+                  <a:srgbClr val="2E869A"/>
+                </a:solidFill>
+                <a:latin typeface="Calibri"/>
+              </a:rPr>
+              <a:t>Q-I  </a:t>
+            </a:r>
+            <a:r>
+              <a:rPr sz="1400" b="0" i="0">
+                <a:solidFill>
+                  <a:srgbClr val="333333"/>
+                </a:solidFill>
+                <a:latin typeface="Calibri"/>
+              </a:rPr>
+              <a:t>Media-independent sensor-reading (value+unit+modality) + full SensorType taxonomy.</a:t>
+            </a:r>
+          </a:p>
+          <a:p>
+            <a:pPr>
+              <a:spcBef>
+                <a:spcPts val="200"/>
+              </a:spcBef>
+              <a:spcAft>
+                <a:spcPts val="900"/>
+              </a:spcAft>
+            </a:pPr>
+            <a:r>
+              <a:rPr sz="1400" b="1" i="0">
+                <a:solidFill>
+                  <a:srgbClr val="2E869A"/>
+                </a:solidFill>
+                <a:latin typeface="Calibri"/>
+              </a:rPr>
+              <a:t>Q-J  </a:t>
+            </a:r>
+            <a:r>
+              <a:rPr sz="1400" b="0" i="0">
+                <a:solidFill>
+                  <a:srgbClr val="333333"/>
+                </a:solidFill>
+                <a:latin typeface="Calibri"/>
+              </a:rPr>
+              <a:t>Swarm residuals: network params, leader role, aggregation, member lifecycle.</a:t>
+            </a:r>
+          </a:p>
+          <a:p>
+            <a:pPr>
+              <a:spcBef>
+                <a:spcPts val="200"/>
+              </a:spcBef>
+              <a:spcAft>
+                <a:spcPts val="900"/>
+              </a:spcAft>
+            </a:pPr>
+            <a:r>
+              <a:rPr sz="1400" b="1" i="0">
+                <a:solidFill>
+                  <a:srgbClr val="2E869A"/>
+                </a:solidFill>
+                <a:latin typeface="Calibri"/>
+              </a:rPr>
+              <a:t>Q-K  </a:t>
+            </a:r>
+            <a:r>
+              <a:rPr sz="1400" b="0" i="0">
+                <a:solidFill>
+                  <a:srgbClr val="333333"/>
+                </a:solidFill>
+                <a:latin typeface="Calibri"/>
+              </a:rPr>
+              <a:t>Engagement authority as a function of autonomy level (Fire Support).</a:t>
+            </a:r>
+          </a:p>
+          <a:p>
+            <a:pPr>
+              <a:spcBef>
+                <a:spcPts val="200"/>
+              </a:spcBef>
+              <a:spcAft>
+                <a:spcPts val="900"/>
+              </a:spcAft>
+            </a:pPr>
+            <a:r>
+              <a:rPr sz="1400" b="1" i="0">
+                <a:solidFill>
+                  <a:srgbClr val="2E869A"/>
+                </a:solidFill>
+                <a:latin typeface="Calibri"/>
+              </a:rPr>
+              <a:t>Q-L  </a:t>
+            </a:r>
+            <a:r>
+              <a:rPr sz="1400" b="0" i="0">
+                <a:solidFill>
+                  <a:srgbClr val="333333"/>
+                </a:solidFill>
+                <a:latin typeface="Calibri"/>
+              </a:rPr>
+              <a:t>Task-verb vocabulary (deliver, manipulate, recover) + typed payload/effector/weapon.</a:t>
+            </a:r>
+          </a:p>
+        </p:txBody>
+      </p:sp>
+      <p:sp>
+        <p:nvSpPr>
+          <p:cNvPr id="5" name="TextBox 4"/>
+          <p:cNvSpPr txBox="1"/>
+          <p:nvPr/>
+        </p:nvSpPr>
+        <p:spPr>
+          <a:xfrm>
+            <a:off x="502920" y="6419088"/>
+            <a:ext cx="11155680" cy="320040"/>
+          </a:xfrm>
+          <a:prstGeom prst="rect">
+            <a:avLst/>
+          </a:prstGeom>
+          <a:noFill/>
+        </p:spPr>
+        <p:txBody>
+          <a:bodyPr wrap="square">
+            <a:spAutoFit/>
+          </a:bodyPr>
+          <a:lstStyle/>
+          <a:p>
+            <a:r>
+              <a:rPr sz="900" b="0" i="0">
+                <a:solidFill>
+                  <a:srgbClr val="666666"/>
+                </a:solidFill>
+                <a:latin typeface="Calibri"/>
+              </a:rPr>
+              <a:t>C2SIM ASX Sub-group   |   Hyssos   |   July 2026</a:t>
+            </a:r>
+          </a:p>
+        </p:txBody>
+      </p:sp>
+      <p:sp>
+        <p:nvSpPr>
+          <p:cNvPr id="6" name="TextBox 5"/>
+          <p:cNvSpPr txBox="1"/>
+          <p:nvPr/>
+        </p:nvSpPr>
+        <p:spPr>
+          <a:xfrm>
+            <a:off x="11338560" y="6419088"/>
+            <a:ext cx="640080" cy="320040"/>
+          </a:xfrm>
+          <a:prstGeom prst="rect">
+            <a:avLst/>
+          </a:prstGeom>
+          <a:noFill/>
+        </p:spPr>
+        <p:txBody>
+          <a:bodyPr wrap="square">
+            <a:spAutoFit/>
+          </a:bodyPr>
+          <a:lstStyle/>
+          <a:p>
+            <a:pPr algn="r"/>
+            <a:r>
+              <a:rPr sz="900" b="0" i="0">
+                <a:solidFill>
+                  <a:srgbClr val="666666"/>
+                </a:solidFill>
+                <a:latin typeface="Calibri"/>
+              </a:rPr>
+              <a:t>15</a:t>
+            </a:r>
+          </a:p>
+        </p:txBody>
+      </p:sp>
+    </p:spTree>
+  </p:cSld>
+  <p:clrMapOvr>
+    <a:masterClrMapping/>
+  </p:clrMapOvr>
+</p:sld>
+</file>
+
+<file path=ppt/slides/slide16.xml><?xml version="1.0" encoding="utf-8"?>
+<p:sld xmlns:a="http://schemas.openxmlformats.org/drawingml/2006/main" xmlns:p="http://schemas.openxmlformats.org/presentationml/2006/main" xmlns:r="http://schemas.openxmlformats.org/officeDocument/2006/relationships">
+  <p:cSld>
+    <p:spTree>
+      <p:nvGrpSpPr>
+        <p:cNvPr id="1" name=""/>
+        <p:cNvGrpSpPr/>
+        <p:nvPr/>
+      </p:nvGrpSpPr>
+      <p:grpSpPr/>
+      <p:sp>
+        <p:nvSpPr>
+          <p:cNvPr id="2" name="Rectangle 1"/>
+          <p:cNvSpPr/>
+          <p:nvPr/>
+        </p:nvSpPr>
+        <p:spPr>
+          <a:xfrm>
+            <a:off x="548640" y="1170432"/>
+            <a:ext cx="2011680" cy="38100"/>
+          </a:xfrm>
+          <a:prstGeom prst="rect">
+            <a:avLst/>
+          </a:prstGeom>
+          <a:solidFill>
+            <a:srgbClr val="2E869A"/>
+          </a:solidFill>
+          <a:ln>
+            <a:noFill/>
+          </a:ln>
+        </p:spPr>
+        <p:style>
+          <a:lnRef idx="1">
+            <a:schemeClr val="accent1"/>
+          </a:lnRef>
+          <a:fillRef idx="3">
+            <a:schemeClr val="accent1"/>
+          </a:fillRef>
+          <a:effectRef idx="2">
+            <a:schemeClr val="accent1"/>
+          </a:effectRef>
+          <a:fontRef idx="minor">
+            <a:schemeClr val="lt1"/>
+          </a:fontRef>
+        </p:style>
+        <p:txBody>
+          <a:bodyPr rtlCol="0" anchor="ctr"/>
+          <a:lstStyle/>
+          <a:p>
+            <a:pPr algn="ctr"/>
+          </a:p>
+        </p:txBody>
+      </p:sp>
+      <p:sp>
+        <p:nvSpPr>
+          <p:cNvPr id="3" name="TextBox 2"/>
+          <p:cNvSpPr txBox="1"/>
+          <p:nvPr/>
+        </p:nvSpPr>
+        <p:spPr>
+          <a:xfrm>
+            <a:off x="502920" y="411480"/>
+            <a:ext cx="11155680" cy="822960"/>
+          </a:xfrm>
+          <a:prstGeom prst="rect">
+            <a:avLst/>
+          </a:prstGeom>
+          <a:noFill/>
+        </p:spPr>
+        <p:txBody>
+          <a:bodyPr wrap="square">
+            <a:spAutoFit/>
+          </a:bodyPr>
+          <a:lstStyle/>
+          <a:p>
+            <a:r>
+              <a:rPr sz="3000" b="1" i="0">
+                <a:solidFill>
+                  <a:srgbClr val="1F3A5F"/>
+                </a:solidFill>
+                <a:latin typeface="Calibri"/>
+              </a:rPr>
               <a:t>Recommended next steps</a:t>
             </a:r>
           </a:p>
@@ -5323,7 +5735,7 @@
                 </a:solidFill>
                 <a:latin typeface="Calibri"/>
               </a:rPr>
-              <a:t>15</a:t>
+              <a:t>16</a:t>
             </a:r>
           </a:p>
         </p:txBody>

</xml_diff>

<commit_message>
Redundancy pass + proposed-fixes slide
Confirmed the three flagged-redundant scenarios (route-clearance, companion,
urban) are ~80% recombinations of existing findings - but the pass extracted a
new one, N1: an area cannot be the subject of a task or report (no
hasAffectedArea; no area-state), which the entity-centric walks missed. Added a
Route Clearance Order tab demonstrating it, decision Q-M, and section 6g.

Deck: added a "Proposed fixes (pending buy-in)" slide grouping the safe
corrections, structural decisions, and new-content designs - explicitly marked
not-applied. Folded in N1/Q-M. 17 slides, 0 off-slide.

Co-Authored-By: Claude Opus 4.8 (1M context) <noreply@anthropic.com>
</commit_message>
<xml_diff>
--- a/Subgroups/ASX/InstantiationReview/ASX-Instantiation-Findings.pptx
+++ b/Subgroups/ASX/InstantiationReview/ASX-Instantiation-Findings.pptx
@@ -21,6 +21,7 @@
     <p:sldId id="269" r:id="rId20"/>
     <p:sldId id="270" r:id="rId21"/>
     <p:sldId id="271" r:id="rId22"/>
+    <p:sldId id="272" r:id="rId23"/>
   </p:sldIdLst>
   <p:sldSz cx="12191695" cy="6858000" type="screen4x3"/>
   <p:notesSz cx="6858000" cy="9144000"/>
@@ -3483,6 +3484,25 @@
               <a:t>Task/effect scenarios: engagement, delivery, manipulation, rescue walked - the gap is consistent (task verbs + payload/effector typing).</a:t>
             </a:r>
           </a:p>
+          <a:p>
+            <a:pPr>
+              <a:spcBef>
+                <a:spcPts val="200"/>
+              </a:spcBef>
+              <a:spcAft>
+                <a:spcPts val="1200"/>
+              </a:spcAft>
+            </a:pPr>
+            <a:r>
+              <a:rPr sz="1650" b="0" i="0">
+                <a:solidFill>
+                  <a:srgbClr val="333333"/>
+                </a:solidFill>
+                <a:latin typeface="Calibri"/>
+              </a:rPr>
+              <a:t>Redundancy pass (route-clearance, companion, urban): confirmed - plus one new finding, N1 (an area cannot be the subject of a task/report).</a:t>
+            </a:r>
+          </a:p>
         </p:txBody>
       </p:sp>
       <p:sp>
@@ -4608,8 +4628,8 @@
         </p:nvSpPr>
         <p:spPr>
           <a:xfrm>
-            <a:off x="640080" y="3703320"/>
-            <a:ext cx="10972800" cy="2651760"/>
+            <a:off x="640080" y="3657600"/>
+            <a:ext cx="10972800" cy="2697480"/>
           </a:xfrm>
           <a:prstGeom prst="rect">
             <a:avLst/>
@@ -4627,11 +4647,11 @@
                 <a:spcPts val="200"/>
               </a:spcBef>
               <a:spcAft>
-                <a:spcPts val="1200"/>
+                <a:spcPts val="900"/>
               </a:spcAft>
             </a:pPr>
             <a:r>
-              <a:rPr sz="1500" b="1" i="0">
+              <a:rPr sz="1400" b="1" i="0">
                 <a:solidFill>
                   <a:srgbClr val="2E7D32"/>
                 </a:solidFill>
@@ -4640,7 +4660,7 @@
               <a:t>Already there (checked):  </a:t>
             </a:r>
             <a:r>
-              <a:rPr sz="1500" b="0" i="0">
+              <a:rPr sz="1400" b="0" i="0">
                 <a:solidFill>
                   <a:srgbClr val="333333"/>
                 </a:solidFill>
@@ -4655,11 +4675,39 @@
                 <a:spcPts val="200"/>
               </a:spcBef>
               <a:spcAft>
-                <a:spcPts val="1200"/>
+                <a:spcPts val="900"/>
               </a:spcAft>
             </a:pPr>
             <a:r>
-              <a:rPr sz="1500" b="1" i="0">
+              <a:rPr sz="1400" b="1" i="0">
+                <a:solidFill>
+                  <a:srgbClr val="C87F0A"/>
+                </a:solidFill>
+                <a:latin typeface="Calibri"/>
+              </a:rPr>
+              <a:t>Also (N1):  </a:t>
+            </a:r>
+            <a:r>
+              <a:rPr sz="1400" b="0" i="0">
+                <a:solidFill>
+                  <a:srgbClr val="333333"/>
+                </a:solidFill>
+                <a:latin typeface="Calibri"/>
+              </a:rPr>
+              <a:t>an area cannot be the subject of a task or report - no hasAffectedArea, no area-state (cleared/contaminated). See Q-M.</a:t>
+            </a:r>
+          </a:p>
+          <a:p>
+            <a:pPr>
+              <a:spcBef>
+                <a:spcPts val="200"/>
+              </a:spcBef>
+              <a:spcAft>
+                <a:spcPts val="900"/>
+              </a:spcAft>
+            </a:pPr>
+            <a:r>
+              <a:rPr sz="1400" b="1" i="0">
                 <a:solidFill>
                   <a:srgbClr val="2E869A"/>
                 </a:solidFill>
@@ -4668,7 +4716,7 @@
               <a:t>Decision (Q-L):  </a:t>
             </a:r>
             <a:r>
-              <a:rPr sz="1500" b="0" i="0">
+              <a:rPr sz="1400" b="0" i="0">
                 <a:solidFill>
                   <a:srgbClr val="333333"/>
                 </a:solidFill>
@@ -5150,7 +5198,7 @@
         </p:nvSpPr>
         <p:spPr>
           <a:xfrm>
-            <a:off x="640080" y="1508760"/>
+            <a:off x="640080" y="1463040"/>
             <a:ext cx="10972800" cy="4754880"/>
           </a:xfrm>
           <a:prstGeom prst="rect">
@@ -5169,11 +5217,11 @@
                 <a:spcPts val="200"/>
               </a:spcBef>
               <a:spcAft>
-                <a:spcPts val="900"/>
+                <a:spcPts val="800"/>
               </a:spcAft>
             </a:pPr>
             <a:r>
-              <a:rPr sz="1400" b="1" i="0">
+              <a:rPr sz="1350" b="1" i="0">
                 <a:solidFill>
                   <a:srgbClr val="2E869A"/>
                 </a:solidFill>
@@ -5182,7 +5230,7 @@
               <a:t>Q-E  </a:t>
             </a:r>
             <a:r>
-              <a:rPr sz="1400" b="0" i="0">
+              <a:rPr sz="1350" b="0" i="0">
                 <a:solidFill>
                   <a:srgbClr val="333333"/>
                 </a:solidFill>
@@ -5197,11 +5245,11 @@
                 <a:spcPts val="200"/>
               </a:spcBef>
               <a:spcAft>
-                <a:spcPts val="900"/>
+                <a:spcPts val="800"/>
               </a:spcAft>
             </a:pPr>
             <a:r>
-              <a:rPr sz="1400" b="1" i="0">
+              <a:rPr sz="1350" b="1" i="0">
                 <a:solidFill>
                   <a:srgbClr val="2E869A"/>
                 </a:solidFill>
@@ -5210,7 +5258,7 @@
               <a:t>Q-F  </a:t>
             </a:r>
             <a:r>
-              <a:rPr sz="1400" b="0" i="0">
+              <a:rPr sz="1350" b="0" i="0">
                 <a:solidFill>
                   <a:srgbClr val="333333"/>
                 </a:solidFill>
@@ -5225,11 +5273,11 @@
                 <a:spcPts val="200"/>
               </a:spcBef>
               <a:spcAft>
-                <a:spcPts val="900"/>
+                <a:spcPts val="800"/>
               </a:spcAft>
             </a:pPr>
             <a:r>
-              <a:rPr sz="1400" b="1" i="0">
+              <a:rPr sz="1350" b="1" i="0">
                 <a:solidFill>
                   <a:srgbClr val="2E869A"/>
                 </a:solidFill>
@@ -5238,7 +5286,7 @@
               <a:t>Q-G  </a:t>
             </a:r>
             <a:r>
-              <a:rPr sz="1400" b="0" i="0">
+              <a:rPr sz="1350" b="0" i="0">
                 <a:solidFill>
                   <a:srgbClr val="333333"/>
                 </a:solidFill>
@@ -5253,11 +5301,11 @@
                 <a:spcPts val="200"/>
               </a:spcBef>
               <a:spcAft>
-                <a:spcPts val="900"/>
+                <a:spcPts val="800"/>
               </a:spcAft>
             </a:pPr>
             <a:r>
-              <a:rPr sz="1400" b="1" i="0">
+              <a:rPr sz="1350" b="1" i="0">
                 <a:solidFill>
                   <a:srgbClr val="2E869A"/>
                 </a:solidFill>
@@ -5266,7 +5314,7 @@
               <a:t>Q-H  </a:t>
             </a:r>
             <a:r>
-              <a:rPr sz="1400" b="0" i="0">
+              <a:rPr sz="1350" b="0" i="0">
                 <a:solidFill>
                   <a:srgbClr val="333333"/>
                 </a:solidFill>
@@ -5281,11 +5329,11 @@
                 <a:spcPts val="200"/>
               </a:spcBef>
               <a:spcAft>
-                <a:spcPts val="900"/>
+                <a:spcPts val="800"/>
               </a:spcAft>
             </a:pPr>
             <a:r>
-              <a:rPr sz="1400" b="1" i="0">
+              <a:rPr sz="1350" b="1" i="0">
                 <a:solidFill>
                   <a:srgbClr val="2E869A"/>
                 </a:solidFill>
@@ -5294,7 +5342,7 @@
               <a:t>Q-I  </a:t>
             </a:r>
             <a:r>
-              <a:rPr sz="1400" b="0" i="0">
+              <a:rPr sz="1350" b="0" i="0">
                 <a:solidFill>
                   <a:srgbClr val="333333"/>
                 </a:solidFill>
@@ -5309,11 +5357,11 @@
                 <a:spcPts val="200"/>
               </a:spcBef>
               <a:spcAft>
-                <a:spcPts val="900"/>
+                <a:spcPts val="800"/>
               </a:spcAft>
             </a:pPr>
             <a:r>
-              <a:rPr sz="1400" b="1" i="0">
+              <a:rPr sz="1350" b="1" i="0">
                 <a:solidFill>
                   <a:srgbClr val="2E869A"/>
                 </a:solidFill>
@@ -5322,7 +5370,7 @@
               <a:t>Q-J  </a:t>
             </a:r>
             <a:r>
-              <a:rPr sz="1400" b="0" i="0">
+              <a:rPr sz="1350" b="0" i="0">
                 <a:solidFill>
                   <a:srgbClr val="333333"/>
                 </a:solidFill>
@@ -5337,11 +5385,11 @@
                 <a:spcPts val="200"/>
               </a:spcBef>
               <a:spcAft>
-                <a:spcPts val="900"/>
+                <a:spcPts val="800"/>
               </a:spcAft>
             </a:pPr>
             <a:r>
-              <a:rPr sz="1400" b="1" i="0">
+              <a:rPr sz="1350" b="1" i="0">
                 <a:solidFill>
                   <a:srgbClr val="2E869A"/>
                 </a:solidFill>
@@ -5350,7 +5398,7 @@
               <a:t>Q-K  </a:t>
             </a:r>
             <a:r>
-              <a:rPr sz="1400" b="0" i="0">
+              <a:rPr sz="1350" b="0" i="0">
                 <a:solidFill>
                   <a:srgbClr val="333333"/>
                 </a:solidFill>
@@ -5365,11 +5413,11 @@
                 <a:spcPts val="200"/>
               </a:spcBef>
               <a:spcAft>
-                <a:spcPts val="900"/>
+                <a:spcPts val="800"/>
               </a:spcAft>
             </a:pPr>
             <a:r>
-              <a:rPr sz="1400" b="1" i="0">
+              <a:rPr sz="1350" b="1" i="0">
                 <a:solidFill>
                   <a:srgbClr val="2E869A"/>
                 </a:solidFill>
@@ -5378,13 +5426,41 @@
               <a:t>Q-L  </a:t>
             </a:r>
             <a:r>
-              <a:rPr sz="1400" b="0" i="0">
+              <a:rPr sz="1350" b="0" i="0">
                 <a:solidFill>
                   <a:srgbClr val="333333"/>
                 </a:solidFill>
                 <a:latin typeface="Calibri"/>
               </a:rPr>
               <a:t>Task-verb vocabulary (deliver, manipulate, recover) + typed payload/effector/weapon.</a:t>
+            </a:r>
+          </a:p>
+          <a:p>
+            <a:pPr>
+              <a:spcBef>
+                <a:spcPts val="200"/>
+              </a:spcBef>
+              <a:spcAft>
+                <a:spcPts val="800"/>
+              </a:spcAft>
+            </a:pPr>
+            <a:r>
+              <a:rPr sz="1350" b="1" i="0">
+                <a:solidFill>
+                  <a:srgbClr val="2E869A"/>
+                </a:solidFill>
+                <a:latin typeface="Calibri"/>
+              </a:rPr>
+              <a:t>Q-M  </a:t>
+            </a:r>
+            <a:r>
+              <a:rPr sz="1350" b="0" i="0">
+                <a:solidFill>
+                  <a:srgbClr val="333333"/>
+                </a:solidFill>
+                <a:latin typeface="Calibri"/>
+              </a:rPr>
+              <a:t>Let an area be the subject of a task/report (hasAffectedArea + area-state).</a:t>
             </a:r>
           </a:p>
         </p:txBody>
@@ -5548,6 +5624,330 @@
                 </a:solidFill>
                 <a:latin typeface="Calibri"/>
               </a:rPr>
+              <a:t>Proposed fixes</a:t>
+            </a:r>
+          </a:p>
+        </p:txBody>
+      </p:sp>
+      <p:sp>
+        <p:nvSpPr>
+          <p:cNvPr id="4" name="TextBox 3"/>
+          <p:cNvSpPr txBox="1"/>
+          <p:nvPr/>
+        </p:nvSpPr>
+        <p:spPr>
+          <a:xfrm>
+            <a:off x="548640" y="914400"/>
+            <a:ext cx="10972800" cy="320040"/>
+          </a:xfrm>
+          <a:prstGeom prst="rect">
+            <a:avLst/>
+          </a:prstGeom>
+          <a:noFill/>
+        </p:spPr>
+        <p:txBody>
+          <a:bodyPr wrap="square">
+            <a:spAutoFit/>
+          </a:bodyPr>
+          <a:lstStyle/>
+          <a:p>
+            <a:r>
+              <a:rPr sz="1300" b="0" i="1">
+                <a:solidFill>
+                  <a:srgbClr val="2E869A"/>
+                </a:solidFill>
+                <a:latin typeface="Calibri"/>
+              </a:rPr>
+              <a:t>Pending group buy-in - nothing applied to the model</a:t>
+            </a:r>
+          </a:p>
+        </p:txBody>
+      </p:sp>
+      <p:sp>
+        <p:nvSpPr>
+          <p:cNvPr id="5" name="TextBox 4"/>
+          <p:cNvSpPr txBox="1"/>
+          <p:nvPr/>
+        </p:nvSpPr>
+        <p:spPr>
+          <a:xfrm>
+            <a:off x="640080" y="1554480"/>
+            <a:ext cx="10972800" cy="4754880"/>
+          </a:xfrm>
+          <a:prstGeom prst="rect">
+            <a:avLst/>
+          </a:prstGeom>
+          <a:noFill/>
+        </p:spPr>
+        <p:txBody>
+          <a:bodyPr wrap="square">
+            <a:spAutoFit/>
+          </a:bodyPr>
+          <a:lstStyle/>
+          <a:p>
+            <a:pPr>
+              <a:spcBef>
+                <a:spcPts val="200"/>
+              </a:spcBef>
+              <a:spcAft>
+                <a:spcPts val="1300"/>
+              </a:spcAft>
+            </a:pPr>
+            <a:r>
+              <a:rPr sz="1400" b="1" i="0">
+                <a:solidFill>
+                  <a:srgbClr val="2E7D32"/>
+                </a:solidFill>
+                <a:latin typeface="Calibri"/>
+              </a:rPr>
+              <a:t>Safe corrections (unambiguous):  </a:t>
+            </a:r>
+            <a:r>
+              <a:rPr sz="1400" b="0" i="0">
+                <a:solidFill>
+                  <a:srgbClr val="333333"/>
+                </a:solidFill>
+                <a:latin typeface="Calibri"/>
+              </a:rPr>
+              <a:t>class typo CollecticeRoboticSystem -&gt; Collective (O1); versionInfo Extrension -&gt; Extension (O2); file CSIM_ASX -&gt; C2SIM_ASX (O3); hasStartTime UUIDBase -&gt; TimeInstant (M7); unify namespace label ASX / C2SIM_ASX (M8).</a:t>
+            </a:r>
+          </a:p>
+          <a:p>
+            <a:pPr>
+              <a:spcBef>
+                <a:spcPts val="200"/>
+              </a:spcBef>
+              <a:spcAft>
+                <a:spcPts val="1300"/>
+              </a:spcAft>
+            </a:pPr>
+            <a:r>
+              <a:rPr sz="1400" b="1" i="0">
+                <a:solidFill>
+                  <a:srgbClr val="C87F0A"/>
+                </a:solidFill>
+                <a:latin typeface="Calibri"/>
+              </a:rPr>
+              <a:t>Structural (decide first):  </a:t>
+            </a:r>
+            <a:r>
+              <a:rPr sz="1400" b="0" i="0">
+                <a:solidFill>
+                  <a:srgbClr val="333333"/>
+                </a:solidFill>
+                <a:latin typeface="Calibri"/>
+              </a:rPr>
+              <a:t>UAV/robot typing (Q-A); Swarm -&gt; CollectiveEntity so it is taskable (Q-B); one sensor model (Q-C); one autonomy vocabulary (Q-D).</a:t>
+            </a:r>
+          </a:p>
+          <a:p>
+            <a:pPr>
+              <a:spcBef>
+                <a:spcPts val="200"/>
+              </a:spcBef>
+              <a:spcAft>
+                <a:spcPts val="1300"/>
+              </a:spcAft>
+            </a:pPr>
+            <a:r>
+              <a:rPr sz="1400" b="1" i="0">
+                <a:solidFill>
+                  <a:srgbClr val="2E869A"/>
+                </a:solidFill>
+                <a:latin typeface="Calibri"/>
+              </a:rPr>
+              <a:t>New content (design):  </a:t>
+            </a:r>
+            <a:r>
+              <a:rPr sz="1400" b="0" i="0">
+                <a:solidFill>
+                  <a:srgbClr val="333333"/>
+                </a:solidFill>
+                <a:latin typeface="Calibri"/>
+              </a:rPr>
+              <a:t>inline entity def (Q-E), MediaReference (Q-F), robot-to-robot (Q-G), rationale report (Q-H), sensor-reading (Q-I), swarm residuals (Q-J), engagement authority (Q-K), task verbs + payload (Q-L), area subject (Q-M).</a:t>
+            </a:r>
+          </a:p>
+          <a:p>
+            <a:pPr>
+              <a:spcBef>
+                <a:spcPts val="200"/>
+              </a:spcBef>
+              <a:spcAft>
+                <a:spcPts val="1300"/>
+              </a:spcAft>
+            </a:pPr>
+            <a:r>
+              <a:rPr sz="1400" b="1" i="0">
+                <a:solidFill>
+                  <a:srgbClr val="333333"/>
+                </a:solidFill>
+                <a:latin typeface="Calibri"/>
+              </a:rPr>
+              <a:t>Nothing here is applied to the model - all items are proposals for group buy-in.</a:t>
+            </a:r>
+          </a:p>
+        </p:txBody>
+      </p:sp>
+      <p:sp>
+        <p:nvSpPr>
+          <p:cNvPr id="6" name="TextBox 5"/>
+          <p:cNvSpPr txBox="1"/>
+          <p:nvPr/>
+        </p:nvSpPr>
+        <p:spPr>
+          <a:xfrm>
+            <a:off x="502920" y="6419088"/>
+            <a:ext cx="11155680" cy="320040"/>
+          </a:xfrm>
+          <a:prstGeom prst="rect">
+            <a:avLst/>
+          </a:prstGeom>
+          <a:noFill/>
+        </p:spPr>
+        <p:txBody>
+          <a:bodyPr wrap="square">
+            <a:spAutoFit/>
+          </a:bodyPr>
+          <a:lstStyle/>
+          <a:p>
+            <a:r>
+              <a:rPr sz="900" b="0" i="0">
+                <a:solidFill>
+                  <a:srgbClr val="666666"/>
+                </a:solidFill>
+                <a:latin typeface="Calibri"/>
+              </a:rPr>
+              <a:t>C2SIM ASX Sub-group   |   Hyssos   |   July 2026</a:t>
+            </a:r>
+          </a:p>
+        </p:txBody>
+      </p:sp>
+      <p:sp>
+        <p:nvSpPr>
+          <p:cNvPr id="7" name="TextBox 6"/>
+          <p:cNvSpPr txBox="1"/>
+          <p:nvPr/>
+        </p:nvSpPr>
+        <p:spPr>
+          <a:xfrm>
+            <a:off x="11338560" y="6419088"/>
+            <a:ext cx="640080" cy="320040"/>
+          </a:xfrm>
+          <a:prstGeom prst="rect">
+            <a:avLst/>
+          </a:prstGeom>
+          <a:noFill/>
+        </p:spPr>
+        <p:txBody>
+          <a:bodyPr wrap="square">
+            <a:spAutoFit/>
+          </a:bodyPr>
+          <a:lstStyle/>
+          <a:p>
+            <a:pPr algn="r"/>
+            <a:r>
+              <a:rPr sz="900" b="0" i="0">
+                <a:solidFill>
+                  <a:srgbClr val="666666"/>
+                </a:solidFill>
+                <a:latin typeface="Calibri"/>
+              </a:rPr>
+              <a:t>16</a:t>
+            </a:r>
+          </a:p>
+        </p:txBody>
+      </p:sp>
+    </p:spTree>
+  </p:cSld>
+  <p:clrMapOvr>
+    <a:masterClrMapping/>
+  </p:clrMapOvr>
+</p:sld>
+</file>
+
+<file path=ppt/slides/slide17.xml><?xml version="1.0" encoding="utf-8"?>
+<p:sld xmlns:a="http://schemas.openxmlformats.org/drawingml/2006/main" xmlns:p="http://schemas.openxmlformats.org/presentationml/2006/main" xmlns:r="http://schemas.openxmlformats.org/officeDocument/2006/relationships">
+  <p:cSld>
+    <p:spTree>
+      <p:nvGrpSpPr>
+        <p:cNvPr id="1" name=""/>
+        <p:cNvGrpSpPr/>
+        <p:nvPr/>
+      </p:nvGrpSpPr>
+      <p:grpSpPr/>
+      <p:sp>
+        <p:nvSpPr>
+          <p:cNvPr id="2" name="Rectangle 1"/>
+          <p:cNvSpPr/>
+          <p:nvPr/>
+        </p:nvSpPr>
+        <p:spPr>
+          <a:xfrm>
+            <a:off x="548640" y="1170432"/>
+            <a:ext cx="2011680" cy="38100"/>
+          </a:xfrm>
+          <a:prstGeom prst="rect">
+            <a:avLst/>
+          </a:prstGeom>
+          <a:solidFill>
+            <a:srgbClr val="2E869A"/>
+          </a:solidFill>
+          <a:ln>
+            <a:noFill/>
+          </a:ln>
+        </p:spPr>
+        <p:style>
+          <a:lnRef idx="1">
+            <a:schemeClr val="accent1"/>
+          </a:lnRef>
+          <a:fillRef idx="3">
+            <a:schemeClr val="accent1"/>
+          </a:fillRef>
+          <a:effectRef idx="2">
+            <a:schemeClr val="accent1"/>
+          </a:effectRef>
+          <a:fontRef idx="minor">
+            <a:schemeClr val="lt1"/>
+          </a:fontRef>
+        </p:style>
+        <p:txBody>
+          <a:bodyPr rtlCol="0" anchor="ctr"/>
+          <a:lstStyle/>
+          <a:p>
+            <a:pPr algn="ctr"/>
+          </a:p>
+        </p:txBody>
+      </p:sp>
+      <p:sp>
+        <p:nvSpPr>
+          <p:cNvPr id="3" name="TextBox 2"/>
+          <p:cNvSpPr txBox="1"/>
+          <p:nvPr/>
+        </p:nvSpPr>
+        <p:spPr>
+          <a:xfrm>
+            <a:off x="502920" y="411480"/>
+            <a:ext cx="11155680" cy="822960"/>
+          </a:xfrm>
+          <a:prstGeom prst="rect">
+            <a:avLst/>
+          </a:prstGeom>
+          <a:noFill/>
+        </p:spPr>
+        <p:txBody>
+          <a:bodyPr wrap="square">
+            <a:spAutoFit/>
+          </a:bodyPr>
+          <a:lstStyle/>
+          <a:p>
+            <a:r>
+              <a:rPr sz="3000" b="1" i="0">
+                <a:solidFill>
+                  <a:srgbClr val="1F3A5F"/>
+                </a:solidFill>
+                <a:latin typeface="Calibri"/>
+              </a:rPr>
               <a:t>Recommended next steps</a:t>
             </a:r>
           </a:p>
@@ -5735,7 +6135,7 @@
                 </a:solidFill>
                 <a:latin typeface="Calibri"/>
               </a:rPr>
-              <a:t>16</a:t>
+              <a:t>17</a:t>
             </a:r>
           </a:p>
         </p:txBody>

</xml_diff>

<commit_message>
Deck: fold in G11/G12 and decisions Q-T/Q-U
Adds environment-conditions (G11/Q-T) and formation-geometry (G12/Q-U) from the
concept-coverage re-sync to the sourcing slide, decisions (3/3), and the
proposed-fixes list. 19 slides, 0 off-slide.

Co-Authored-By: Claude Opus 4.8 (1M context) <noreply@anthropic.com>
</commit_message>
<xml_diff>
--- a/Subgroups/ASX/InstantiationReview/ASX-Instantiation-Findings.pptx
+++ b/Subgroups/ASX/InstantiationReview/ASX-Instantiation-Findings.pptx
@@ -5048,7 +5048,7 @@
                 </a:solidFill>
                 <a:latin typeface="Calibri"/>
               </a:rPr>
-              <a:t>Explore/Search-Area order (G2); denied-comms operation + deployable relay (G1); decoy behavior (G8); maritime cross-cue with a shared track (G3).</a:t>
+              <a:t>Explore/Search-Area order (G2); denied-comms + relay (G1); decoy (G8); maritime cross-cue with a shared track (G3); environment conditions (G11); formation geometry (G12).</a:t>
             </a:r>
           </a:p>
           <a:p>
@@ -5982,7 +5982,7 @@
         </p:nvSpPr>
         <p:spPr>
           <a:xfrm>
-            <a:off x="640080" y="1554480"/>
+            <a:off x="640080" y="1463040"/>
             <a:ext cx="10972800" cy="4754880"/>
           </a:xfrm>
           <a:prstGeom prst="rect">
@@ -6001,11 +6001,11 @@
                 <a:spcPts val="200"/>
               </a:spcBef>
               <a:spcAft>
-                <a:spcPts val="1100"/>
+                <a:spcPts val="800"/>
               </a:spcAft>
             </a:pPr>
             <a:r>
-              <a:rPr sz="1500" b="1" i="0">
+              <a:rPr sz="1350" b="1" i="0">
                 <a:solidFill>
                   <a:srgbClr val="2E869A"/>
                 </a:solidFill>
@@ -6014,7 +6014,7 @@
               <a:t>Q-N  </a:t>
             </a:r>
             <a:r>
-              <a:rPr sz="1500" b="0" i="0">
+              <a:rPr sz="1350" b="0" i="0">
                 <a:solidFill>
                   <a:srgbClr val="333333"/>
                 </a:solidFill>
@@ -6029,11 +6029,11 @@
                 <a:spcPts val="200"/>
               </a:spcBef>
               <a:spcAft>
-                <a:spcPts val="1100"/>
+                <a:spcPts val="800"/>
               </a:spcAft>
             </a:pPr>
             <a:r>
-              <a:rPr sz="1500" b="1" i="0">
+              <a:rPr sz="1350" b="1" i="0">
                 <a:solidFill>
                   <a:srgbClr val="2E869A"/>
                 </a:solidFill>
@@ -6042,7 +6042,7 @@
               <a:t>Q-O  </a:t>
             </a:r>
             <a:r>
-              <a:rPr sz="1500" b="0" i="0">
+              <a:rPr sz="1350" b="0" i="0">
                 <a:solidFill>
                   <a:srgbClr val="333333"/>
                 </a:solidFill>
@@ -6057,11 +6057,11 @@
                 <a:spcPts val="200"/>
               </a:spcBef>
               <a:spcAft>
-                <a:spcPts val="1100"/>
+                <a:spcPts val="800"/>
               </a:spcAft>
             </a:pPr>
             <a:r>
-              <a:rPr sz="1500" b="1" i="0">
+              <a:rPr sz="1350" b="1" i="0">
                 <a:solidFill>
                   <a:srgbClr val="2E869A"/>
                 </a:solidFill>
@@ -6070,7 +6070,7 @@
               <a:t>Q-P  </a:t>
             </a:r>
             <a:r>
-              <a:rPr sz="1500" b="0" i="0">
+              <a:rPr sz="1350" b="0" i="0">
                 <a:solidFill>
                   <a:srgbClr val="333333"/>
                 </a:solidFill>
@@ -6085,11 +6085,11 @@
                 <a:spcPts val="200"/>
               </a:spcBef>
               <a:spcAft>
-                <a:spcPts val="1100"/>
+                <a:spcPts val="800"/>
               </a:spcAft>
             </a:pPr>
             <a:r>
-              <a:rPr sz="1500" b="1" i="0">
+              <a:rPr sz="1350" b="1" i="0">
                 <a:solidFill>
                   <a:srgbClr val="2E869A"/>
                 </a:solidFill>
@@ -6098,7 +6098,7 @@
               <a:t>Q-Q  </a:t>
             </a:r>
             <a:r>
-              <a:rPr sz="1500" b="0" i="0">
+              <a:rPr sz="1350" b="0" i="0">
                 <a:solidFill>
                   <a:srgbClr val="333333"/>
                 </a:solidFill>
@@ -6113,11 +6113,11 @@
                 <a:spcPts val="200"/>
               </a:spcBef>
               <a:spcAft>
-                <a:spcPts val="1100"/>
+                <a:spcPts val="800"/>
               </a:spcAft>
             </a:pPr>
             <a:r>
-              <a:rPr sz="1500" b="1" i="0">
+              <a:rPr sz="1350" b="1" i="0">
                 <a:solidFill>
                   <a:srgbClr val="2E869A"/>
                 </a:solidFill>
@@ -6126,7 +6126,7 @@
               <a:t>Q-R  </a:t>
             </a:r>
             <a:r>
-              <a:rPr sz="1500" b="0" i="0">
+              <a:rPr sz="1350" b="0" i="0">
                 <a:solidFill>
                   <a:srgbClr val="333333"/>
                 </a:solidFill>
@@ -6141,11 +6141,11 @@
                 <a:spcPts val="200"/>
               </a:spcBef>
               <a:spcAft>
-                <a:spcPts val="1100"/>
+                <a:spcPts val="800"/>
               </a:spcAft>
             </a:pPr>
             <a:r>
-              <a:rPr sz="1500" b="1" i="0">
+              <a:rPr sz="1350" b="1" i="0">
                 <a:solidFill>
                   <a:srgbClr val="2E869A"/>
                 </a:solidFill>
@@ -6154,13 +6154,69 @@
               <a:t>Q-S  </a:t>
             </a:r>
             <a:r>
-              <a:rPr sz="1500" b="0" i="0">
+              <a:rPr sz="1350" b="0" i="0">
                 <a:solidFill>
                   <a:srgbClr val="333333"/>
                 </a:solidFill>
                 <a:latin typeface="Calibri"/>
               </a:rPr>
               <a:t>Decoy/deception behavior + threat-aware order annotations.</a:t>
+            </a:r>
+          </a:p>
+          <a:p>
+            <a:pPr>
+              <a:spcBef>
+                <a:spcPts val="200"/>
+              </a:spcBef>
+              <a:spcAft>
+                <a:spcPts val="800"/>
+              </a:spcAft>
+            </a:pPr>
+            <a:r>
+              <a:rPr sz="1350" b="1" i="0">
+                <a:solidFill>
+                  <a:srgbClr val="2E869A"/>
+                </a:solidFill>
+                <a:latin typeface="Calibri"/>
+              </a:rPr>
+              <a:t>Q-T  </a:t>
+            </a:r>
+            <a:r>
+              <a:rPr sz="1350" b="0" i="0">
+                <a:solidFill>
+                  <a:srgbClr val="333333"/>
+                </a:solidFill>
+                <a:latin typeface="Calibri"/>
+              </a:rPr>
+              <a:t>Operating-environment condition attributes (GPS-denied, illumination, sea-state, terrain).</a:t>
+            </a:r>
+          </a:p>
+          <a:p>
+            <a:pPr>
+              <a:spcBef>
+                <a:spcPts val="200"/>
+              </a:spcBef>
+              <a:spcAft>
+                <a:spcPts val="800"/>
+              </a:spcAft>
+            </a:pPr>
+            <a:r>
+              <a:rPr sz="1350" b="1" i="0">
+                <a:solidFill>
+                  <a:srgbClr val="2E869A"/>
+                </a:solidFill>
+                <a:latin typeface="Calibri"/>
+              </a:rPr>
+              <a:t>Q-U  </a:t>
+            </a:r>
+            <a:r>
+              <a:rPr sz="1350" b="0" i="0">
+                <a:solidFill>
+                  <a:srgbClr val="333333"/>
+                </a:solidFill>
+                <a:latin typeface="Calibri"/>
+              </a:rPr>
+              <a:t>Formation / relative-geometry construct (orbit, convoy spacing) beyond single RelativeLocation.</a:t>
             </a:r>
           </a:p>
         </p:txBody>
@@ -6465,7 +6521,7 @@
                 </a:solidFill>
                 <a:latin typeface="Calibri"/>
               </a:rPr>
-              <a:t>inline entity def (Q-E), MediaReference (Q-F), robot-to-robot + cross-cue (Q-G/Q-P), rationale report (Q-H), generic detection report (Q-I/Q-Q), swarm residuals (Q-J), engagement authority (Q-K), task verbs + payload (Q-L), area subject (Q-M), explore order (Q-N), denied-comms/relay (Q-O), locomotion subtypes (Q-R), decoy/threat-aware (Q-S).</a:t>
+              <a:t>inline entity def (Q-E), MediaReference (Q-F), robot-to-robot + cross-cue (Q-G/Q-P), rationale report (Q-H), generic detection report (Q-I/Q-Q), swarm residuals (Q-J), engagement authority (Q-K), task verbs + payload (Q-L), area subject (Q-M), explore order (Q-N), denied-comms/relay (Q-O), locomotion subtypes (Q-R), decoy/threat-aware (Q-S), environment conditions (Q-T), formation geometry (Q-U).</a:t>
             </a:r>
           </a:p>
           <a:p>

</xml_diff>

<commit_message>
Integrate scavenger's 9 sourced missions: validation evidence + BML prior art
Consumes the scavenger session's nine sourced+extracted missions
(Documents-Found.md / V2Extractions). Moves the validation holes to evidenced
(explainability, CBRN, EW, persistence each now have a real mission) and
captures concrete report schemas to adopt.

Key result: the measurement/detection report flagged as missing (Y5/Q-Q) is
prior art in C2SIM's BML lineage - Remmersmann's WhoMeasuredType {value, UOM,
phenomenon, sensor, time, place} - so Q-Q should re-adopt, not invent; Q-F
aligns to BML ResourceType; Q-H gets the Agrawal {event, action, reasoning,
confidence} schema. New finding G13 (capability self-report / WhoHoldingType),
decision Q-V. Two tabs: Hazard Area Map Report, MUM-T High-Level Tasking.

Log 6j + C8; deck 20 slides (validation-evidence slide), 0 off-slide.

Co-Authored-By: Claude Opus 4.8 (1M context) <noreply@anthropic.com>
</commit_message>
<xml_diff>
--- a/Subgroups/ASX/InstantiationReview/ASX-Instantiation-Findings.pptx
+++ b/Subgroups/ASX/InstantiationReview/ASX-Instantiation-Findings.pptx
@@ -24,6 +24,7 @@
     <p:sldId id="272" r:id="rId23"/>
     <p:sldId id="273" r:id="rId24"/>
     <p:sldId id="274" r:id="rId25"/>
+    <p:sldId id="275" r:id="rId26"/>
   </p:sldIdLst>
   <p:sldSz cx="12191695" cy="6858000" type="screen4x3"/>
   <p:notesSz cx="6858000" cy="9144000"/>
@@ -5231,7 +5232,7 @@
                 </a:solidFill>
                 <a:latin typeface="Calibri"/>
               </a:rPr>
-              <a:t>Decisions (1/2): model structure</a:t>
+              <a:t>Validation: the gaps are now evidenced</a:t>
             </a:r>
           </a:p>
         </p:txBody>
@@ -5244,8 +5245,42 @@
         </p:nvSpPr>
         <p:spPr>
           <a:xfrm>
-            <a:off x="640080" y="1737360"/>
-            <a:ext cx="10972800" cy="4617720"/>
+            <a:off x="548640" y="914400"/>
+            <a:ext cx="10972800" cy="320040"/>
+          </a:xfrm>
+          <a:prstGeom prst="rect">
+            <a:avLst/>
+          </a:prstGeom>
+          <a:noFill/>
+        </p:spPr>
+        <p:txBody>
+          <a:bodyPr wrap="square">
+            <a:spAutoFit/>
+          </a:bodyPr>
+          <a:lstStyle/>
+          <a:p>
+            <a:r>
+              <a:rPr sz="1300" b="0" i="1">
+                <a:solidFill>
+                  <a:srgbClr val="2E869A"/>
+                </a:solidFill>
+                <a:latin typeface="Calibri"/>
+              </a:rPr>
+              <a:t>Nine sourced missions closed the document holes</a:t>
+            </a:r>
+          </a:p>
+        </p:txBody>
+      </p:sp>
+      <p:sp>
+        <p:nvSpPr>
+          <p:cNvPr id="5" name="TextBox 4"/>
+          <p:cNvSpPr txBox="1"/>
+          <p:nvPr/>
+        </p:nvSpPr>
+        <p:spPr>
+          <a:xfrm>
+            <a:off x="640080" y="1600200"/>
+            <a:ext cx="10972800" cy="4754880"/>
           </a:xfrm>
           <a:prstGeom prst="rect">
             <a:avLst/>
@@ -5263,26 +5298,26 @@
                 <a:spcPts val="200"/>
               </a:spcBef>
               <a:spcAft>
-                <a:spcPts val="1800"/>
+                <a:spcPts val="1200"/>
               </a:spcAft>
             </a:pPr>
             <a:r>
-              <a:rPr sz="1800" b="1" i="0">
-                <a:solidFill>
-                  <a:srgbClr val="2E869A"/>
-                </a:solidFill>
-                <a:latin typeface="Calibri"/>
-              </a:rPr>
-              <a:t>Q-A  </a:t>
-            </a:r>
-            <a:r>
-              <a:rPr sz="1800" b="0" i="0">
+              <a:rPr sz="1450" b="1" i="0">
+                <a:solidFill>
+                  <a:srgbClr val="2E7D32"/>
+                </a:solidFill>
+                <a:latin typeface="Calibri"/>
+              </a:rPr>
+              <a:t>Now grounded by a real mission:  </a:t>
+            </a:r>
+            <a:r>
+              <a:rPr sz="1450" b="0" i="0">
                 <a:solidFill>
                   <a:srgbClr val="333333"/>
                 </a:solidFill>
                 <a:latin typeface="Calibri"/>
               </a:rPr>
-              <a:t>UAV/robot typing: a role on the existing Platform tree, or a parallel Robot tree?</a:t>
+              <a:t>explainability (Agrawal DroneResponse), CBRN (UGV-CBRN), EW (UAV emitter geolocation), persistence (MDARS) - all previously asserted-but-untested.</a:t>
             </a:r>
           </a:p>
           <a:p>
@@ -5291,26 +5326,26 @@
                 <a:spcPts val="200"/>
               </a:spcBef>
               <a:spcAft>
-                <a:spcPts val="1800"/>
+                <a:spcPts val="1200"/>
               </a:spcAft>
             </a:pPr>
             <a:r>
-              <a:rPr sz="1800" b="1" i="0">
+              <a:rPr sz="1450" b="1" i="0">
                 <a:solidFill>
                   <a:srgbClr val="2E869A"/>
                 </a:solidFill>
                 <a:latin typeface="Calibri"/>
               </a:rPr>
-              <a:t>Q-B  </a:t>
-            </a:r>
-            <a:r>
-              <a:rPr sz="1800" b="0" i="0">
+              <a:t>Prior art, not invention (Q-Q):  </a:t>
+            </a:r>
+            <a:r>
+              <a:rPr sz="1450" b="0" i="0">
                 <a:solidFill>
                   <a:srgbClr val="333333"/>
                 </a:solidFill>
                 <a:latin typeface="Calibri"/>
               </a:rPr>
-              <a:t>Swarm: derive from CollectiveEntity (ActorEntity) so it can be tasked.</a:t>
+              <a:t>the measurement report flagged as missing already existed in C2SIM's BML lineage - WhoMeasuredType {value, unit, phenomenon, sensor, time, place}. Re-adopt it.</a:t>
             </a:r>
           </a:p>
           <a:p>
@@ -5319,26 +5354,26 @@
                 <a:spcPts val="200"/>
               </a:spcBef>
               <a:spcAft>
-                <a:spcPts val="1800"/>
+                <a:spcPts val="1200"/>
               </a:spcAft>
             </a:pPr>
             <a:r>
-              <a:rPr sz="1800" b="1" i="0">
-                <a:solidFill>
-                  <a:srgbClr val="2E869A"/>
-                </a:solidFill>
-                <a:latin typeface="Calibri"/>
-              </a:rPr>
-              <a:t>Q-C  </a:t>
-            </a:r>
-            <a:r>
-              <a:rPr sz="1800" b="0" i="0">
+              <a:rPr sz="1450" b="1" i="0">
+                <a:solidFill>
+                  <a:srgbClr val="C87F0A"/>
+                </a:solidFill>
+                <a:latin typeface="Calibri"/>
+              </a:rPr>
+              <a:t>Concrete schemas:  </a:t>
+            </a:r>
+            <a:r>
+              <a:rPr sz="1450" b="0" i="0">
                 <a:solidFill>
                   <a:srgbClr val="333333"/>
                 </a:solidFill>
                 <a:latin typeface="Calibri"/>
               </a:rPr>
-              <a:t>Sensor: entity, class, or attribute - choose one model and apply it everywhere.</a:t>
+              <a:t>explanation report {event, action, reasoning, confidence} (Q-H); area map w/ per-cell value+variance (Q-M/Q-Q); on-the-loop verbs configure/suspend/ack/override (Q-K).</a:t>
             </a:r>
           </a:p>
           <a:p>
@@ -5347,33 +5382,24 @@
                 <a:spcPts val="200"/>
               </a:spcBef>
               <a:spcAft>
-                <a:spcPts val="1800"/>
+                <a:spcPts val="1200"/>
               </a:spcAft>
             </a:pPr>
             <a:r>
-              <a:rPr sz="1800" b="1" i="0">
-                <a:solidFill>
-                  <a:srgbClr val="2E869A"/>
-                </a:solidFill>
-                <a:latin typeface="Calibri"/>
-              </a:rPr>
-              <a:t>Q-D  </a:t>
-            </a:r>
-            <a:r>
-              <a:rPr sz="1800" b="0" i="0">
-                <a:solidFill>
-                  <a:srgbClr val="333333"/>
-                </a:solidFill>
-                <a:latin typeface="Calibri"/>
-              </a:rPr>
-              <a:t>Autonomy: choose one normative vocabulary.</a:t>
-            </a:r>
-          </a:p>
-        </p:txBody>
-      </p:sp>
-      <p:sp>
-        <p:nvSpPr>
-          <p:cNvPr id="5" name="TextBox 4"/>
+              <a:rPr sz="1450" b="0" i="0">
+                <a:solidFill>
+                  <a:srgbClr val="666666"/>
+                </a:solidFill>
+                <a:latin typeface="Calibri"/>
+              </a:rPr>
+              <a:t>New: capability self-report (G13/Q-V) and collective-task decomposition + report aggregation (Z1), from BML MUM-T tasking.</a:t>
+            </a:r>
+          </a:p>
+        </p:txBody>
+      </p:sp>
+      <p:sp>
+        <p:nvSpPr>
+          <p:cNvPr id="6" name="TextBox 5"/>
           <p:cNvSpPr txBox="1"/>
           <p:nvPr/>
         </p:nvSpPr>
@@ -5407,7 +5433,7 @@
       </p:sp>
       <p:sp>
         <p:nvSpPr>
-          <p:cNvPr id="6" name="TextBox 5"/>
+          <p:cNvPr id="7" name="TextBox 6"/>
           <p:cNvSpPr txBox="1"/>
           <p:nvPr/>
         </p:nvSpPr>
@@ -5530,7 +5556,7 @@
                 </a:solidFill>
                 <a:latin typeface="Calibri"/>
               </a:rPr>
-              <a:t>Decisions (2/3): new content types needed</a:t>
+              <a:t>Decisions (1/2): model structure</a:t>
             </a:r>
           </a:p>
         </p:txBody>
@@ -5543,8 +5569,8 @@
         </p:nvSpPr>
         <p:spPr>
           <a:xfrm>
-            <a:off x="640080" y="1463040"/>
-            <a:ext cx="10972800" cy="4754880"/>
+            <a:off x="640080" y="1737360"/>
+            <a:ext cx="10972800" cy="4617720"/>
           </a:xfrm>
           <a:prstGeom prst="rect">
             <a:avLst/>
@@ -5562,26 +5588,26 @@
                 <a:spcPts val="200"/>
               </a:spcBef>
               <a:spcAft>
-                <a:spcPts val="800"/>
+                <a:spcPts val="1800"/>
               </a:spcAft>
             </a:pPr>
             <a:r>
-              <a:rPr sz="1350" b="1" i="0">
+              <a:rPr sz="1800" b="1" i="0">
                 <a:solidFill>
                   <a:srgbClr val="2E869A"/>
                 </a:solidFill>
                 <a:latin typeface="Calibri"/>
               </a:rPr>
-              <a:t>Q-E  </a:t>
-            </a:r>
-            <a:r>
-              <a:rPr sz="1350" b="0" i="0">
+              <a:t>Q-A  </a:t>
+            </a:r>
+            <a:r>
+              <a:rPr sz="1800" b="0" i="0">
                 <a:solidFill>
                   <a:srgbClr val="333333"/>
                 </a:solidFill>
                 <a:latin typeface="Calibri"/>
               </a:rPr>
-              <a:t>Inline entity definition for newly-observed entities in reports.</a:t>
+              <a:t>UAV/robot typing: a role on the existing Platform tree, or a parallel Robot tree?</a:t>
             </a:r>
           </a:p>
           <a:p>
@@ -5590,26 +5616,26 @@
                 <a:spcPts val="200"/>
               </a:spcBef>
               <a:spcAft>
-                <a:spcPts val="800"/>
+                <a:spcPts val="1800"/>
               </a:spcAft>
             </a:pPr>
             <a:r>
-              <a:rPr sz="1350" b="1" i="0">
+              <a:rPr sz="1800" b="1" i="0">
                 <a:solidFill>
                   <a:srgbClr val="2E869A"/>
                 </a:solidFill>
                 <a:latin typeface="Calibri"/>
               </a:rPr>
-              <a:t>Q-F  </a:t>
-            </a:r>
-            <a:r>
-              <a:rPr sz="1350" b="0" i="0">
+              <a:t>Q-B  </a:t>
+            </a:r>
+            <a:r>
+              <a:rPr sz="1800" b="0" i="0">
                 <a:solidFill>
                   <a:srgbClr val="333333"/>
                 </a:solidFill>
                 <a:latin typeface="Calibri"/>
               </a:rPr>
-              <a:t>MediaReference identity; separate media-format from sensor-modality.</a:t>
+              <a:t>Swarm: derive from CollectiveEntity (ActorEntity) so it can be tasked.</a:t>
             </a:r>
           </a:p>
           <a:p>
@@ -5618,26 +5644,26 @@
                 <a:spcPts val="200"/>
               </a:spcBef>
               <a:spcAft>
-                <a:spcPts val="800"/>
+                <a:spcPts val="1800"/>
               </a:spcAft>
             </a:pPr>
             <a:r>
-              <a:rPr sz="1350" b="1" i="0">
+              <a:rPr sz="1800" b="1" i="0">
                 <a:solidFill>
                   <a:srgbClr val="2E869A"/>
                 </a:solidFill>
                 <a:latin typeface="Calibri"/>
               </a:rPr>
-              <a:t>Q-G  </a:t>
-            </a:r>
-            <a:r>
-              <a:rPr sz="1350" b="0" i="0">
+              <a:t>Q-C  </a:t>
+            </a:r>
+            <a:r>
+              <a:rPr sz="1800" b="0" i="0">
                 <a:solidFill>
                   <a:srgbClr val="333333"/>
                 </a:solidFill>
                 <a:latin typeface="Calibri"/>
               </a:rPr>
-              <a:t>Robot-to-robot coordination content type + issuing authority (CASEVAC).</a:t>
+              <a:t>Sensor: entity, class, or attribute - choose one model and apply it everywhere.</a:t>
             </a:r>
           </a:p>
           <a:p>
@@ -5646,166 +5672,26 @@
                 <a:spcPts val="200"/>
               </a:spcBef>
               <a:spcAft>
-                <a:spcPts val="800"/>
+                <a:spcPts val="1800"/>
               </a:spcAft>
             </a:pPr>
             <a:r>
-              <a:rPr sz="1350" b="1" i="0">
+              <a:rPr sz="1800" b="1" i="0">
                 <a:solidFill>
                   <a:srgbClr val="2E869A"/>
                 </a:solidFill>
                 <a:latin typeface="Calibri"/>
               </a:rPr>
-              <a:t>Q-H  </a:t>
-            </a:r>
-            <a:r>
-              <a:rPr sz="1350" b="0" i="0">
+              <a:t>Q-D  </a:t>
+            </a:r>
+            <a:r>
+              <a:rPr sz="1800" b="0" i="0">
                 <a:solidFill>
                   <a:srgbClr val="333333"/>
                 </a:solidFill>
                 <a:latin typeface="Calibri"/>
               </a:rPr>
-              <a:t>Rationale/explanation ReportContent - report why, not just what (CASEVAC).</a:t>
-            </a:r>
-          </a:p>
-          <a:p>
-            <a:pPr>
-              <a:spcBef>
-                <a:spcPts val="200"/>
-              </a:spcBef>
-              <a:spcAft>
-                <a:spcPts val="800"/>
-              </a:spcAft>
-            </a:pPr>
-            <a:r>
-              <a:rPr sz="1350" b="1" i="0">
-                <a:solidFill>
-                  <a:srgbClr val="2E869A"/>
-                </a:solidFill>
-                <a:latin typeface="Calibri"/>
-              </a:rPr>
-              <a:t>Q-I  </a:t>
-            </a:r>
-            <a:r>
-              <a:rPr sz="1350" b="0" i="0">
-                <a:solidFill>
-                  <a:srgbClr val="333333"/>
-                </a:solidFill>
-                <a:latin typeface="Calibri"/>
-              </a:rPr>
-              <a:t>Media-independent sensor-reading (value+unit+modality) + full SensorType taxonomy.</a:t>
-            </a:r>
-          </a:p>
-          <a:p>
-            <a:pPr>
-              <a:spcBef>
-                <a:spcPts val="200"/>
-              </a:spcBef>
-              <a:spcAft>
-                <a:spcPts val="800"/>
-              </a:spcAft>
-            </a:pPr>
-            <a:r>
-              <a:rPr sz="1350" b="1" i="0">
-                <a:solidFill>
-                  <a:srgbClr val="2E869A"/>
-                </a:solidFill>
-                <a:latin typeface="Calibri"/>
-              </a:rPr>
-              <a:t>Q-J  </a:t>
-            </a:r>
-            <a:r>
-              <a:rPr sz="1350" b="0" i="0">
-                <a:solidFill>
-                  <a:srgbClr val="333333"/>
-                </a:solidFill>
-                <a:latin typeface="Calibri"/>
-              </a:rPr>
-              <a:t>Swarm residuals: network params, leader role, aggregation, member lifecycle.</a:t>
-            </a:r>
-          </a:p>
-          <a:p>
-            <a:pPr>
-              <a:spcBef>
-                <a:spcPts val="200"/>
-              </a:spcBef>
-              <a:spcAft>
-                <a:spcPts val="800"/>
-              </a:spcAft>
-            </a:pPr>
-            <a:r>
-              <a:rPr sz="1350" b="1" i="0">
-                <a:solidFill>
-                  <a:srgbClr val="2E869A"/>
-                </a:solidFill>
-                <a:latin typeface="Calibri"/>
-              </a:rPr>
-              <a:t>Q-K  </a:t>
-            </a:r>
-            <a:r>
-              <a:rPr sz="1350" b="0" i="0">
-                <a:solidFill>
-                  <a:srgbClr val="333333"/>
-                </a:solidFill>
-                <a:latin typeface="Calibri"/>
-              </a:rPr>
-              <a:t>Engagement authority as a function of autonomy level (Fire Support).</a:t>
-            </a:r>
-          </a:p>
-          <a:p>
-            <a:pPr>
-              <a:spcBef>
-                <a:spcPts val="200"/>
-              </a:spcBef>
-              <a:spcAft>
-                <a:spcPts val="800"/>
-              </a:spcAft>
-            </a:pPr>
-            <a:r>
-              <a:rPr sz="1350" b="1" i="0">
-                <a:solidFill>
-                  <a:srgbClr val="2E869A"/>
-                </a:solidFill>
-                <a:latin typeface="Calibri"/>
-              </a:rPr>
-              <a:t>Q-L  </a:t>
-            </a:r>
-            <a:r>
-              <a:rPr sz="1350" b="0" i="0">
-                <a:solidFill>
-                  <a:srgbClr val="333333"/>
-                </a:solidFill>
-                <a:latin typeface="Calibri"/>
-              </a:rPr>
-              <a:t>Task-verb vocabulary (deliver, manipulate, recover) + typed payload/effector/weapon.</a:t>
-            </a:r>
-          </a:p>
-          <a:p>
-            <a:pPr>
-              <a:spcBef>
-                <a:spcPts val="200"/>
-              </a:spcBef>
-              <a:spcAft>
-                <a:spcPts val="800"/>
-              </a:spcAft>
-            </a:pPr>
-            <a:r>
-              <a:rPr sz="1350" b="1" i="0">
-                <a:solidFill>
-                  <a:srgbClr val="2E869A"/>
-                </a:solidFill>
-                <a:latin typeface="Calibri"/>
-              </a:rPr>
-              <a:t>Q-M  </a:t>
-            </a:r>
-            <a:r>
-              <a:rPr sz="1350" b="0" i="0">
-                <a:solidFill>
-                  <a:srgbClr val="333333"/>
-                </a:solidFill>
-                <a:latin typeface="Calibri"/>
-              </a:rPr>
-              <a:t>Let an area be the subject of a task/report (hasAffectedArea + area-state).</a:t>
+              <a:t>Autonomy: choose one normative vocabulary.</a:t>
             </a:r>
           </a:p>
         </p:txBody>
@@ -5969,7 +5855,7 @@
                 </a:solidFill>
                 <a:latin typeface="Calibri"/>
               </a:rPr>
-              <a:t>Decisions (3/3): from the sourced scenarios</a:t>
+              <a:t>Decisions (2/3): new content types needed</a:t>
             </a:r>
           </a:p>
         </p:txBody>
@@ -6011,7 +5897,7 @@
                 </a:solidFill>
                 <a:latin typeface="Calibri"/>
               </a:rPr>
-              <a:t>Q-N  </a:t>
+              <a:t>Q-E  </a:t>
             </a:r>
             <a:r>
               <a:rPr sz="1350" b="0" i="0">
@@ -6020,7 +5906,7 @@
                 </a:solidFill>
                 <a:latin typeface="Calibri"/>
               </a:rPr>
-              <a:t>Explore / Search-Area order with a coverage goal (distinct from Patrol).</a:t>
+              <a:t>Inline entity definition for newly-observed entities in reports.</a:t>
             </a:r>
           </a:p>
           <a:p>
@@ -6039,7 +5925,7 @@
                 </a:solidFill>
                 <a:latin typeface="Calibri"/>
               </a:rPr>
-              <a:t>Q-O  </a:t>
+              <a:t>Q-F  </a:t>
             </a:r>
             <a:r>
               <a:rPr sz="1350" b="0" i="0">
@@ -6048,7 +5934,7 @@
                 </a:solidFill>
                 <a:latin typeface="Calibri"/>
               </a:rPr>
-              <a:t>Denied-comms operating mode + deployable comms-relay entity/behavior.</a:t>
+              <a:t>MediaReference identity; separate media-format from sensor-modality.</a:t>
             </a:r>
           </a:p>
           <a:p>
@@ -6067,7 +5953,7 @@
                 </a:solidFill>
                 <a:latin typeface="Calibri"/>
               </a:rPr>
-              <a:t>Q-P  </a:t>
+              <a:t>Q-G  </a:t>
             </a:r>
             <a:r>
               <a:rPr sz="1350" b="0" i="0">
@@ -6076,7 +5962,7 @@
                 </a:solidFill>
                 <a:latin typeface="Calibri"/>
               </a:rPr>
-              <a:t>Cross-cueing: system-to-system tasking + shared classified track/contact (extends Q-G).</a:t>
+              <a:t>Robot-to-robot coordination content type + issuing authority (CASEVAC).</a:t>
             </a:r>
           </a:p>
           <a:p>
@@ -6095,7 +5981,7 @@
                 </a:solidFill>
                 <a:latin typeface="Calibri"/>
               </a:rPr>
-              <a:t>Q-Q  </a:t>
+              <a:t>Q-H  </a:t>
             </a:r>
             <a:r>
               <a:rPr sz="1350" b="0" i="0">
@@ -6104,7 +5990,7 @@
                 </a:solidFill>
                 <a:latin typeface="Calibri"/>
               </a:rPr>
-              <a:t>One generic Detection Report (confidence + error-bound + false-positive) - resolves the Y-series (extends Q-I).</a:t>
+              <a:t>Rationale/explanation ReportContent - report why, not just what (CASEVAC).</a:t>
             </a:r>
           </a:p>
           <a:p>
@@ -6123,7 +6009,7 @@
                 </a:solidFill>
                 <a:latin typeface="Calibri"/>
               </a:rPr>
-              <a:t>Q-R  </a:t>
+              <a:t>Q-I  </a:t>
             </a:r>
             <a:r>
               <a:rPr sz="1350" b="0" i="0">
@@ -6132,7 +6018,7 @@
                 </a:solidFill>
                 <a:latin typeface="Calibri"/>
               </a:rPr>
-              <a:t>Platform locomotion/role subtypes: wheeled/tracked/legged UGV; detector/neutralizer USV (extends Q-A).</a:t>
+              <a:t>Media-independent sensor-reading (value+unit+modality) + full SensorType taxonomy.</a:t>
             </a:r>
           </a:p>
           <a:p>
@@ -6151,7 +6037,7 @@
                 </a:solidFill>
                 <a:latin typeface="Calibri"/>
               </a:rPr>
-              <a:t>Q-S  </a:t>
+              <a:t>Q-J  </a:t>
             </a:r>
             <a:r>
               <a:rPr sz="1350" b="0" i="0">
@@ -6160,7 +6046,7 @@
                 </a:solidFill>
                 <a:latin typeface="Calibri"/>
               </a:rPr>
-              <a:t>Decoy/deception behavior + threat-aware order annotations.</a:t>
+              <a:t>Swarm residuals: network params, leader role, aggregation, member lifecycle.</a:t>
             </a:r>
           </a:p>
           <a:p>
@@ -6179,7 +6065,7 @@
                 </a:solidFill>
                 <a:latin typeface="Calibri"/>
               </a:rPr>
-              <a:t>Q-T  </a:t>
+              <a:t>Q-K  </a:t>
             </a:r>
             <a:r>
               <a:rPr sz="1350" b="0" i="0">
@@ -6188,7 +6074,7 @@
                 </a:solidFill>
                 <a:latin typeface="Calibri"/>
               </a:rPr>
-              <a:t>Operating-environment condition attributes (GPS-denied, illumination, sea-state, terrain).</a:t>
+              <a:t>Engagement authority as a function of autonomy level (Fire Support).</a:t>
             </a:r>
           </a:p>
           <a:p>
@@ -6207,7 +6093,7 @@
                 </a:solidFill>
                 <a:latin typeface="Calibri"/>
               </a:rPr>
-              <a:t>Q-U  </a:t>
+              <a:t>Q-L  </a:t>
             </a:r>
             <a:r>
               <a:rPr sz="1350" b="0" i="0">
@@ -6216,7 +6102,35 @@
                 </a:solidFill>
                 <a:latin typeface="Calibri"/>
               </a:rPr>
-              <a:t>Formation / relative-geometry construct (orbit, convoy spacing) beyond single RelativeLocation.</a:t>
+              <a:t>Task-verb vocabulary (deliver, manipulate, recover) + typed payload/effector/weapon.</a:t>
+            </a:r>
+          </a:p>
+          <a:p>
+            <a:pPr>
+              <a:spcBef>
+                <a:spcPts val="200"/>
+              </a:spcBef>
+              <a:spcAft>
+                <a:spcPts val="800"/>
+              </a:spcAft>
+            </a:pPr>
+            <a:r>
+              <a:rPr sz="1350" b="1" i="0">
+                <a:solidFill>
+                  <a:srgbClr val="2E869A"/>
+                </a:solidFill>
+                <a:latin typeface="Calibri"/>
+              </a:rPr>
+              <a:t>Q-M  </a:t>
+            </a:r>
+            <a:r>
+              <a:rPr sz="1350" b="0" i="0">
+                <a:solidFill>
+                  <a:srgbClr val="333333"/>
+                </a:solidFill>
+                <a:latin typeface="Calibri"/>
+              </a:rPr>
+              <a:t>Let an area be the subject of a task/report (hasAffectedArea + area-state).</a:t>
             </a:r>
           </a:p>
         </p:txBody>
@@ -6380,7 +6294,7 @@
                 </a:solidFill>
                 <a:latin typeface="Calibri"/>
               </a:rPr>
-              <a:t>Proposed fixes</a:t>
+              <a:t>Decisions (3/3): from the sourced scenarios</a:t>
             </a:r>
           </a:p>
         </p:txBody>
@@ -6393,41 +6307,7 @@
         </p:nvSpPr>
         <p:spPr>
           <a:xfrm>
-            <a:off x="548640" y="914400"/>
-            <a:ext cx="10972800" cy="320040"/>
-          </a:xfrm>
-          <a:prstGeom prst="rect">
-            <a:avLst/>
-          </a:prstGeom>
-          <a:noFill/>
-        </p:spPr>
-        <p:txBody>
-          <a:bodyPr wrap="square">
-            <a:spAutoFit/>
-          </a:bodyPr>
-          <a:lstStyle/>
-          <a:p>
-            <a:r>
-              <a:rPr sz="1300" b="0" i="1">
-                <a:solidFill>
-                  <a:srgbClr val="2E869A"/>
-                </a:solidFill>
-                <a:latin typeface="Calibri"/>
-              </a:rPr>
-              <a:t>Pending group buy-in - nothing applied to the model</a:t>
-            </a:r>
-          </a:p>
-        </p:txBody>
-      </p:sp>
-      <p:sp>
-        <p:nvSpPr>
-          <p:cNvPr id="5" name="TextBox 4"/>
-          <p:cNvSpPr txBox="1"/>
-          <p:nvPr/>
-        </p:nvSpPr>
-        <p:spPr>
-          <a:xfrm>
-            <a:off x="640080" y="1554480"/>
+            <a:off x="640080" y="1417320"/>
             <a:ext cx="10972800" cy="4754880"/>
           </a:xfrm>
           <a:prstGeom prst="rect">
@@ -6446,26 +6326,26 @@
                 <a:spcPts val="200"/>
               </a:spcBef>
               <a:spcAft>
-                <a:spcPts val="1300"/>
+                <a:spcPts val="700"/>
               </a:spcAft>
             </a:pPr>
             <a:r>
-              <a:rPr sz="1400" b="1" i="0">
-                <a:solidFill>
-                  <a:srgbClr val="2E7D32"/>
-                </a:solidFill>
-                <a:latin typeface="Calibri"/>
-              </a:rPr>
-              <a:t>Safe corrections (unambiguous):  </a:t>
-            </a:r>
-            <a:r>
-              <a:rPr sz="1400" b="0" i="0">
+              <a:rPr sz="1300" b="1" i="0">
+                <a:solidFill>
+                  <a:srgbClr val="2E869A"/>
+                </a:solidFill>
+                <a:latin typeface="Calibri"/>
+              </a:rPr>
+              <a:t>Q-N  </a:t>
+            </a:r>
+            <a:r>
+              <a:rPr sz="1300" b="0" i="0">
                 <a:solidFill>
                   <a:srgbClr val="333333"/>
                 </a:solidFill>
                 <a:latin typeface="Calibri"/>
               </a:rPr>
-              <a:t>class typo CollecticeRoboticSystem -&gt; Collective (O1); versionInfo Extrension -&gt; Extension (O2); file CSIM_ASX -&gt; C2SIM_ASX (O3); hasStartTime UUIDBase -&gt; TimeInstant (M7); unify namespace label ASX / C2SIM_ASX (M8).</a:t>
+              <a:t>Explore / Search-Area order with a coverage goal (distinct from Patrol).</a:t>
             </a:r>
           </a:p>
           <a:p>
@@ -6474,26 +6354,26 @@
                 <a:spcPts val="200"/>
               </a:spcBef>
               <a:spcAft>
-                <a:spcPts val="1300"/>
+                <a:spcPts val="700"/>
               </a:spcAft>
             </a:pPr>
             <a:r>
-              <a:rPr sz="1400" b="1" i="0">
-                <a:solidFill>
-                  <a:srgbClr val="C87F0A"/>
-                </a:solidFill>
-                <a:latin typeface="Calibri"/>
-              </a:rPr>
-              <a:t>Structural (decide first):  </a:t>
-            </a:r>
-            <a:r>
-              <a:rPr sz="1400" b="0" i="0">
+              <a:rPr sz="1300" b="1" i="0">
+                <a:solidFill>
+                  <a:srgbClr val="2E869A"/>
+                </a:solidFill>
+                <a:latin typeface="Calibri"/>
+              </a:rPr>
+              <a:t>Q-O  </a:t>
+            </a:r>
+            <a:r>
+              <a:rPr sz="1300" b="0" i="0">
                 <a:solidFill>
                   <a:srgbClr val="333333"/>
                 </a:solidFill>
                 <a:latin typeface="Calibri"/>
               </a:rPr>
-              <a:t>UAV/robot typing (Q-A); Swarm -&gt; CollectiveEntity so it is taskable (Q-B); one sensor model (Q-C); one autonomy vocabulary (Q-D).</a:t>
+              <a:t>Denied-comms operating mode + deployable comms-relay entity/behavior.</a:t>
             </a:r>
           </a:p>
           <a:p>
@@ -6502,26 +6382,26 @@
                 <a:spcPts val="200"/>
               </a:spcBef>
               <a:spcAft>
-                <a:spcPts val="1300"/>
+                <a:spcPts val="700"/>
               </a:spcAft>
             </a:pPr>
             <a:r>
-              <a:rPr sz="1400" b="1" i="0">
+              <a:rPr sz="1300" b="1" i="0">
                 <a:solidFill>
                   <a:srgbClr val="2E869A"/>
                 </a:solidFill>
                 <a:latin typeface="Calibri"/>
               </a:rPr>
-              <a:t>New content (design):  </a:t>
-            </a:r>
-            <a:r>
-              <a:rPr sz="1400" b="0" i="0">
+              <a:t>Q-P  </a:t>
+            </a:r>
+            <a:r>
+              <a:rPr sz="1300" b="0" i="0">
                 <a:solidFill>
                   <a:srgbClr val="333333"/>
                 </a:solidFill>
                 <a:latin typeface="Calibri"/>
               </a:rPr>
-              <a:t>inline entity def (Q-E), MediaReference (Q-F), robot-to-robot + cross-cue (Q-G/Q-P), rationale report (Q-H), generic detection report (Q-I/Q-Q), swarm residuals (Q-J), engagement authority (Q-K), task verbs + payload (Q-L), area subject (Q-M), explore order (Q-N), denied-comms/relay (Q-O), locomotion subtypes (Q-R), decoy/threat-aware (Q-S), environment conditions (Q-T), formation geometry (Q-U).</a:t>
+              <a:t>Cross-cueing: system-to-system tasking + shared classified track/contact (extends Q-G).</a:t>
             </a:r>
           </a:p>
           <a:p>
@@ -6530,24 +6410,173 @@
                 <a:spcPts val="200"/>
               </a:spcBef>
               <a:spcAft>
-                <a:spcPts val="1300"/>
+                <a:spcPts val="700"/>
               </a:spcAft>
             </a:pPr>
             <a:r>
-              <a:rPr sz="1400" b="1" i="0">
+              <a:rPr sz="1300" b="1" i="0">
+                <a:solidFill>
+                  <a:srgbClr val="2E869A"/>
+                </a:solidFill>
+                <a:latin typeface="Calibri"/>
+              </a:rPr>
+              <a:t>Q-Q  </a:t>
+            </a:r>
+            <a:r>
+              <a:rPr sz="1300" b="0" i="0">
                 <a:solidFill>
                   <a:srgbClr val="333333"/>
                 </a:solidFill>
                 <a:latin typeface="Calibri"/>
               </a:rPr>
-              <a:t>Nothing here is applied to the model - all items are proposals for group buy-in.</a:t>
-            </a:r>
-          </a:p>
-        </p:txBody>
-      </p:sp>
-      <p:sp>
-        <p:nvSpPr>
-          <p:cNvPr id="6" name="TextBox 5"/>
+              <a:t>One generic Detection Report (confidence + error-bound + false-positive) - resolves the Y-series (extends Q-I).</a:t>
+            </a:r>
+          </a:p>
+          <a:p>
+            <a:pPr>
+              <a:spcBef>
+                <a:spcPts val="200"/>
+              </a:spcBef>
+              <a:spcAft>
+                <a:spcPts val="700"/>
+              </a:spcAft>
+            </a:pPr>
+            <a:r>
+              <a:rPr sz="1300" b="1" i="0">
+                <a:solidFill>
+                  <a:srgbClr val="2E869A"/>
+                </a:solidFill>
+                <a:latin typeface="Calibri"/>
+              </a:rPr>
+              <a:t>Q-R  </a:t>
+            </a:r>
+            <a:r>
+              <a:rPr sz="1300" b="0" i="0">
+                <a:solidFill>
+                  <a:srgbClr val="333333"/>
+                </a:solidFill>
+                <a:latin typeface="Calibri"/>
+              </a:rPr>
+              <a:t>Platform locomotion/role subtypes: wheeled/tracked/legged UGV; detector/neutralizer USV (extends Q-A).</a:t>
+            </a:r>
+          </a:p>
+          <a:p>
+            <a:pPr>
+              <a:spcBef>
+                <a:spcPts val="200"/>
+              </a:spcBef>
+              <a:spcAft>
+                <a:spcPts val="700"/>
+              </a:spcAft>
+            </a:pPr>
+            <a:r>
+              <a:rPr sz="1300" b="1" i="0">
+                <a:solidFill>
+                  <a:srgbClr val="2E869A"/>
+                </a:solidFill>
+                <a:latin typeface="Calibri"/>
+              </a:rPr>
+              <a:t>Q-S  </a:t>
+            </a:r>
+            <a:r>
+              <a:rPr sz="1300" b="0" i="0">
+                <a:solidFill>
+                  <a:srgbClr val="333333"/>
+                </a:solidFill>
+                <a:latin typeface="Calibri"/>
+              </a:rPr>
+              <a:t>Decoy/deception behavior + threat-aware order annotations.</a:t>
+            </a:r>
+          </a:p>
+          <a:p>
+            <a:pPr>
+              <a:spcBef>
+                <a:spcPts val="200"/>
+              </a:spcBef>
+              <a:spcAft>
+                <a:spcPts val="700"/>
+              </a:spcAft>
+            </a:pPr>
+            <a:r>
+              <a:rPr sz="1300" b="1" i="0">
+                <a:solidFill>
+                  <a:srgbClr val="2E869A"/>
+                </a:solidFill>
+                <a:latin typeface="Calibri"/>
+              </a:rPr>
+              <a:t>Q-T  </a:t>
+            </a:r>
+            <a:r>
+              <a:rPr sz="1300" b="0" i="0">
+                <a:solidFill>
+                  <a:srgbClr val="333333"/>
+                </a:solidFill>
+                <a:latin typeface="Calibri"/>
+              </a:rPr>
+              <a:t>Operating-environment condition attributes (GPS-denied, illumination, sea-state, terrain).</a:t>
+            </a:r>
+          </a:p>
+          <a:p>
+            <a:pPr>
+              <a:spcBef>
+                <a:spcPts val="200"/>
+              </a:spcBef>
+              <a:spcAft>
+                <a:spcPts val="700"/>
+              </a:spcAft>
+            </a:pPr>
+            <a:r>
+              <a:rPr sz="1300" b="1" i="0">
+                <a:solidFill>
+                  <a:srgbClr val="2E869A"/>
+                </a:solidFill>
+                <a:latin typeface="Calibri"/>
+              </a:rPr>
+              <a:t>Q-U  </a:t>
+            </a:r>
+            <a:r>
+              <a:rPr sz="1300" b="0" i="0">
+                <a:solidFill>
+                  <a:srgbClr val="333333"/>
+                </a:solidFill>
+                <a:latin typeface="Calibri"/>
+              </a:rPr>
+              <a:t>Formation / relative-geometry construct (orbit, convoy spacing) beyond single RelativeLocation.</a:t>
+            </a:r>
+          </a:p>
+          <a:p>
+            <a:pPr>
+              <a:spcBef>
+                <a:spcPts val="200"/>
+              </a:spcBef>
+              <a:spcAft>
+                <a:spcPts val="700"/>
+              </a:spcAft>
+            </a:pPr>
+            <a:r>
+              <a:rPr sz="1300" b="1" i="0">
+                <a:solidFill>
+                  <a:srgbClr val="2E869A"/>
+                </a:solidFill>
+                <a:latin typeface="Calibri"/>
+              </a:rPr>
+              <a:t>Q-V  </a:t>
+            </a:r>
+            <a:r>
+              <a:rPr sz="1300" b="0" i="0">
+                <a:solidFill>
+                  <a:srgbClr val="333333"/>
+                </a:solidFill>
+                <a:latin typeface="Calibri"/>
+              </a:rPr>
+              <a:t>Capability self-report (robot declares mounted equipment; assign by capability) - BML WhoHoldingType.</a:t>
+            </a:r>
+          </a:p>
+        </p:txBody>
+      </p:sp>
+      <p:sp>
+        <p:nvSpPr>
+          <p:cNvPr id="5" name="TextBox 4"/>
           <p:cNvSpPr txBox="1"/>
           <p:nvPr/>
         </p:nvSpPr>
@@ -6581,7 +6610,7 @@
       </p:sp>
       <p:sp>
         <p:nvSpPr>
-          <p:cNvPr id="7" name="TextBox 6"/>
+          <p:cNvPr id="6" name="TextBox 5"/>
           <p:cNvSpPr txBox="1"/>
           <p:nvPr/>
         </p:nvSpPr>
@@ -6704,7 +6733,7 @@
                 </a:solidFill>
                 <a:latin typeface="Calibri"/>
               </a:rPr>
-              <a:t>Recommended next steps</a:t>
+              <a:t>Proposed fixes</a:t>
             </a:r>
           </a:p>
         </p:txBody>
@@ -6717,8 +6746,42 @@
         </p:nvSpPr>
         <p:spPr>
           <a:xfrm>
-            <a:off x="640080" y="1645920"/>
-            <a:ext cx="10972800" cy="4709160"/>
+            <a:off x="548640" y="914400"/>
+            <a:ext cx="10972800" cy="320040"/>
+          </a:xfrm>
+          <a:prstGeom prst="rect">
+            <a:avLst/>
+          </a:prstGeom>
+          <a:noFill/>
+        </p:spPr>
+        <p:txBody>
+          <a:bodyPr wrap="square">
+            <a:spAutoFit/>
+          </a:bodyPr>
+          <a:lstStyle/>
+          <a:p>
+            <a:r>
+              <a:rPr sz="1300" b="0" i="1">
+                <a:solidFill>
+                  <a:srgbClr val="2E869A"/>
+                </a:solidFill>
+                <a:latin typeface="Calibri"/>
+              </a:rPr>
+              <a:t>Pending group buy-in - nothing applied to the model</a:t>
+            </a:r>
+          </a:p>
+        </p:txBody>
+      </p:sp>
+      <p:sp>
+        <p:nvSpPr>
+          <p:cNvPr id="5" name="TextBox 4"/>
+          <p:cNvSpPr txBox="1"/>
+          <p:nvPr/>
+        </p:nvSpPr>
+        <p:spPr>
+          <a:xfrm>
+            <a:off x="640080" y="1554480"/>
+            <a:ext cx="10972800" cy="4754880"/>
           </a:xfrm>
           <a:prstGeom prst="rect">
             <a:avLst/>
@@ -6736,17 +6799,26 @@
                 <a:spcPts val="200"/>
               </a:spcBef>
               <a:spcAft>
-                <a:spcPts val="1200"/>
+                <a:spcPts val="1300"/>
               </a:spcAft>
             </a:pPr>
             <a:r>
-              <a:rPr sz="1650" b="1" i="0">
+              <a:rPr sz="1400" b="1" i="0">
+                <a:solidFill>
+                  <a:srgbClr val="2E7D32"/>
+                </a:solidFill>
+                <a:latin typeface="Calibri"/>
+              </a:rPr>
+              <a:t>Safe corrections (unambiguous):  </a:t>
+            </a:r>
+            <a:r>
+              <a:rPr sz="1400" b="0" i="0">
                 <a:solidFill>
                   <a:srgbClr val="333333"/>
                 </a:solidFill>
                 <a:latin typeface="Calibri"/>
               </a:rPr>
-              <a:t>Settle the two entity-typing decisions (Q-A, Q-B) - this unblocks Initialization.</a:t>
+              <a:t>class typo CollecticeRoboticSystem -&gt; Collective (O1); versionInfo Extrension -&gt; Extension (O2); file CSIM_ASX -&gt; C2SIM_ASX (O3); hasStartTime UUIDBase -&gt; TimeInstant (M7); unify namespace label ASX / C2SIM_ASX (M8).</a:t>
             </a:r>
           </a:p>
           <a:p>
@@ -6755,17 +6827,26 @@
                 <a:spcPts val="200"/>
               </a:spcBef>
               <a:spcAft>
-                <a:spcPts val="1200"/>
+                <a:spcPts val="1300"/>
               </a:spcAft>
             </a:pPr>
             <a:r>
-              <a:rPr sz="1650" b="0" i="0">
+              <a:rPr sz="1400" b="1" i="0">
+                <a:solidFill>
+                  <a:srgbClr val="C87F0A"/>
+                </a:solidFill>
+                <a:latin typeface="Calibri"/>
+              </a:rPr>
+              <a:t>Structural (decide first):  </a:t>
+            </a:r>
+            <a:r>
+              <a:rPr sz="1400" b="0" i="0">
                 <a:solidFill>
                   <a:srgbClr val="333333"/>
                 </a:solidFill>
                 <a:latin typeface="Calibri"/>
               </a:rPr>
-              <a:t>Complete the Initialization instantiations (drafts provided for the 3 named scenarios).</a:t>
+              <a:t>UAV/robot typing (Q-A); Swarm -&gt; CollectiveEntity so it is taskable (Q-B); one sensor model (Q-C); one autonomy vocabulary (Q-D).</a:t>
             </a:r>
           </a:p>
           <a:p>
@@ -6774,17 +6855,26 @@
                 <a:spcPts val="200"/>
               </a:spcBef>
               <a:spcAft>
-                <a:spcPts val="1200"/>
+                <a:spcPts val="1300"/>
               </a:spcAft>
             </a:pPr>
             <a:r>
-              <a:rPr sz="1650" b="0" i="0">
+              <a:rPr sz="1400" b="1" i="0">
+                <a:solidFill>
+                  <a:srgbClr val="2E869A"/>
+                </a:solidFill>
+                <a:latin typeface="Calibri"/>
+              </a:rPr>
+              <a:t>New content (design):  </a:t>
+            </a:r>
+            <a:r>
+              <a:rPr sz="1400" b="0" i="0">
                 <a:solidFill>
                   <a:srgbClr val="333333"/>
                 </a:solidFill>
                 <a:latin typeface="Calibri"/>
               </a:rPr>
-              <a:t>Add the two CASEVAC content types (Q-G robot-to-robot, Q-H rationale) - both are explicit scenario requirements.</a:t>
+              <a:t>inline entity def (Q-E), MediaReference (Q-F), robot-to-robot + cross-cue (Q-G/Q-P), rationale report (Q-H), generic detection report (Q-I/Q-Q), swarm residuals (Q-J), engagement authority (Q-K), task verbs + payload (Q-L), area subject (Q-M), explore order (Q-N), denied-comms/relay (Q-O), locomotion subtypes (Q-R), decoy/threat-aware (Q-S), environment conditions (Q-T), formation geometry (Q-U).</a:t>
             </a:r>
           </a:p>
           <a:p>
@@ -6793,43 +6883,24 @@
                 <a:spcPts val="200"/>
               </a:spcBef>
               <a:spcAft>
-                <a:spcPts val="1200"/>
+                <a:spcPts val="1300"/>
               </a:spcAft>
             </a:pPr>
             <a:r>
-              <a:rPr sz="1650" b="0" i="0">
+              <a:rPr sz="1400" b="1" i="0">
                 <a:solidFill>
                   <a:srgbClr val="333333"/>
                 </a:solidFill>
                 <a:latin typeface="Calibri"/>
               </a:rPr>
-              <a:t>Reconcile the OWL model with the June spreadsheet decisions; fix the typos.</a:t>
-            </a:r>
-          </a:p>
-          <a:p>
-            <a:pPr>
-              <a:spcBef>
-                <a:spcPts val="200"/>
-              </a:spcBef>
-              <a:spcAft>
-                <a:spcPts val="1200"/>
-              </a:spcAft>
-            </a:pPr>
-            <a:r>
-              <a:rPr sz="1650" b="0" i="0">
-                <a:solidFill>
-                  <a:srgbClr val="333333"/>
-                </a:solidFill>
-                <a:latin typeface="Calibri"/>
-              </a:rPr>
-              <a:t>Optional: adopt the diff-able (.xml) workbooks so edits can be reviewed and merged in git.</a:t>
-            </a:r>
-          </a:p>
-        </p:txBody>
-      </p:sp>
-      <p:sp>
-        <p:nvSpPr>
-          <p:cNvPr id="5" name="TextBox 4"/>
+              <a:t>Nothing here is applied to the model - all items are proposals for group buy-in.</a:t>
+            </a:r>
+          </a:p>
+        </p:txBody>
+      </p:sp>
+      <p:sp>
+        <p:nvSpPr>
+          <p:cNvPr id="6" name="TextBox 5"/>
           <p:cNvSpPr txBox="1"/>
           <p:nvPr/>
         </p:nvSpPr>
@@ -6863,7 +6934,7 @@
       </p:sp>
       <p:sp>
         <p:nvSpPr>
-          <p:cNvPr id="6" name="TextBox 5"/>
+          <p:cNvPr id="7" name="TextBox 6"/>
           <p:cNvSpPr txBox="1"/>
           <p:nvPr/>
         </p:nvSpPr>
@@ -7189,6 +7260,288 @@
                 <a:latin typeface="Calibri"/>
               </a:rPr>
               <a:t>2</a:t>
+            </a:r>
+          </a:p>
+        </p:txBody>
+      </p:sp>
+    </p:spTree>
+  </p:cSld>
+  <p:clrMapOvr>
+    <a:masterClrMapping/>
+  </p:clrMapOvr>
+</p:sld>
+</file>
+
+<file path=ppt/slides/slide20.xml><?xml version="1.0" encoding="utf-8"?>
+<p:sld xmlns:a="http://schemas.openxmlformats.org/drawingml/2006/main" xmlns:p="http://schemas.openxmlformats.org/presentationml/2006/main" xmlns:r="http://schemas.openxmlformats.org/officeDocument/2006/relationships">
+  <p:cSld>
+    <p:spTree>
+      <p:nvGrpSpPr>
+        <p:cNvPr id="1" name=""/>
+        <p:cNvGrpSpPr/>
+        <p:nvPr/>
+      </p:nvGrpSpPr>
+      <p:grpSpPr/>
+      <p:sp>
+        <p:nvSpPr>
+          <p:cNvPr id="2" name="Rectangle 1"/>
+          <p:cNvSpPr/>
+          <p:nvPr/>
+        </p:nvSpPr>
+        <p:spPr>
+          <a:xfrm>
+            <a:off x="548640" y="1170432"/>
+            <a:ext cx="2011680" cy="38100"/>
+          </a:xfrm>
+          <a:prstGeom prst="rect">
+            <a:avLst/>
+          </a:prstGeom>
+          <a:solidFill>
+            <a:srgbClr val="2E869A"/>
+          </a:solidFill>
+          <a:ln>
+            <a:noFill/>
+          </a:ln>
+        </p:spPr>
+        <p:style>
+          <a:lnRef idx="1">
+            <a:schemeClr val="accent1"/>
+          </a:lnRef>
+          <a:fillRef idx="3">
+            <a:schemeClr val="accent1"/>
+          </a:fillRef>
+          <a:effectRef idx="2">
+            <a:schemeClr val="accent1"/>
+          </a:effectRef>
+          <a:fontRef idx="minor">
+            <a:schemeClr val="lt1"/>
+          </a:fontRef>
+        </p:style>
+        <p:txBody>
+          <a:bodyPr rtlCol="0" anchor="ctr"/>
+          <a:lstStyle/>
+          <a:p>
+            <a:pPr algn="ctr"/>
+          </a:p>
+        </p:txBody>
+      </p:sp>
+      <p:sp>
+        <p:nvSpPr>
+          <p:cNvPr id="3" name="TextBox 2"/>
+          <p:cNvSpPr txBox="1"/>
+          <p:nvPr/>
+        </p:nvSpPr>
+        <p:spPr>
+          <a:xfrm>
+            <a:off x="502920" y="411480"/>
+            <a:ext cx="11155680" cy="822960"/>
+          </a:xfrm>
+          <a:prstGeom prst="rect">
+            <a:avLst/>
+          </a:prstGeom>
+          <a:noFill/>
+        </p:spPr>
+        <p:txBody>
+          <a:bodyPr wrap="square">
+            <a:spAutoFit/>
+          </a:bodyPr>
+          <a:lstStyle/>
+          <a:p>
+            <a:r>
+              <a:rPr sz="3000" b="1" i="0">
+                <a:solidFill>
+                  <a:srgbClr val="1F3A5F"/>
+                </a:solidFill>
+                <a:latin typeface="Calibri"/>
+              </a:rPr>
+              <a:t>Recommended next steps</a:t>
+            </a:r>
+          </a:p>
+        </p:txBody>
+      </p:sp>
+      <p:sp>
+        <p:nvSpPr>
+          <p:cNvPr id="4" name="TextBox 3"/>
+          <p:cNvSpPr txBox="1"/>
+          <p:nvPr/>
+        </p:nvSpPr>
+        <p:spPr>
+          <a:xfrm>
+            <a:off x="640080" y="1645920"/>
+            <a:ext cx="10972800" cy="4709160"/>
+          </a:xfrm>
+          <a:prstGeom prst="rect">
+            <a:avLst/>
+          </a:prstGeom>
+          <a:noFill/>
+        </p:spPr>
+        <p:txBody>
+          <a:bodyPr wrap="square">
+            <a:spAutoFit/>
+          </a:bodyPr>
+          <a:lstStyle/>
+          <a:p>
+            <a:pPr>
+              <a:spcBef>
+                <a:spcPts val="200"/>
+              </a:spcBef>
+              <a:spcAft>
+                <a:spcPts val="1200"/>
+              </a:spcAft>
+            </a:pPr>
+            <a:r>
+              <a:rPr sz="1650" b="1" i="0">
+                <a:solidFill>
+                  <a:srgbClr val="333333"/>
+                </a:solidFill>
+                <a:latin typeface="Calibri"/>
+              </a:rPr>
+              <a:t>Settle the two entity-typing decisions (Q-A, Q-B) - this unblocks Initialization.</a:t>
+            </a:r>
+          </a:p>
+          <a:p>
+            <a:pPr>
+              <a:spcBef>
+                <a:spcPts val="200"/>
+              </a:spcBef>
+              <a:spcAft>
+                <a:spcPts val="1200"/>
+              </a:spcAft>
+            </a:pPr>
+            <a:r>
+              <a:rPr sz="1650" b="0" i="0">
+                <a:solidFill>
+                  <a:srgbClr val="333333"/>
+                </a:solidFill>
+                <a:latin typeface="Calibri"/>
+              </a:rPr>
+              <a:t>Complete the Initialization instantiations (drafts provided for the 3 named scenarios).</a:t>
+            </a:r>
+          </a:p>
+          <a:p>
+            <a:pPr>
+              <a:spcBef>
+                <a:spcPts val="200"/>
+              </a:spcBef>
+              <a:spcAft>
+                <a:spcPts val="1200"/>
+              </a:spcAft>
+            </a:pPr>
+            <a:r>
+              <a:rPr sz="1650" b="0" i="0">
+                <a:solidFill>
+                  <a:srgbClr val="333333"/>
+                </a:solidFill>
+                <a:latin typeface="Calibri"/>
+              </a:rPr>
+              <a:t>Add the two CASEVAC content types (Q-G robot-to-robot, Q-H rationale) - both are explicit scenario requirements.</a:t>
+            </a:r>
+          </a:p>
+          <a:p>
+            <a:pPr>
+              <a:spcBef>
+                <a:spcPts val="200"/>
+              </a:spcBef>
+              <a:spcAft>
+                <a:spcPts val="1200"/>
+              </a:spcAft>
+            </a:pPr>
+            <a:r>
+              <a:rPr sz="1650" b="0" i="0">
+                <a:solidFill>
+                  <a:srgbClr val="333333"/>
+                </a:solidFill>
+                <a:latin typeface="Calibri"/>
+              </a:rPr>
+              <a:t>Reconcile the OWL model with the June spreadsheet decisions; fix the typos.</a:t>
+            </a:r>
+          </a:p>
+          <a:p>
+            <a:pPr>
+              <a:spcBef>
+                <a:spcPts val="200"/>
+              </a:spcBef>
+              <a:spcAft>
+                <a:spcPts val="1200"/>
+              </a:spcAft>
+            </a:pPr>
+            <a:r>
+              <a:rPr sz="1650" b="0" i="0">
+                <a:solidFill>
+                  <a:srgbClr val="333333"/>
+                </a:solidFill>
+                <a:latin typeface="Calibri"/>
+              </a:rPr>
+              <a:t>Optional: adopt the diff-able (.xml) workbooks so edits can be reviewed and merged in git.</a:t>
+            </a:r>
+          </a:p>
+        </p:txBody>
+      </p:sp>
+      <p:sp>
+        <p:nvSpPr>
+          <p:cNvPr id="5" name="TextBox 4"/>
+          <p:cNvSpPr txBox="1"/>
+          <p:nvPr/>
+        </p:nvSpPr>
+        <p:spPr>
+          <a:xfrm>
+            <a:off x="502920" y="6419088"/>
+            <a:ext cx="11155680" cy="320040"/>
+          </a:xfrm>
+          <a:prstGeom prst="rect">
+            <a:avLst/>
+          </a:prstGeom>
+          <a:noFill/>
+        </p:spPr>
+        <p:txBody>
+          <a:bodyPr wrap="square">
+            <a:spAutoFit/>
+          </a:bodyPr>
+          <a:lstStyle/>
+          <a:p>
+            <a:r>
+              <a:rPr sz="900" b="0" i="0">
+                <a:solidFill>
+                  <a:srgbClr val="666666"/>
+                </a:solidFill>
+                <a:latin typeface="Calibri"/>
+              </a:rPr>
+              <a:t>C2SIM ASX Sub-group   |   Hyssos   |   July 2026</a:t>
+            </a:r>
+          </a:p>
+        </p:txBody>
+      </p:sp>
+      <p:sp>
+        <p:nvSpPr>
+          <p:cNvPr id="6" name="TextBox 5"/>
+          <p:cNvSpPr txBox="1"/>
+          <p:nvPr/>
+        </p:nvSpPr>
+        <p:spPr>
+          <a:xfrm>
+            <a:off x="11338560" y="6419088"/>
+            <a:ext cx="640080" cy="320040"/>
+          </a:xfrm>
+          <a:prstGeom prst="rect">
+            <a:avLst/>
+          </a:prstGeom>
+          <a:noFill/>
+        </p:spPr>
+        <p:txBody>
+          <a:bodyPr wrap="square">
+            <a:spAutoFit/>
+          </a:bodyPr>
+          <a:lstStyle/>
+          <a:p>
+            <a:pPr algn="r"/>
+            <a:r>
+              <a:rPr sz="900" b="0" i="0">
+                <a:solidFill>
+                  <a:srgbClr val="666666"/>
+                </a:solidFill>
+                <a:latin typeface="Calibri"/>
+              </a:rPr>
+              <a:t>20</a:t>
             </a:r>
           </a:p>
         </p:txBody>

</xml_diff>

<commit_message>
ASX deck: add "Where to dig deeper" reference map + decisions -> log pointers
Give the audience navigation from the summarized slides to the detailed source
docs. New final slide maps each topic (coverage, entity typing, CASEVAC,
sensors/swarm, task/effect, sourced/validation, redundancy) to its walk doc and
log section, plus the master log and the .xml workbooks. The three decisions
slides now carry a subtitle pointing to log section 7 (the full 22-decision
register). 23 slides.

Co-Authored-By: Claude Opus 4.8 (1M context) <noreply@anthropic.com>
</commit_message>
<xml_diff>
--- a/Subgroups/ASX/InstantiationReview/ASX-Instantiation-Findings.pptx
+++ b/Subgroups/ASX/InstantiationReview/ASX-Instantiation-Findings.pptx
@@ -27,6 +27,7 @@
     <p:sldId id="275" r:id="rId26"/>
     <p:sldId id="276" r:id="rId27"/>
     <p:sldId id="277" r:id="rId28"/>
+    <p:sldId id="278" r:id="rId29"/>
   </p:sldIdLst>
   <p:sldSz cx="12191695" cy="6858000" type="screen4x3"/>
   <p:notesSz cx="6858000" cy="9144000"/>
@@ -6237,6 +6238,40 @@
         </p:nvSpPr>
         <p:spPr>
           <a:xfrm>
+            <a:off x="548640" y="914400"/>
+            <a:ext cx="10972800" cy="320040"/>
+          </a:xfrm>
+          <a:prstGeom prst="rect">
+            <a:avLst/>
+          </a:prstGeom>
+          <a:noFill/>
+        </p:spPr>
+        <p:txBody>
+          <a:bodyPr wrap="square">
+            <a:spAutoFit/>
+          </a:bodyPr>
+          <a:lstStyle/>
+          <a:p>
+            <a:r>
+              <a:rPr sz="1300" b="0" i="1">
+                <a:solidFill>
+                  <a:srgbClr val="2E869A"/>
+                </a:solidFill>
+                <a:latin typeface="Calibri"/>
+              </a:rPr>
+              <a:t>Full register - all 22, with what each resolves: log section 7</a:t>
+            </a:r>
+          </a:p>
+        </p:txBody>
+      </p:sp>
+      <p:sp>
+        <p:nvSpPr>
+          <p:cNvPr id="5" name="TextBox 4"/>
+          <p:cNvSpPr txBox="1"/>
+          <p:nvPr/>
+        </p:nvSpPr>
+        <p:spPr>
+          <a:xfrm>
             <a:off x="640080" y="1737360"/>
             <a:ext cx="10972800" cy="4617720"/>
           </a:xfrm>
@@ -6366,7 +6401,7 @@
       </p:sp>
       <p:sp>
         <p:nvSpPr>
-          <p:cNvPr id="5" name="TextBox 4"/>
+          <p:cNvPr id="6" name="TextBox 5"/>
           <p:cNvSpPr txBox="1"/>
           <p:nvPr/>
         </p:nvSpPr>
@@ -6400,7 +6435,7 @@
       </p:sp>
       <p:sp>
         <p:nvSpPr>
-          <p:cNvPr id="6" name="TextBox 5"/>
+          <p:cNvPr id="7" name="TextBox 6"/>
           <p:cNvSpPr txBox="1"/>
           <p:nvPr/>
         </p:nvSpPr>
@@ -6536,6 +6571,40 @@
         </p:nvSpPr>
         <p:spPr>
           <a:xfrm>
+            <a:off x="548640" y="914400"/>
+            <a:ext cx="10972800" cy="320040"/>
+          </a:xfrm>
+          <a:prstGeom prst="rect">
+            <a:avLst/>
+          </a:prstGeom>
+          <a:noFill/>
+        </p:spPr>
+        <p:txBody>
+          <a:bodyPr wrap="square">
+            <a:spAutoFit/>
+          </a:bodyPr>
+          <a:lstStyle/>
+          <a:p>
+            <a:r>
+              <a:rPr sz="1300" b="0" i="1">
+                <a:solidFill>
+                  <a:srgbClr val="2E869A"/>
+                </a:solidFill>
+                <a:latin typeface="Calibri"/>
+              </a:rPr>
+              <a:t>continued - full text + grounding in log section 7</a:t>
+            </a:r>
+          </a:p>
+        </p:txBody>
+      </p:sp>
+      <p:sp>
+        <p:nvSpPr>
+          <p:cNvPr id="5" name="TextBox 4"/>
+          <p:cNvSpPr txBox="1"/>
+          <p:nvPr/>
+        </p:nvSpPr>
+        <p:spPr>
+          <a:xfrm>
             <a:off x="640080" y="1463040"/>
             <a:ext cx="10972800" cy="4754880"/>
           </a:xfrm>
@@ -6805,7 +6874,7 @@
       </p:sp>
       <p:sp>
         <p:nvSpPr>
-          <p:cNvPr id="5" name="TextBox 4"/>
+          <p:cNvPr id="6" name="TextBox 5"/>
           <p:cNvSpPr txBox="1"/>
           <p:nvPr/>
         </p:nvSpPr>
@@ -6839,7 +6908,7 @@
       </p:sp>
       <p:sp>
         <p:nvSpPr>
-          <p:cNvPr id="6" name="TextBox 5"/>
+          <p:cNvPr id="7" name="TextBox 6"/>
           <p:cNvSpPr txBox="1"/>
           <p:nvPr/>
         </p:nvSpPr>
@@ -7272,6 +7341,40 @@
         </p:nvSpPr>
         <p:spPr>
           <a:xfrm>
+            <a:off x="548640" y="914400"/>
+            <a:ext cx="10972800" cy="320040"/>
+          </a:xfrm>
+          <a:prstGeom prst="rect">
+            <a:avLst/>
+          </a:prstGeom>
+          <a:noFill/>
+        </p:spPr>
+        <p:txBody>
+          <a:bodyPr wrap="square">
+            <a:spAutoFit/>
+          </a:bodyPr>
+          <a:lstStyle/>
+          <a:p>
+            <a:r>
+              <a:rPr sz="1300" b="0" i="1">
+                <a:solidFill>
+                  <a:srgbClr val="2E869A"/>
+                </a:solidFill>
+                <a:latin typeface="Calibri"/>
+              </a:rPr>
+              <a:t>continued - full text + grounding in log section 7</a:t>
+            </a:r>
+          </a:p>
+        </p:txBody>
+      </p:sp>
+      <p:sp>
+        <p:nvSpPr>
+          <p:cNvPr id="5" name="TextBox 4"/>
+          <p:cNvSpPr txBox="1"/>
+          <p:nvPr/>
+        </p:nvSpPr>
+        <p:spPr>
+          <a:xfrm>
             <a:off x="640080" y="1417320"/>
             <a:ext cx="10972800" cy="4754880"/>
           </a:xfrm>
@@ -7541,7 +7644,7 @@
       </p:sp>
       <p:sp>
         <p:nvSpPr>
-          <p:cNvPr id="5" name="TextBox 4"/>
+          <p:cNvPr id="6" name="TextBox 5"/>
           <p:cNvSpPr txBox="1"/>
           <p:nvPr/>
         </p:nvSpPr>
@@ -7575,7 +7678,7 @@
       </p:sp>
       <p:sp>
         <p:nvSpPr>
-          <p:cNvPr id="6" name="TextBox 5"/>
+          <p:cNvPr id="7" name="TextBox 6"/>
           <p:cNvSpPr txBox="1"/>
           <p:nvPr/>
         </p:nvSpPr>
@@ -8210,6 +8313,479 @@
                 <a:latin typeface="Calibri"/>
               </a:rPr>
               <a:t>22</a:t>
+            </a:r>
+          </a:p>
+        </p:txBody>
+      </p:sp>
+    </p:spTree>
+  </p:cSld>
+  <p:clrMapOvr>
+    <a:masterClrMapping/>
+  </p:clrMapOvr>
+</p:sld>
+</file>
+
+<file path=ppt/slides/slide23.xml><?xml version="1.0" encoding="utf-8"?>
+<p:sld xmlns:a="http://schemas.openxmlformats.org/drawingml/2006/main" xmlns:p="http://schemas.openxmlformats.org/presentationml/2006/main" xmlns:r="http://schemas.openxmlformats.org/officeDocument/2006/relationships">
+  <p:cSld>
+    <p:spTree>
+      <p:nvGrpSpPr>
+        <p:cNvPr id="1" name=""/>
+        <p:cNvGrpSpPr/>
+        <p:nvPr/>
+      </p:nvGrpSpPr>
+      <p:grpSpPr/>
+      <p:sp>
+        <p:nvSpPr>
+          <p:cNvPr id="2" name="Rectangle 1"/>
+          <p:cNvSpPr/>
+          <p:nvPr/>
+        </p:nvSpPr>
+        <p:spPr>
+          <a:xfrm>
+            <a:off x="548640" y="1170432"/>
+            <a:ext cx="2011680" cy="38100"/>
+          </a:xfrm>
+          <a:prstGeom prst="rect">
+            <a:avLst/>
+          </a:prstGeom>
+          <a:solidFill>
+            <a:srgbClr val="2E869A"/>
+          </a:solidFill>
+          <a:ln>
+            <a:noFill/>
+          </a:ln>
+        </p:spPr>
+        <p:style>
+          <a:lnRef idx="1">
+            <a:schemeClr val="accent1"/>
+          </a:lnRef>
+          <a:fillRef idx="3">
+            <a:schemeClr val="accent1"/>
+          </a:fillRef>
+          <a:effectRef idx="2">
+            <a:schemeClr val="accent1"/>
+          </a:effectRef>
+          <a:fontRef idx="minor">
+            <a:schemeClr val="lt1"/>
+          </a:fontRef>
+        </p:style>
+        <p:txBody>
+          <a:bodyPr rtlCol="0" anchor="ctr"/>
+          <a:lstStyle/>
+          <a:p>
+            <a:pPr algn="ctr"/>
+          </a:p>
+        </p:txBody>
+      </p:sp>
+      <p:sp>
+        <p:nvSpPr>
+          <p:cNvPr id="3" name="TextBox 2"/>
+          <p:cNvSpPr txBox="1"/>
+          <p:nvPr/>
+        </p:nvSpPr>
+        <p:spPr>
+          <a:xfrm>
+            <a:off x="502920" y="411480"/>
+            <a:ext cx="11155680" cy="822960"/>
+          </a:xfrm>
+          <a:prstGeom prst="rect">
+            <a:avLst/>
+          </a:prstGeom>
+          <a:noFill/>
+        </p:spPr>
+        <p:txBody>
+          <a:bodyPr wrap="square">
+            <a:spAutoFit/>
+          </a:bodyPr>
+          <a:lstStyle/>
+          <a:p>
+            <a:r>
+              <a:rPr sz="3000" b="1" i="0">
+                <a:solidFill>
+                  <a:srgbClr val="1F3A5F"/>
+                </a:solidFill>
+                <a:latin typeface="Calibri"/>
+              </a:rPr>
+              <a:t>Where to dig deeper</a:t>
+            </a:r>
+          </a:p>
+        </p:txBody>
+      </p:sp>
+      <p:sp>
+        <p:nvSpPr>
+          <p:cNvPr id="4" name="TextBox 3"/>
+          <p:cNvSpPr txBox="1"/>
+          <p:nvPr/>
+        </p:nvSpPr>
+        <p:spPr>
+          <a:xfrm>
+            <a:off x="548640" y="914400"/>
+            <a:ext cx="10972800" cy="320040"/>
+          </a:xfrm>
+          <a:prstGeom prst="rect">
+            <a:avLst/>
+          </a:prstGeom>
+          <a:noFill/>
+        </p:spPr>
+        <p:txBody>
+          <a:bodyPr wrap="square">
+            <a:spAutoFit/>
+          </a:bodyPr>
+          <a:lstStyle/>
+          <a:p>
+            <a:r>
+              <a:rPr sz="1300" b="0" i="1">
+                <a:solidFill>
+                  <a:srgbClr val="2E869A"/>
+                </a:solidFill>
+                <a:latin typeface="Calibri"/>
+              </a:rPr>
+              <a:t>Branch asx-diffable-spreadsheets: docs in ASX/InstantiationReview, workbooks in ASX/Proposed Extension Working Materials</a:t>
+            </a:r>
+          </a:p>
+        </p:txBody>
+      </p:sp>
+      <p:sp>
+        <p:nvSpPr>
+          <p:cNvPr id="5" name="TextBox 4"/>
+          <p:cNvSpPr txBox="1"/>
+          <p:nvPr/>
+        </p:nvSpPr>
+        <p:spPr>
+          <a:xfrm>
+            <a:off x="640080" y="1508760"/>
+            <a:ext cx="10972800" cy="4754880"/>
+          </a:xfrm>
+          <a:prstGeom prst="rect">
+            <a:avLst/>
+          </a:prstGeom>
+          <a:noFill/>
+        </p:spPr>
+        <p:txBody>
+          <a:bodyPr wrap="square">
+            <a:spAutoFit/>
+          </a:bodyPr>
+          <a:lstStyle/>
+          <a:p>
+            <a:pPr>
+              <a:spcBef>
+                <a:spcPts val="200"/>
+              </a:spcBef>
+              <a:spcAft>
+                <a:spcPts val="600"/>
+              </a:spcAft>
+            </a:pPr>
+            <a:r>
+              <a:rPr sz="1250" b="1" i="0">
+                <a:solidFill>
+                  <a:srgbClr val="1F3A5F"/>
+                </a:solidFill>
+                <a:latin typeface="Calibri"/>
+              </a:rPr>
+              <a:t>Master evidence log:  </a:t>
+            </a:r>
+            <a:r>
+              <a:rPr sz="1250" b="0" i="0">
+                <a:solidFill>
+                  <a:srgbClr val="333333"/>
+                </a:solidFill>
+                <a:latin typeface="Calibri"/>
+              </a:rPr>
+              <a:t>Issues-And-Comments-Log.md - every finding, the 22 decisions (sec 7), v0.0.3 reconciliation (sec 9), why gaps remain (sec 8).</a:t>
+            </a:r>
+          </a:p>
+          <a:p>
+            <a:pPr>
+              <a:spcBef>
+                <a:spcPts val="200"/>
+              </a:spcBef>
+              <a:spcAft>
+                <a:spcPts val="600"/>
+              </a:spcAft>
+            </a:pPr>
+            <a:r>
+              <a:rPr sz="1250" b="1" i="0">
+                <a:solidFill>
+                  <a:srgbClr val="1F3A5F"/>
+                </a:solidFill>
+                <a:latin typeface="Calibri"/>
+              </a:rPr>
+              <a:t>Briefing / Q&amp;A / talk track:  </a:t>
+            </a:r>
+            <a:r>
+              <a:rPr sz="1250" b="0" i="0">
+                <a:solidFill>
+                  <a:srgbClr val="333333"/>
+                </a:solidFill>
+                <a:latin typeface="Calibri"/>
+              </a:rPr>
+              <a:t>Group-Briefing.md (one page); Anticipated-QA.md; Presenter-Notes.md.</a:t>
+            </a:r>
+          </a:p>
+          <a:p>
+            <a:pPr>
+              <a:spcBef>
+                <a:spcPts val="200"/>
+              </a:spcBef>
+              <a:spcAft>
+                <a:spcPts val="600"/>
+              </a:spcAft>
+            </a:pPr>
+            <a:r>
+              <a:rPr sz="1250" b="1" i="0">
+                <a:solidFill>
+                  <a:srgbClr val="1F3A5F"/>
+                </a:solidFill>
+                <a:latin typeface="Calibri"/>
+              </a:rPr>
+              <a:t>Coverage + the actual messages:  </a:t>
+            </a:r>
+            <a:r>
+              <a:rPr sz="1250" b="0" i="0">
+                <a:solidFill>
+                  <a:srgbClr val="333333"/>
+                </a:solidFill>
+                <a:latin typeface="Calibri"/>
+              </a:rPr>
+              <a:t>Message-Instantiation-Coverage.md; the three 'ASX Sample *.xml' workbooks (the ~33 instantiations, diff-able).</a:t>
+            </a:r>
+          </a:p>
+          <a:p>
+            <a:pPr>
+              <a:spcBef>
+                <a:spcPts val="200"/>
+              </a:spcBef>
+              <a:spcAft>
+                <a:spcPts val="600"/>
+              </a:spcAft>
+            </a:pPr>
+            <a:r>
+              <a:rPr sz="1250" b="1" i="0">
+                <a:solidFill>
+                  <a:srgbClr val="1F3A5F"/>
+                </a:solidFill>
+                <a:latin typeface="Calibri"/>
+              </a:rPr>
+              <a:t>Initialization &amp; entity typing (P1/P2/P7):  </a:t>
+            </a:r>
+            <a:r>
+              <a:rPr sz="1250" b="0" i="0">
+                <a:solidFill>
+                  <a:srgbClr val="333333"/>
+                </a:solidFill>
+                <a:latin typeface="Calibri"/>
+              </a:rPr>
+              <a:t>Initialization-Walk.md; log sec 5.</a:t>
+            </a:r>
+          </a:p>
+          <a:p>
+            <a:pPr>
+              <a:spcBef>
+                <a:spcPts val="200"/>
+              </a:spcBef>
+              <a:spcAft>
+                <a:spcPts val="600"/>
+              </a:spcAft>
+            </a:pPr>
+            <a:r>
+              <a:rPr sz="1250" b="1" i="0">
+                <a:solidFill>
+                  <a:srgbClr val="1F3A5F"/>
+                </a:solidFill>
+                <a:latin typeface="Calibri"/>
+              </a:rPr>
+              <a:t>CASEVAC (X1/X2 -&gt; Q-G/Q-H):  </a:t>
+            </a:r>
+            <a:r>
+              <a:rPr sz="1250" b="0" i="0">
+                <a:solidFill>
+                  <a:srgbClr val="333333"/>
+                </a:solidFill>
+                <a:latin typeface="Calibri"/>
+              </a:rPr>
+              <a:t>CASEVAC-Walk.md; log sec 6b.</a:t>
+            </a:r>
+          </a:p>
+          <a:p>
+            <a:pPr>
+              <a:spcBef>
+                <a:spcPts val="200"/>
+              </a:spcBef>
+              <a:spcAft>
+                <a:spcPts val="600"/>
+              </a:spcAft>
+            </a:pPr>
+            <a:r>
+              <a:rPr sz="1250" b="1" i="0">
+                <a:solidFill>
+                  <a:srgbClr val="1F3A5F"/>
+                </a:solidFill>
+                <a:latin typeface="Calibri"/>
+              </a:rPr>
+              <a:t>Sensors &amp; swarm (Y / Z series):  </a:t>
+            </a:r>
+            <a:r>
+              <a:rPr sz="1250" b="0" i="0">
+                <a:solidFill>
+                  <a:srgbClr val="333333"/>
+                </a:solidFill>
+                <a:latin typeface="Calibri"/>
+              </a:rPr>
+              <a:t>NonVideoSensors-Walk.md; Swarm-Walk.md; log sec 6c / 6d.</a:t>
+            </a:r>
+          </a:p>
+          <a:p>
+            <a:pPr>
+              <a:spcBef>
+                <a:spcPts val="200"/>
+              </a:spcBef>
+              <a:spcAft>
+                <a:spcPts val="600"/>
+              </a:spcAft>
+            </a:pPr>
+            <a:r>
+              <a:rPr sz="1250" b="1" i="0">
+                <a:solidFill>
+                  <a:srgbClr val="1F3A5F"/>
+                </a:solidFill>
+                <a:latin typeface="Calibri"/>
+              </a:rPr>
+              <a:t>Task / effect &amp; engagement (W / L, Q-K/Q-L):  </a:t>
+            </a:r>
+            <a:r>
+              <a:rPr sz="1250" b="0" i="0">
+                <a:solidFill>
+                  <a:srgbClr val="333333"/>
+                </a:solidFill>
+                <a:latin typeface="Calibri"/>
+              </a:rPr>
+              <a:t>FireSupport-Walk.md; TaskEffect-Batch-Walk.md; log sec 6e / 6f.</a:t>
+            </a:r>
+          </a:p>
+          <a:p>
+            <a:pPr>
+              <a:spcBef>
+                <a:spcPts val="200"/>
+              </a:spcBef>
+              <a:spcAft>
+                <a:spcPts val="600"/>
+              </a:spcAft>
+            </a:pPr>
+            <a:r>
+              <a:rPr sz="1250" b="1" i="0">
+                <a:solidFill>
+                  <a:srgbClr val="1F3A5F"/>
+                </a:solidFill>
+                <a:latin typeface="Calibri"/>
+              </a:rPr>
+              <a:t>Sourced &amp; validation missions:  </a:t>
+            </a:r>
+            <a:r>
+              <a:rPr sz="1250" b="0" i="0">
+                <a:solidFill>
+                  <a:srgbClr val="333333"/>
+                </a:solidFill>
+                <a:latin typeface="Calibri"/>
+              </a:rPr>
+              <a:t>SourcedScenarios-Walk.md; ValidationEvidence-Walk.md; Documents-Found.md; log sec 6h / 6j.</a:t>
+            </a:r>
+          </a:p>
+          <a:p>
+            <a:pPr>
+              <a:spcBef>
+                <a:spcPts val="200"/>
+              </a:spcBef>
+              <a:spcAft>
+                <a:spcPts val="600"/>
+              </a:spcAft>
+            </a:pPr>
+            <a:r>
+              <a:rPr sz="1250" b="1" i="0">
+                <a:solidFill>
+                  <a:srgbClr val="1F3A5F"/>
+                </a:solidFill>
+                <a:latin typeface="Calibri"/>
+              </a:rPr>
+              <a:t>Redundancy screen (N1):  </a:t>
+            </a:r>
+            <a:r>
+              <a:rPr sz="1250" b="0" i="0">
+                <a:solidFill>
+                  <a:srgbClr val="333333"/>
+                </a:solidFill>
+                <a:latin typeface="Calibri"/>
+              </a:rPr>
+              <a:t>RedundancyPass-Walk.md; log sec 6g.</a:t>
+            </a:r>
+          </a:p>
+        </p:txBody>
+      </p:sp>
+      <p:sp>
+        <p:nvSpPr>
+          <p:cNvPr id="6" name="TextBox 5"/>
+          <p:cNvSpPr txBox="1"/>
+          <p:nvPr/>
+        </p:nvSpPr>
+        <p:spPr>
+          <a:xfrm>
+            <a:off x="502920" y="6419088"/>
+            <a:ext cx="11155680" cy="320040"/>
+          </a:xfrm>
+          <a:prstGeom prst="rect">
+            <a:avLst/>
+          </a:prstGeom>
+          <a:noFill/>
+        </p:spPr>
+        <p:txBody>
+          <a:bodyPr wrap="square">
+            <a:spAutoFit/>
+          </a:bodyPr>
+          <a:lstStyle/>
+          <a:p>
+            <a:r>
+              <a:rPr sz="900" b="0" i="0">
+                <a:solidFill>
+                  <a:srgbClr val="666666"/>
+                </a:solidFill>
+                <a:latin typeface="Calibri"/>
+              </a:rPr>
+              <a:t>C2SIM ASX Sub-group   |   Hyssos   |   July 2026</a:t>
+            </a:r>
+          </a:p>
+        </p:txBody>
+      </p:sp>
+      <p:sp>
+        <p:nvSpPr>
+          <p:cNvPr id="7" name="TextBox 6"/>
+          <p:cNvSpPr txBox="1"/>
+          <p:nvPr/>
+        </p:nvSpPr>
+        <p:spPr>
+          <a:xfrm>
+            <a:off x="11338560" y="6419088"/>
+            <a:ext cx="640080" cy="320040"/>
+          </a:xfrm>
+          <a:prstGeom prst="rect">
+            <a:avLst/>
+          </a:prstGeom>
+          <a:noFill/>
+        </p:spPr>
+        <p:txBody>
+          <a:bodyPr wrap="square">
+            <a:spAutoFit/>
+          </a:bodyPr>
+          <a:lstStyle/>
+          <a:p>
+            <a:pPr algn="r"/>
+            <a:r>
+              <a:rPr sz="900" b="0" i="0">
+                <a:solidFill>
+                  <a:srgbClr val="666666"/>
+                </a:solidFill>
+                <a:latin typeface="Calibri"/>
+              </a:rPr>
+              <a:t>23</a:t>
             </a:r>
           </a:p>
         </p:txBody>

</xml_diff>